<commit_message>
Lesson sd-10-014: explain each standard from MDN, the OpenAPI and ECMAScript repositories and the OAuth 2.1 draft instead of following the source sentences, with the figure, metadata and deck
Co-Authored-By: Claude Sonnet 5.5 <noreply@anthropic.com>
Claude-Session: https://claude.ai/code/session_011dmt3ZFdN8sjiTfDnyUVN7
</commit_message>
<xml_diff>
--- a/system-design-101/vi/lessons/sd-10-014/slides/sd-10-014.pptx
+++ b/system-design-101/vi/lessons/sd-10-014/slides/sd-10-014.pptx
@@ -2176,7 +2176,7 @@
               <a:buNone/>
             </a:pPr>
             <a:r>
-              <a:rPr lang="en-US" sz="6000" dirty="0" spc="2" kern="0">
+              <a:rPr lang="en-US" sz="6000" dirty="0" kern="0">
                 <a:solidFill>
                   <a:srgbClr val="F3EEE3"/>
                 </a:solidFill>
@@ -2184,7 +2184,7 @@
                 <a:ea typeface="Bricolage Grotesque ExtraBold" pitchFamily="34" charset="-122"/>
                 <a:cs typeface="Bricolage Grotesque ExtraBold" pitchFamily="34" charset="-120"/>
               </a:rPr>
-              <a:t>3</a:t>
+              <a:t>7</a:t>
             </a:r>
             <a:endParaRPr lang="en-US" sz="6000" dirty="0"/>
           </a:p>
@@ -5595,15 +5595,48 @@
               <a:buNone/>
             </a:pPr>
             <a:r>
-              <a:rPr lang="en-US" sz="2850" dirty="0" spc="-3" kern="0">
-                <a:solidFill>
-                  <a:srgbClr val="F3EEE3"/>
-                </a:solidFill>
-                <a:latin typeface="Be Vietnam Pro" pitchFamily="34" charset="0"/>
-                <a:ea typeface="Be Vietnam Pro" pitchFamily="34" charset="-122"/>
-                <a:cs typeface="Be Vietnam Pro" pitchFamily="34" charset="-120"/>
-              </a:rPr>
-              <a:t>Nguồn</a:t>
+              <a:rPr lang="en-US" sz="2850" dirty="0" spc="-35" kern="0">
+                <a:solidFill>
+                  <a:srgbClr val="F3EEE3"/>
+                </a:solidFill>
+                <a:latin typeface="Be Vietnam Pro" pitchFamily="34" charset="0"/>
+                <a:ea typeface="Be Vietnam Pro" pitchFamily="34" charset="-122"/>
+                <a:cs typeface="Be Vietnam Pro" pitchFamily="34" charset="-120"/>
+              </a:rPr>
+              <a:t>TCP/IP</a:t>
+            </a:r>
+            <a:r>
+              <a:rPr lang="en-US" sz="2850" dirty="0" spc="14" kern="0">
+                <a:solidFill>
+                  <a:srgbClr val="F3EEE3"/>
+                </a:solidFill>
+                <a:latin typeface="Be Vietnam Pro" pitchFamily="34" charset="0"/>
+                <a:ea typeface="Be Vietnam Pro" pitchFamily="34" charset="-122"/>
+                <a:cs typeface="Be Vietnam Pro" pitchFamily="34" charset="-120"/>
+              </a:rPr>
+              <a:t> đưa</a:t>
+            </a:r>
+            <a:r>
+              <a:rPr lang="en-US" sz="2850" dirty="0" spc="-1" kern="0">
+                <a:solidFill>
+                  <a:srgbClr val="F3EEE3"/>
+                </a:solidFill>
+                <a:latin typeface="Be Vietnam Pro" pitchFamily="34" charset="0"/>
+                <a:ea typeface="Be Vietnam Pro" pitchFamily="34" charset="-122"/>
+                <a:cs typeface="Be Vietnam Pro" pitchFamily="34" charset="-120"/>
+              </a:rPr>
+              <a:t> dữ</a:t>
+            </a:r>
+            <a:r>
+              <a:rPr lang="en-US" sz="2850" dirty="0" spc="2" kern="0">
+                <a:solidFill>
+                  <a:srgbClr val="F3EEE3"/>
+                </a:solidFill>
+                <a:latin typeface="Be Vietnam Pro" pitchFamily="34" charset="0"/>
+                <a:ea typeface="Be Vietnam Pro" pitchFamily="34" charset="-122"/>
+                <a:cs typeface="Be Vietnam Pro" pitchFamily="34" charset="-120"/>
+              </a:rPr>
+              <a:t> liệu,</a:t>
             </a:r>
             <a:r>
               <a:rPr lang="en-US" sz="2850" dirty="0" spc="0" kern="0">
@@ -5614,7 +5647,40 @@
                 <a:ea typeface="Be Vietnam Pro" pitchFamily="34" charset="-122"/>
                 <a:cs typeface="Be Vietnam Pro" pitchFamily="34" charset="-120"/>
               </a:rPr>
-              <a:t> nói</a:t>
+              <a:t> HTTP</a:t>
+            </a:r>
+            <a:r>
+              <a:rPr lang="en-US" sz="2850" dirty="0" spc="1" kern="0">
+                <a:solidFill>
+                  <a:srgbClr val="F3EEE3"/>
+                </a:solidFill>
+                <a:latin typeface="Be Vietnam Pro" pitchFamily="34" charset="0"/>
+                <a:ea typeface="Be Vietnam Pro" pitchFamily="34" charset="-122"/>
+                <a:cs typeface="Be Vietnam Pro" pitchFamily="34" charset="-120"/>
+              </a:rPr>
+              <a:t> hỏi</a:t>
+            </a:r>
+            <a:r>
+              <a:rPr lang="en-US" sz="2850" dirty="0" spc="-16" kern="0">
+                <a:solidFill>
+                  <a:srgbClr val="F3EEE3"/>
+                </a:solidFill>
+                <a:latin typeface="Be Vietnam Pro" pitchFamily="34" charset="0"/>
+                <a:ea typeface="Be Vietnam Pro" pitchFamily="34" charset="-122"/>
+                <a:cs typeface="Be Vietnam Pro" pitchFamily="34" charset="-120"/>
+              </a:rPr>
+              <a:t> và</a:t>
+            </a:r>
+            <a:r>
+              <a:rPr lang="en-US" sz="2850" dirty="0" spc="11" kern="0">
+                <a:solidFill>
+                  <a:srgbClr val="F3EEE3"/>
+                </a:solidFill>
+                <a:latin typeface="Be Vietnam Pro" pitchFamily="34" charset="0"/>
+                <a:ea typeface="Be Vietnam Pro" pitchFamily="34" charset="-122"/>
+                <a:cs typeface="Be Vietnam Pro" pitchFamily="34" charset="-120"/>
+              </a:rPr>
+              <a:t> đáp,</a:t>
             </a:r>
             <a:r>
               <a:rPr lang="en-US" sz="2850" dirty="0" spc="3" kern="0">
@@ -5625,43 +5691,10 @@
                 <a:ea typeface="Be Vietnam Pro" pitchFamily="34" charset="-122"/>
                 <a:cs typeface="Be Vietnam Pro" pitchFamily="34" charset="-120"/>
               </a:rPr>
-              <a:t> IETF</a:t>
-            </a:r>
-            <a:r>
-              <a:rPr lang="en-US" sz="2850" dirty="0" spc="-13" kern="0">
-                <a:solidFill>
-                  <a:srgbClr val="F3EEE3"/>
-                </a:solidFill>
-                <a:latin typeface="Be Vietnam Pro" pitchFamily="34" charset="0"/>
-                <a:ea typeface="Be Vietnam Pro" pitchFamily="34" charset="-122"/>
-                <a:cs typeface="Be Vietnam Pro" pitchFamily="34" charset="-120"/>
-              </a:rPr>
-              <a:t> phát</a:t>
-            </a:r>
-            <a:r>
-              <a:rPr lang="en-US" sz="2850" dirty="0" spc="10" kern="0">
-                <a:solidFill>
-                  <a:srgbClr val="F3EEE3"/>
-                </a:solidFill>
-                <a:latin typeface="Be Vietnam Pro" pitchFamily="34" charset="0"/>
-                <a:ea typeface="Be Vietnam Pro" pitchFamily="34" charset="-122"/>
-                <a:cs typeface="Be Vietnam Pro" pitchFamily="34" charset="-120"/>
-              </a:rPr>
-              <a:t> triển</a:t>
-            </a:r>
-            <a:r>
-              <a:rPr lang="en-US" sz="2850" dirty="0" spc="-30" kern="0">
-                <a:solidFill>
-                  <a:srgbClr val="F3EEE3"/>
-                </a:solidFill>
-                <a:latin typeface="Be Vietnam Pro" pitchFamily="34" charset="0"/>
-                <a:ea typeface="Be Vietnam Pro" pitchFamily="34" charset="-122"/>
-                <a:cs typeface="Be Vietnam Pro" pitchFamily="34" charset="-120"/>
-              </a:rPr>
-              <a:t> TCP/IP</a:t>
-            </a:r>
-            <a:r>
-              <a:rPr lang="en-US" sz="2850" dirty="0" spc="-15" kern="0">
+              <a:t> HTML</a:t>
+            </a:r>
+            <a:r>
+              <a:rPr lang="en-US" sz="2850" dirty="0" spc="-16" kern="0">
                 <a:solidFill>
                   <a:srgbClr val="F3EEE3"/>
                 </a:solidFill>
@@ -5672,17 +5705,6 @@
               <a:t> và</a:t>
             </a:r>
             <a:r>
-              <a:rPr lang="en-US" sz="2850" dirty="0" spc="1" kern="0">
-                <a:solidFill>
-                  <a:srgbClr val="F3EEE3"/>
-                </a:solidFill>
-                <a:latin typeface="Be Vietnam Pro" pitchFamily="34" charset="0"/>
-                <a:ea typeface="Be Vietnam Pro" pitchFamily="34" charset="-122"/>
-                <a:cs typeface="Be Vietnam Pro" pitchFamily="34" charset="-120"/>
-              </a:rPr>
-              <a:t> HTTP.</a:t>
-            </a:r>
-            <a:r>
               <a:rPr lang="en-US" sz="2850" dirty="0" spc="-1" kern="0">
                 <a:solidFill>
                   <a:srgbClr val="F3EEE3"/>
@@ -5694,48 +5716,26 @@
               <a:t> CSS</a:t>
             </a:r>
             <a:r>
-              <a:rPr lang="en-US" sz="2850" dirty="0" spc="5" kern="0">
-                <a:solidFill>
-                  <a:srgbClr val="F3EEE3"/>
-                </a:solidFill>
-                <a:latin typeface="Be Vietnam Pro" pitchFamily="34" charset="0"/>
-                <a:ea typeface="Be Vietnam Pro" pitchFamily="34" charset="-122"/>
-                <a:cs typeface="Be Vietnam Pro" pitchFamily="34" charset="-120"/>
-              </a:rPr>
-              <a:t> thường</a:t>
-            </a:r>
-            <a:r>
-              <a:rPr lang="en-US" sz="2850" dirty="0" spc="-3" kern="0">
-                <a:solidFill>
-                  <a:srgbClr val="F3EEE3"/>
-                </a:solidFill>
-                <a:latin typeface="Be Vietnam Pro" pitchFamily="34" charset="0"/>
-                <a:ea typeface="Be Vietnam Pro" pitchFamily="34" charset="-122"/>
-                <a:cs typeface="Be Vietnam Pro" pitchFamily="34" charset="-120"/>
-              </a:rPr>
-              <a:t> dùng</a:t>
-            </a:r>
-            <a:r>
-              <a:rPr lang="en-US" sz="2850" dirty="0" spc="-2" kern="0">
-                <a:solidFill>
-                  <a:srgbClr val="F3EEE3"/>
-                </a:solidFill>
-                <a:latin typeface="Be Vietnam Pro" pitchFamily="34" charset="0"/>
-                <a:ea typeface="Be Vietnam Pro" pitchFamily="34" charset="-122"/>
-                <a:cs typeface="Be Vietnam Pro" pitchFamily="34" charset="-120"/>
-              </a:rPr>
-              <a:t> cùng</a:t>
-            </a:r>
-            <a:r>
-              <a:rPr lang="en-US" sz="2850" dirty="0" spc="3" kern="0">
-                <a:solidFill>
-                  <a:srgbClr val="F3EEE3"/>
-                </a:solidFill>
-                <a:latin typeface="Be Vietnam Pro" pitchFamily="34" charset="0"/>
-                <a:ea typeface="Be Vietnam Pro" pitchFamily="34" charset="-122"/>
-                <a:cs typeface="Be Vietnam Pro" pitchFamily="34" charset="-120"/>
-              </a:rPr>
-              <a:t> HTML.</a:t>
+              <a:rPr lang="en-US" sz="2850" dirty="0" spc="20" kern="0">
+                <a:solidFill>
+                  <a:srgbClr val="F3EEE3"/>
+                </a:solidFill>
+                <a:latin typeface="Be Vietnam Pro" pitchFamily="34" charset="0"/>
+                <a:ea typeface="Be Vietnam Pro" pitchFamily="34" charset="-122"/>
+                <a:cs typeface="Be Vietnam Pro" pitchFamily="34" charset="-120"/>
+              </a:rPr>
+              <a:t> dựng</a:t>
+            </a:r>
+            <a:r>
+              <a:rPr lang="en-US" sz="2850" dirty="0" spc="-16" kern="0">
+                <a:solidFill>
+                  <a:srgbClr val="F3EEE3"/>
+                </a:solidFill>
+                <a:latin typeface="Be Vietnam Pro" pitchFamily="34" charset="0"/>
+                <a:ea typeface="Be Vietnam Pro" pitchFamily="34" charset="-122"/>
+                <a:cs typeface="Be Vietnam Pro" pitchFamily="34" charset="-120"/>
+              </a:rPr>
+              <a:t> trang.</a:t>
             </a:r>
             <a:endParaRPr lang="en-US" sz="2850" dirty="0"/>
           </a:p>
@@ -5997,15 +5997,70 @@
               <a:buChar char="•"/>
             </a:pPr>
             <a:r>
-              <a:rPr lang="en-US" sz="2550" dirty="0" spc="-30" kern="0">
-                <a:solidFill>
-                  <a:srgbClr val="F3EEE3"/>
-                </a:solidFill>
-                <a:latin typeface="Be Vietnam Pro" pitchFamily="34" charset="0"/>
-                <a:ea typeface="Be Vietnam Pro" pitchFamily="34" charset="-122"/>
-                <a:cs typeface="Be Vietnam Pro" pitchFamily="34" charset="-120"/>
-              </a:rPr>
-              <a:t>TCP/IP</a:t>
+              <a:rPr lang="en-US" sz="2550" dirty="0" spc="-43" kern="0">
+                <a:solidFill>
+                  <a:srgbClr val="F3EEE3"/>
+                </a:solidFill>
+                <a:latin typeface="Be Vietnam Pro" pitchFamily="34" charset="0"/>
+                <a:ea typeface="Be Vietnam Pro" pitchFamily="34" charset="-122"/>
+                <a:cs typeface="Be Vietnam Pro" pitchFamily="34" charset="-120"/>
+              </a:rPr>
+              <a:t>TCP:</a:t>
+            </a:r>
+            <a:r>
+              <a:rPr lang="en-US" sz="2550" dirty="0" spc="-3" kern="0">
+                <a:solidFill>
+                  <a:srgbClr val="F3EEE3"/>
+                </a:solidFill>
+                <a:latin typeface="Be Vietnam Pro" pitchFamily="34" charset="0"/>
+                <a:ea typeface="Be Vietnam Pro" pitchFamily="34" charset="-122"/>
+                <a:cs typeface="Be Vietnam Pro" pitchFamily="34" charset="-120"/>
+              </a:rPr>
+              <a:t> dữ</a:t>
+            </a:r>
+            <a:r>
+              <a:rPr lang="en-US" sz="2550" dirty="0" spc="2" kern="0">
+                <a:solidFill>
+                  <a:srgbClr val="F3EEE3"/>
+                </a:solidFill>
+                <a:latin typeface="Be Vietnam Pro" pitchFamily="34" charset="0"/>
+                <a:ea typeface="Be Vietnam Pro" pitchFamily="34" charset="-122"/>
+                <a:cs typeface="Be Vietnam Pro" pitchFamily="34" charset="-120"/>
+              </a:rPr>
+              <a:t> liệu</a:t>
+            </a:r>
+            <a:r>
+              <a:rPr lang="en-US" sz="2550" dirty="0" spc="12" kern="0">
+                <a:solidFill>
+                  <a:srgbClr val="F3EEE3"/>
+                </a:solidFill>
+                <a:latin typeface="Be Vietnam Pro" pitchFamily="34" charset="0"/>
+                <a:ea typeface="Be Vietnam Pro" pitchFamily="34" charset="-122"/>
+                <a:cs typeface="Be Vietnam Pro" pitchFamily="34" charset="-120"/>
+              </a:rPr>
+              <a:t> đến</a:t>
+            </a:r>
+            <a:r>
+              <a:rPr lang="en-US" sz="2550" dirty="0" spc="-2" kern="0">
+                <a:solidFill>
+                  <a:srgbClr val="F3EEE3"/>
+                </a:solidFill>
+                <a:latin typeface="Be Vietnam Pro" pitchFamily="34" charset="0"/>
+                <a:ea typeface="Be Vietnam Pro" pitchFamily="34" charset="-122"/>
+                <a:cs typeface="Be Vietnam Pro" pitchFamily="34" charset="-120"/>
+              </a:rPr>
+              <a:t> đủ,</a:t>
+            </a:r>
+            <a:r>
+              <a:rPr lang="en-US" sz="2550" dirty="0" spc="-1" kern="0">
+                <a:solidFill>
+                  <a:srgbClr val="F3EEE3"/>
+                </a:solidFill>
+                <a:latin typeface="Be Vietnam Pro" pitchFamily="34" charset="0"/>
+                <a:ea typeface="Be Vietnam Pro" pitchFamily="34" charset="-122"/>
+                <a:cs typeface="Be Vietnam Pro" pitchFamily="34" charset="-120"/>
+              </a:rPr>
+              <a:t> đúng</a:t>
             </a:r>
             <a:r>
               <a:rPr lang="en-US" sz="2550" dirty="0" spc="0" kern="0">
@@ -6016,29 +6071,18 @@
                 <a:ea typeface="Be Vietnam Pro" pitchFamily="34" charset="-122"/>
                 <a:cs typeface="Be Vietnam Pro" pitchFamily="34" charset="-120"/>
               </a:rPr>
-              <a:t> là nền</a:t>
-            </a:r>
-            <a:r>
-              <a:rPr lang="en-US" sz="2550" dirty="0" spc="-2" kern="0">
-                <a:solidFill>
-                  <a:srgbClr val="F3EEE3"/>
-                </a:solidFill>
-                <a:latin typeface="Be Vietnam Pro" pitchFamily="34" charset="0"/>
-                <a:ea typeface="Be Vietnam Pro" pitchFamily="34" charset="-122"/>
-                <a:cs typeface="Be Vietnam Pro" pitchFamily="34" charset="-120"/>
-              </a:rPr>
-              <a:t> của</a:t>
-            </a:r>
-            <a:r>
-              <a:rPr lang="en-US" sz="2550" dirty="0" spc="-14" kern="0">
-                <a:solidFill>
-                  <a:srgbClr val="F3EEE3"/>
-                </a:solidFill>
-                <a:latin typeface="Be Vietnam Pro" pitchFamily="34" charset="0"/>
-                <a:ea typeface="Be Vietnam Pro" pitchFamily="34" charset="-122"/>
-                <a:cs typeface="Be Vietnam Pro" pitchFamily="34" charset="-120"/>
-              </a:rPr>
-              <a:t> Internet</a:t>
+              <a:t> thứ</a:t>
+            </a:r>
+            <a:r>
+              <a:rPr lang="en-US" sz="2550" dirty="0" spc="-1" kern="0">
+                <a:solidFill>
+                  <a:srgbClr val="F3EEE3"/>
+                </a:solidFill>
+                <a:latin typeface="Be Vietnam Pro" pitchFamily="34" charset="0"/>
+                <a:ea typeface="Be Vietnam Pro" pitchFamily="34" charset="-122"/>
+                <a:cs typeface="Be Vietnam Pro" pitchFamily="34" charset="-120"/>
+              </a:rPr>
+              <a:t> tự</a:t>
             </a:r>
             <a:endParaRPr lang="en-US" sz="2550" dirty="0"/>
           </a:p>
@@ -6066,39 +6110,6 @@
               <a:t>HTTP</a:t>
             </a:r>
             <a:r>
-              <a:rPr lang="en-US" sz="2550" dirty="0" spc="-3" kern="0">
-                <a:solidFill>
-                  <a:srgbClr val="F3EEE3"/>
-                </a:solidFill>
-                <a:latin typeface="Be Vietnam Pro" pitchFamily="34" charset="0"/>
-                <a:ea typeface="Be Vietnam Pro" pitchFamily="34" charset="-122"/>
-                <a:cs typeface="Be Vietnam Pro" pitchFamily="34" charset="-120"/>
-              </a:rPr>
-              <a:t> thiết</a:t>
-            </a:r>
-            <a:r>
-              <a:rPr lang="en-US" sz="2550" dirty="0" spc="-21" kern="0">
-                <a:solidFill>
-                  <a:srgbClr val="F3EEE3"/>
-                </a:solidFill>
-                <a:latin typeface="Be Vietnam Pro" pitchFamily="34" charset="0"/>
-                <a:ea typeface="Be Vietnam Pro" pitchFamily="34" charset="-122"/>
-                <a:cs typeface="Be Vietnam Pro" pitchFamily="34" charset="-120"/>
-              </a:rPr>
-              <a:t> yếu</a:t>
-            </a:r>
-            <a:r>
-              <a:rPr lang="en-US" sz="2550" dirty="0" spc="-15" kern="0">
-                <a:solidFill>
-                  <a:srgbClr val="F3EEE3"/>
-                </a:solidFill>
-                <a:latin typeface="Be Vietnam Pro" pitchFamily="34" charset="0"/>
-                <a:ea typeface="Be Vietnam Pro" pitchFamily="34" charset="-122"/>
-                <a:cs typeface="Be Vietnam Pro" pitchFamily="34" charset="-120"/>
-              </a:rPr>
-              <a:t> với</a:t>
-            </a:r>
-            <a:r>
               <a:rPr lang="en-US" sz="2550" dirty="0" spc="0" kern="0">
                 <a:solidFill>
                   <a:srgbClr val="F3EEE3"/>
@@ -6107,18 +6118,29 @@
                 <a:ea typeface="Be Vietnam Pro" pitchFamily="34" charset="-122"/>
                 <a:cs typeface="Be Vietnam Pro" pitchFamily="34" charset="-120"/>
               </a:rPr>
-              <a:t> mọi</a:t>
-            </a:r>
-            <a:r>
-              <a:rPr lang="en-US" sz="2550" dirty="0" spc="5" kern="0">
-                <a:solidFill>
-                  <a:srgbClr val="F3EEE3"/>
-                </a:solidFill>
-                <a:latin typeface="Be Vietnam Pro" pitchFamily="34" charset="0"/>
-                <a:ea typeface="Be Vietnam Pro" pitchFamily="34" charset="-122"/>
-                <a:cs typeface="Be Vietnam Pro" pitchFamily="34" charset="-120"/>
-              </a:rPr>
-              <a:t> người</a:t>
+              <a:t> không</a:t>
+            </a:r>
+            <a:r>
+              <a:rPr lang="en-US" sz="2550" dirty="0" spc="-1" kern="0">
+                <a:solidFill>
+                  <a:srgbClr val="F3EEE3"/>
+                </a:solidFill>
+                <a:latin typeface="Be Vietnam Pro" pitchFamily="34" charset="0"/>
+                <a:ea typeface="Be Vietnam Pro" pitchFamily="34" charset="-122"/>
+                <a:cs typeface="Be Vietnam Pro" pitchFamily="34" charset="-120"/>
+              </a:rPr>
+              <a:t> nhớ</a:t>
+            </a:r>
+            <a:r>
+              <a:rPr lang="en-US" sz="2550" dirty="0" spc="-16" kern="0">
+                <a:solidFill>
+                  <a:srgbClr val="F3EEE3"/>
+                </a:solidFill>
+                <a:latin typeface="Be Vietnam Pro" pitchFamily="34" charset="0"/>
+                <a:ea typeface="Be Vietnam Pro" pitchFamily="34" charset="-122"/>
+                <a:cs typeface="Be Vietnam Pro" pitchFamily="34" charset="-120"/>
+              </a:rPr>
+              <a:t> trạng</a:t>
             </a:r>
             <a:r>
               <a:rPr lang="en-US" sz="2550" dirty="0" spc="1" kern="0">
@@ -6129,18 +6151,40 @@
                 <a:ea typeface="Be Vietnam Pro" pitchFamily="34" charset="-122"/>
                 <a:cs typeface="Be Vietnam Pro" pitchFamily="34" charset="-120"/>
               </a:rPr>
-              <a:t> làm</a:t>
-            </a:r>
-            <a:r>
-              <a:rPr lang="en-US" sz="2550" dirty="0" spc="-11" kern="0">
-                <a:solidFill>
-                  <a:srgbClr val="F3EEE3"/>
-                </a:solidFill>
-                <a:latin typeface="Be Vietnam Pro" pitchFamily="34" charset="0"/>
-                <a:ea typeface="Be Vietnam Pro" pitchFamily="34" charset="-122"/>
-                <a:cs typeface="Be Vietnam Pro" pitchFamily="34" charset="-120"/>
-              </a:rPr>
-              <a:t> web</a:t>
+              <a:t> thái</a:t>
+            </a:r>
+            <a:r>
+              <a:rPr lang="en-US" sz="2550" dirty="0" spc="6" kern="0">
+                <a:solidFill>
+                  <a:srgbClr val="F3EEE3"/>
+                </a:solidFill>
+                <a:latin typeface="Be Vietnam Pro" pitchFamily="34" charset="0"/>
+                <a:ea typeface="Be Vietnam Pro" pitchFamily="34" charset="-122"/>
+                <a:cs typeface="Be Vietnam Pro" pitchFamily="34" charset="-120"/>
+              </a:rPr>
+              <a:t> giữa</a:t>
+            </a:r>
+            <a:r>
+              <a:rPr lang="en-US" sz="2550" dirty="0" spc="1" kern="0">
+                <a:solidFill>
+                  <a:srgbClr val="F3EEE3"/>
+                </a:solidFill>
+                <a:latin typeface="Be Vietnam Pro" pitchFamily="34" charset="0"/>
+                <a:ea typeface="Be Vietnam Pro" pitchFamily="34" charset="-122"/>
+                <a:cs typeface="Be Vietnam Pro" pitchFamily="34" charset="-120"/>
+              </a:rPr>
+              <a:t> các</a:t>
+            </a:r>
+            <a:r>
+              <a:rPr lang="en-US" sz="2550" dirty="0" spc="0" kern="0">
+                <a:solidFill>
+                  <a:srgbClr val="F3EEE3"/>
+                </a:solidFill>
+                <a:latin typeface="Be Vietnam Pro" pitchFamily="34" charset="0"/>
+                <a:ea typeface="Be Vietnam Pro" pitchFamily="34" charset="-122"/>
+                <a:cs typeface="Be Vietnam Pro" pitchFamily="34" charset="-120"/>
+              </a:rPr>
+              <a:t> lần</a:t>
             </a:r>
             <a:endParaRPr lang="en-US" sz="2550" dirty="0"/>
           </a:p>
@@ -6165,26 +6209,26 @@
               <a:t>HTML</a:t>
             </a:r>
             <a:r>
-              <a:rPr lang="en-US" sz="2550" dirty="0" spc="-2" kern="0">
-                <a:solidFill>
-                  <a:srgbClr val="F3EEE3"/>
-                </a:solidFill>
-                <a:latin typeface="Be Vietnam Pro" pitchFamily="34" charset="0"/>
-                <a:ea typeface="Be Vietnam Pro" pitchFamily="34" charset="-122"/>
-                <a:cs typeface="Be Vietnam Pro" pitchFamily="34" charset="-120"/>
-              </a:rPr>
-              <a:t> giúp</a:t>
-            </a:r>
-            <a:r>
-              <a:rPr lang="en-US" sz="2550" dirty="0" spc="-16" kern="0">
-                <a:solidFill>
-                  <a:srgbClr val="F3EEE3"/>
-                </a:solidFill>
-                <a:latin typeface="Be Vietnam Pro" pitchFamily="34" charset="0"/>
-                <a:ea typeface="Be Vietnam Pro" pitchFamily="34" charset="-122"/>
-                <a:cs typeface="Be Vietnam Pro" pitchFamily="34" charset="-120"/>
-              </a:rPr>
-              <a:t> trang</a:t>
+              <a:rPr lang="en-US" sz="2550" dirty="0" spc="19" kern="0">
+                <a:solidFill>
+                  <a:srgbClr val="F3EEE3"/>
+                </a:solidFill>
+                <a:latin typeface="Be Vietnam Pro" pitchFamily="34" charset="0"/>
+                <a:ea typeface="Be Vietnam Pro" pitchFamily="34" charset="-122"/>
+                <a:cs typeface="Be Vietnam Pro" pitchFamily="34" charset="-120"/>
+              </a:rPr>
+              <a:t> dựng</a:t>
+            </a:r>
+            <a:r>
+              <a:rPr lang="en-US" sz="2550" dirty="0" spc="2" kern="0">
+                <a:solidFill>
+                  <a:srgbClr val="F3EEE3"/>
+                </a:solidFill>
+                <a:latin typeface="Be Vietnam Pro" pitchFamily="34" charset="0"/>
+                <a:ea typeface="Be Vietnam Pro" pitchFamily="34" charset="-122"/>
+                <a:cs typeface="Be Vietnam Pro" pitchFamily="34" charset="-120"/>
+              </a:rPr>
+              <a:t> cấu</a:t>
             </a:r>
             <a:r>
               <a:rPr lang="en-US" sz="2550" dirty="0" spc="-1" kern="0">
@@ -6195,40 +6239,51 @@
                 <a:ea typeface="Be Vietnam Pro" pitchFamily="34" charset="-122"/>
                 <a:cs typeface="Be Vietnam Pro" pitchFamily="34" charset="-120"/>
               </a:rPr>
-              <a:t> hiển</a:t>
-            </a:r>
-            <a:r>
-              <a:rPr lang="en-US" sz="2550" dirty="0" spc="2" kern="0">
-                <a:solidFill>
-                  <a:srgbClr val="F3EEE3"/>
-                </a:solidFill>
-                <a:latin typeface="Be Vietnam Pro" pitchFamily="34" charset="0"/>
-                <a:ea typeface="Be Vietnam Pro" pitchFamily="34" charset="-122"/>
-                <a:cs typeface="Be Vietnam Pro" pitchFamily="34" charset="-120"/>
-              </a:rPr>
-              <a:t> thị</a:t>
-            </a:r>
-            <a:r>
-              <a:rPr lang="en-US" sz="2550" dirty="0" spc="10" kern="0">
-                <a:solidFill>
-                  <a:srgbClr val="F3EEE3"/>
-                </a:solidFill>
-                <a:latin typeface="Be Vietnam Pro" pitchFamily="34" charset="0"/>
-                <a:ea typeface="Be Vietnam Pro" pitchFamily="34" charset="-122"/>
-                <a:cs typeface="Be Vietnam Pro" pitchFamily="34" charset="-120"/>
-              </a:rPr>
-              <a:t> đồng</a:t>
-            </a:r>
-            <a:r>
-              <a:rPr lang="en-US" sz="2550" dirty="0" spc="-9" kern="0">
-                <a:solidFill>
-                  <a:srgbClr val="F3EEE3"/>
-                </a:solidFill>
-                <a:latin typeface="Be Vietnam Pro" pitchFamily="34" charset="0"/>
-                <a:ea typeface="Be Vietnam Pro" pitchFamily="34" charset="-122"/>
-                <a:cs typeface="Be Vietnam Pro" pitchFamily="34" charset="-120"/>
-              </a:rPr>
-              <a:t> nhất</a:t>
+              <a:t> trúc,</a:t>
+            </a:r>
+            <a:r>
+              <a:rPr lang="en-US" sz="2550" dirty="0" spc="-3" kern="0">
+                <a:solidFill>
+                  <a:srgbClr val="F3EEE3"/>
+                </a:solidFill>
+                <a:latin typeface="Be Vietnam Pro" pitchFamily="34" charset="0"/>
+                <a:ea typeface="Be Vietnam Pro" pitchFamily="34" charset="-122"/>
+                <a:cs typeface="Be Vietnam Pro" pitchFamily="34" charset="-120"/>
+              </a:rPr>
+              <a:t> CSS</a:t>
+            </a:r>
+            <a:r>
+              <a:rPr lang="en-US" sz="2550" dirty="0" spc="20" kern="0">
+                <a:solidFill>
+                  <a:srgbClr val="F3EEE3"/>
+                </a:solidFill>
+                <a:latin typeface="Be Vietnam Pro" pitchFamily="34" charset="0"/>
+                <a:ea typeface="Be Vietnam Pro" pitchFamily="34" charset="-122"/>
+                <a:cs typeface="Be Vietnam Pro" pitchFamily="34" charset="-120"/>
+              </a:rPr>
+              <a:t> dựng</a:t>
+            </a:r>
+            <a:r>
+              <a:rPr lang="en-US" sz="2550" dirty="0" spc="0" kern="0">
+                <a:solidFill>
+                  <a:srgbClr val="F3EEE3"/>
+                </a:solidFill>
+                <a:latin typeface="Be Vietnam Pro" pitchFamily="34" charset="0"/>
+                <a:ea typeface="Be Vietnam Pro" pitchFamily="34" charset="-122"/>
+                <a:cs typeface="Be Vietnam Pro" pitchFamily="34" charset="-120"/>
+              </a:rPr>
+              <a:t> hình</a:t>
+            </a:r>
+            <a:r>
+              <a:rPr lang="en-US" sz="2550" dirty="0" spc="7" kern="0">
+                <a:solidFill>
+                  <a:srgbClr val="F3EEE3"/>
+                </a:solidFill>
+                <a:latin typeface="Be Vietnam Pro" pitchFamily="34" charset="0"/>
+                <a:ea typeface="Be Vietnam Pro" pitchFamily="34" charset="-122"/>
+                <a:cs typeface="Be Vietnam Pro" pitchFamily="34" charset="-120"/>
+              </a:rPr>
+              <a:t> thức</a:t>
             </a:r>
             <a:endParaRPr lang="en-US" sz="2550" dirty="0"/>
           </a:p>
@@ -8178,7 +8233,29 @@
                 <a:ea typeface="Be Vietnam Pro" pitchFamily="34" charset="-122"/>
                 <a:cs typeface="Be Vietnam Pro" pitchFamily="34" charset="-120"/>
               </a:rPr>
-              <a:t> quản</a:t>
+              <a:t> truy</a:t>
+            </a:r>
+            <a:r>
+              <a:rPr lang="en-US" sz="2550" dirty="0" spc="-14" kern="0">
+                <a:solidFill>
+                  <a:srgbClr val="14161C"/>
+                </a:solidFill>
+                <a:latin typeface="Be Vietnam Pro" pitchFamily="34" charset="0"/>
+                <a:ea typeface="Be Vietnam Pro" pitchFamily="34" charset="-122"/>
+                <a:cs typeface="Be Vietnam Pro" pitchFamily="34" charset="-120"/>
+              </a:rPr>
+              <a:t> vấn</a:t>
+            </a:r>
+            <a:r>
+              <a:rPr lang="en-US" sz="2550" dirty="0" spc="-18" kern="0">
+                <a:solidFill>
+                  <a:srgbClr val="14161C"/>
+                </a:solidFill>
+                <a:latin typeface="Be Vietnam Pro" pitchFamily="34" charset="0"/>
+                <a:ea typeface="Be Vietnam Pro" pitchFamily="34" charset="-122"/>
+                <a:cs typeface="Be Vietnam Pro" pitchFamily="34" charset="-120"/>
+              </a:rPr>
+              <a:t> và</a:t>
             </a:r>
             <a:r>
               <a:rPr lang="en-US" sz="2550" dirty="0" spc="0" kern="0">
@@ -8189,7 +8266,18 @@
                 <a:ea typeface="Be Vietnam Pro" pitchFamily="34" charset="-122"/>
                 <a:cs typeface="Be Vietnam Pro" pitchFamily="34" charset="-120"/>
               </a:rPr>
-              <a:t> lý</a:t>
+              <a:t> cập</a:t>
+            </a:r>
+            <a:r>
+              <a:rPr lang="en-US" sz="2550" dirty="0" spc="-9" kern="0">
+                <a:solidFill>
+                  <a:srgbClr val="14161C"/>
+                </a:solidFill>
+                <a:latin typeface="Be Vietnam Pro" pitchFamily="34" charset="0"/>
+                <a:ea typeface="Be Vietnam Pro" pitchFamily="34" charset="-122"/>
+                <a:cs typeface="Be Vietnam Pro" pitchFamily="34" charset="-120"/>
+              </a:rPr>
+              <a:t> nhật</a:t>
             </a:r>
             <a:r>
               <a:rPr lang="en-US" sz="2550" dirty="0" spc="-2" kern="0">
@@ -8212,6 +8300,17 @@
                 <a:cs typeface="Be Vietnam Pro" pitchFamily="34" charset="-120"/>
               </a:rPr>
               <a:t> liệu</a:t>
+            </a:r>
+            <a:r>
+              <a:rPr lang="en-US" sz="2550" dirty="0" spc="-2" kern="0">
+                <a:solidFill>
+                  <a:srgbClr val="14161C"/>
+                </a:solidFill>
+                <a:latin typeface="Be Vietnam Pro" pitchFamily="34" charset="0"/>
+                <a:ea typeface="Be Vietnam Pro" pitchFamily="34" charset="-122"/>
+                <a:cs typeface="Be Vietnam Pro" pitchFamily="34" charset="-120"/>
+              </a:rPr>
+              <a:t> bảng</a:t>
             </a:r>
             <a:endParaRPr lang="en-US" sz="2550" dirty="0"/>
           </a:p>
@@ -8349,6 +8448,28 @@
               <a:t> tả</a:t>
             </a:r>
             <a:r>
+              <a:rPr lang="en-US" sz="2550" dirty="0" spc="0" kern="0">
+                <a:solidFill>
+                  <a:srgbClr val="14161C"/>
+                </a:solidFill>
+                <a:latin typeface="Be Vietnam Pro" pitchFamily="34" charset="0"/>
+                <a:ea typeface="Be Vietnam Pro" pitchFamily="34" charset="-122"/>
+                <a:cs typeface="Be Vietnam Pro" pitchFamily="34" charset="-120"/>
+              </a:rPr>
+              <a:t> API</a:t>
+            </a:r>
+            <a:r>
+              <a:rPr lang="en-US" sz="2550" dirty="0" spc="-8" kern="0">
+                <a:solidFill>
+                  <a:srgbClr val="14161C"/>
+                </a:solidFill>
+                <a:latin typeface="Be Vietnam Pro" pitchFamily="34" charset="0"/>
+                <a:ea typeface="Be Vietnam Pro" pitchFamily="34" charset="-122"/>
+                <a:cs typeface="Be Vietnam Pro" pitchFamily="34" charset="-120"/>
+              </a:rPr>
+              <a:t> chạy</a:t>
+            </a:r>
+            <a:r>
               <a:rPr lang="en-US" sz="2550" dirty="0" spc="-19" kern="0">
                 <a:solidFill>
                   <a:srgbClr val="14161C"/>
@@ -8357,51 +8478,18 @@
                 <a:ea typeface="Be Vietnam Pro" pitchFamily="34" charset="-122"/>
                 <a:cs typeface="Be Vietnam Pro" pitchFamily="34" charset="-120"/>
               </a:rPr>
-              <a:t> và</a:t>
-            </a:r>
-            <a:r>
-              <a:rPr lang="en-US" sz="2550" dirty="0" spc="0" kern="0">
-                <a:solidFill>
-                  <a:srgbClr val="14161C"/>
-                </a:solidFill>
-                <a:latin typeface="Be Vietnam Pro" pitchFamily="34" charset="0"/>
-                <a:ea typeface="Be Vietnam Pro" pitchFamily="34" charset="-122"/>
-                <a:cs typeface="Be Vietnam Pro" pitchFamily="34" charset="-120"/>
-              </a:rPr>
-              <a:t> ghi</a:t>
-            </a:r>
-            <a:r>
-              <a:rPr lang="en-US" sz="2550" dirty="0" spc="-12" kern="0">
-                <a:solidFill>
-                  <a:srgbClr val="14161C"/>
-                </a:solidFill>
-                <a:latin typeface="Be Vietnam Pro" pitchFamily="34" charset="0"/>
-                <a:ea typeface="Be Vietnam Pro" pitchFamily="34" charset="-122"/>
-                <a:cs typeface="Be Vietnam Pro" pitchFamily="34" charset="-120"/>
-              </a:rPr>
-              <a:t> tài</a:t>
-            </a:r>
-            <a:r>
-              <a:rPr lang="en-US" sz="2550" dirty="0" spc="1" kern="0">
-                <a:solidFill>
-                  <a:srgbClr val="14161C"/>
-                </a:solidFill>
-                <a:latin typeface="Be Vietnam Pro" pitchFamily="34" charset="0"/>
-                <a:ea typeface="Be Vietnam Pro" pitchFamily="34" charset="-122"/>
-                <a:cs typeface="Be Vietnam Pro" pitchFamily="34" charset="-120"/>
-              </a:rPr>
-              <a:t> liệu</a:t>
-            </a:r>
-            <a:r>
-              <a:rPr lang="en-US" sz="2550" dirty="0" spc="0" kern="0">
-                <a:solidFill>
-                  <a:srgbClr val="14161C"/>
-                </a:solidFill>
-                <a:latin typeface="Be Vietnam Pro" pitchFamily="34" charset="0"/>
-                <a:ea typeface="Be Vietnam Pro" pitchFamily="34" charset="-122"/>
-                <a:cs typeface="Be Vietnam Pro" pitchFamily="34" charset="-120"/>
-              </a:rPr>
-              <a:t> API</a:t>
+              <a:t> trên</a:t>
+            </a:r>
+            <a:r>
+              <a:rPr lang="en-US" sz="2550" dirty="0" spc="-2" kern="0">
+                <a:solidFill>
+                  <a:srgbClr val="14161C"/>
+                </a:solidFill>
+                <a:latin typeface="Be Vietnam Pro" pitchFamily="34" charset="0"/>
+                <a:ea typeface="Be Vietnam Pro" pitchFamily="34" charset="-122"/>
+                <a:cs typeface="Be Vietnam Pro" pitchFamily="34" charset="-120"/>
+              </a:rPr>
+              <a:t> HTTP</a:t>
             </a:r>
             <a:endParaRPr lang="en-US" sz="2550" dirty="0"/>
           </a:p>
@@ -8563,7 +8651,7 @@
               <a:buNone/>
             </a:pPr>
             <a:r>
-              <a:rPr lang="en-US" sz="1950" b="1" spc="138" kern="0" dirty="0">
+              <a:rPr lang="en-US" sz="1950" b="1" spc="145" kern="0" dirty="0">
                 <a:solidFill>
                   <a:srgbClr val="B45309"/>
                 </a:solidFill>
@@ -8571,10 +8659,10 @@
                 <a:ea typeface="Be Vietnam Pro" pitchFamily="34" charset="-122"/>
                 <a:cs typeface="Be Vietnam Pro" pitchFamily="34" charset="-120"/>
               </a:rPr>
-              <a:t>QUẢN</a:t>
-            </a:r>
-            <a:r>
-              <a:rPr lang="en-US" sz="1950" b="1" spc="49" kern="0" dirty="0">
+              <a:t>TRUY</a:t>
+            </a:r>
+            <a:r>
+              <a:rPr lang="en-US" sz="1950" b="1" spc="112" kern="0" dirty="0">
                 <a:solidFill>
                   <a:srgbClr val="B45309"/>
                 </a:solidFill>
@@ -8582,7 +8670,7 @@
                 <a:ea typeface="Be Vietnam Pro" pitchFamily="34" charset="-122"/>
                 <a:cs typeface="Be Vietnam Pro" pitchFamily="34" charset="-120"/>
               </a:rPr>
-              <a:t> LÝ</a:t>
+              <a:t> VẤN</a:t>
             </a:r>
             <a:endParaRPr lang="en-US" sz="1950" dirty="0"/>
           </a:p>
@@ -8638,26 +8726,15 @@
               <a:t> ngữ</a:t>
             </a:r>
             <a:r>
-              <a:rPr lang="en-US" sz="2250" dirty="0" spc="-11" kern="0">
-                <a:solidFill>
-                  <a:srgbClr val="14161C"/>
-                </a:solidFill>
-                <a:latin typeface="Be Vietnam Pro" pitchFamily="34" charset="0"/>
-                <a:ea typeface="Be Vietnam Pro" pitchFamily="34" charset="-122"/>
-                <a:cs typeface="Be Vietnam Pro" pitchFamily="34" charset="-120"/>
-              </a:rPr>
-              <a:t> chuyên</a:t>
-            </a:r>
-            <a:r>
-              <a:rPr lang="en-US" sz="2250" dirty="0" spc="-5" kern="0">
-                <a:solidFill>
-                  <a:srgbClr val="14161C"/>
-                </a:solidFill>
-                <a:latin typeface="Be Vietnam Pro" pitchFamily="34" charset="0"/>
-                <a:ea typeface="Be Vietnam Pro" pitchFamily="34" charset="-122"/>
-                <a:cs typeface="Be Vietnam Pro" pitchFamily="34" charset="-120"/>
-              </a:rPr>
-              <a:t> biệt</a:t>
+              <a:rPr lang="en-US" sz="2250" dirty="0" spc="15" kern="0">
+                <a:solidFill>
+                  <a:srgbClr val="14161C"/>
+                </a:solidFill>
+                <a:latin typeface="Be Vietnam Pro" pitchFamily="34" charset="0"/>
+                <a:ea typeface="Be Vietnam Pro" pitchFamily="34" charset="-122"/>
+                <a:cs typeface="Be Vietnam Pro" pitchFamily="34" charset="-120"/>
+              </a:rPr>
+              <a:t> để</a:t>
             </a:r>
             <a:r>
               <a:rPr lang="en-US" sz="2250" dirty="0" spc="0" kern="0">
@@ -8668,29 +8745,73 @@
                 <a:ea typeface="Be Vietnam Pro" pitchFamily="34" charset="-122"/>
                 <a:cs typeface="Be Vietnam Pro" pitchFamily="34" charset="-120"/>
               </a:rPr>
-              <a:t> (domain-specific</a:t>
-            </a:r>
-            <a:r>
-              <a:rPr lang="en-US" sz="2250" dirty="0" spc="-6" kern="0">
-                <a:solidFill>
-                  <a:srgbClr val="14161C"/>
-                </a:solidFill>
-                <a:latin typeface="Be Vietnam Pro" pitchFamily="34" charset="0"/>
-                <a:ea typeface="Be Vietnam Pro" pitchFamily="34" charset="-122"/>
-                <a:cs typeface="Be Vietnam Pro" pitchFamily="34" charset="-120"/>
-              </a:rPr>
-              <a:t> language)</a:t>
-            </a:r>
-            <a:r>
-              <a:rPr lang="en-US" sz="2250" dirty="0" spc="16" kern="0">
-                <a:solidFill>
-                  <a:srgbClr val="14161C"/>
-                </a:solidFill>
-                <a:latin typeface="Be Vietnam Pro" pitchFamily="34" charset="0"/>
-                <a:ea typeface="Be Vietnam Pro" pitchFamily="34" charset="-122"/>
-                <a:cs typeface="Be Vietnam Pro" pitchFamily="34" charset="-120"/>
-              </a:rPr>
-              <a:t> để</a:t>
+              <a:t> truy</a:t>
+            </a:r>
+            <a:r>
+              <a:rPr lang="en-US" sz="2250" dirty="0" spc="-12" kern="0">
+                <a:solidFill>
+                  <a:srgbClr val="14161C"/>
+                </a:solidFill>
+                <a:latin typeface="Be Vietnam Pro" pitchFamily="34" charset="0"/>
+                <a:ea typeface="Be Vietnam Pro" pitchFamily="34" charset="-122"/>
+                <a:cs typeface="Be Vietnam Pro" pitchFamily="34" charset="-120"/>
+              </a:rPr>
+              <a:t> vấn</a:t>
+            </a:r>
+            <a:r>
+              <a:rPr lang="en-US" sz="2250" dirty="0" spc="-17" kern="0">
+                <a:solidFill>
+                  <a:srgbClr val="14161C"/>
+                </a:solidFill>
+                <a:latin typeface="Be Vietnam Pro" pitchFamily="34" charset="0"/>
+                <a:ea typeface="Be Vietnam Pro" pitchFamily="34" charset="-122"/>
+                <a:cs typeface="Be Vietnam Pro" pitchFamily="34" charset="-120"/>
+              </a:rPr>
+              <a:t> và</a:t>
+            </a:r>
+            <a:r>
+              <a:rPr lang="en-US" sz="2250" dirty="0" spc="2" kern="0">
+                <a:solidFill>
+                  <a:srgbClr val="14161C"/>
+                </a:solidFill>
+                <a:latin typeface="Be Vietnam Pro" pitchFamily="34" charset="0"/>
+                <a:ea typeface="Be Vietnam Pro" pitchFamily="34" charset="-122"/>
+                <a:cs typeface="Be Vietnam Pro" pitchFamily="34" charset="-120"/>
+              </a:rPr>
+              <a:t> cập</a:t>
+            </a:r>
+            <a:r>
+              <a:rPr lang="en-US" sz="2250" dirty="0" spc="-9" kern="0">
+                <a:solidFill>
+                  <a:srgbClr val="14161C"/>
+                </a:solidFill>
+                <a:latin typeface="Be Vietnam Pro" pitchFamily="34" charset="0"/>
+                <a:ea typeface="Be Vietnam Pro" pitchFamily="34" charset="-122"/>
+                <a:cs typeface="Be Vietnam Pro" pitchFamily="34" charset="-120"/>
+              </a:rPr>
+              <a:t> nhật</a:t>
+            </a:r>
+            <a:r>
+              <a:rPr lang="en-US" sz="2250" dirty="0" spc="5" kern="0">
+                <a:solidFill>
+                  <a:srgbClr val="14161C"/>
+                </a:solidFill>
+                <a:latin typeface="Be Vietnam Pro" pitchFamily="34" charset="0"/>
+                <a:ea typeface="Be Vietnam Pro" pitchFamily="34" charset="-122"/>
+                <a:cs typeface="Be Vietnam Pro" pitchFamily="34" charset="-120"/>
+              </a:rPr>
+              <a:t> dữ</a:t>
+            </a:r>
+            <a:r>
+              <a:rPr lang="en-US" sz="2250" dirty="0" spc="-2" kern="0">
+                <a:solidFill>
+                  <a:srgbClr val="14161C"/>
+                </a:solidFill>
+                <a:latin typeface="Be Vietnam Pro" pitchFamily="34" charset="0"/>
+                <a:ea typeface="Be Vietnam Pro" pitchFamily="34" charset="-122"/>
+                <a:cs typeface="Be Vietnam Pro" pitchFamily="34" charset="-120"/>
+              </a:rPr>
+              <a:t> liệu</a:t>
             </a:r>
             <a:r>
               <a:rPr lang="en-US" sz="2250" dirty="0" spc="1" kern="0">
@@ -8701,40 +8822,18 @@
                 <a:ea typeface="Be Vietnam Pro" pitchFamily="34" charset="-122"/>
                 <a:cs typeface="Be Vietnam Pro" pitchFamily="34" charset="-120"/>
               </a:rPr>
-              <a:t> quản</a:t>
-            </a:r>
-            <a:r>
-              <a:rPr lang="en-US" sz="2250" dirty="0" spc="0" kern="0">
-                <a:solidFill>
-                  <a:srgbClr val="14161C"/>
-                </a:solidFill>
-                <a:latin typeface="Be Vietnam Pro" pitchFamily="34" charset="0"/>
-                <a:ea typeface="Be Vietnam Pro" pitchFamily="34" charset="-122"/>
-                <a:cs typeface="Be Vietnam Pro" pitchFamily="34" charset="-120"/>
-              </a:rPr>
-              <a:t> lý</a:t>
-            </a:r>
-            <a:r>
-              <a:rPr lang="en-US" sz="2250" dirty="0" spc="5" kern="0">
-                <a:solidFill>
-                  <a:srgbClr val="14161C"/>
-                </a:solidFill>
-                <a:latin typeface="Be Vietnam Pro" pitchFamily="34" charset="0"/>
-                <a:ea typeface="Be Vietnam Pro" pitchFamily="34" charset="-122"/>
-                <a:cs typeface="Be Vietnam Pro" pitchFamily="34" charset="-120"/>
-              </a:rPr>
-              <a:t> dữ</a:t>
-            </a:r>
-            <a:r>
-              <a:rPr lang="en-US" sz="2250" dirty="0" spc="0" kern="0">
-                <a:solidFill>
-                  <a:srgbClr val="14161C"/>
-                </a:solidFill>
-                <a:latin typeface="Be Vietnam Pro" pitchFamily="34" charset="0"/>
-                <a:ea typeface="Be Vietnam Pro" pitchFamily="34" charset="-122"/>
-                <a:cs typeface="Be Vietnam Pro" pitchFamily="34" charset="-120"/>
-              </a:rPr>
-              <a:t> liệu.</a:t>
+              <a:t> dạng</a:t>
+            </a:r>
+            <a:r>
+              <a:rPr lang="en-US" sz="2250" dirty="0" spc="-1" kern="0">
+                <a:solidFill>
+                  <a:srgbClr val="14161C"/>
+                </a:solidFill>
+                <a:latin typeface="Be Vietnam Pro" pitchFamily="34" charset="0"/>
+                <a:ea typeface="Be Vietnam Pro" pitchFamily="34" charset="-122"/>
+                <a:cs typeface="Be Vietnam Pro" pitchFamily="34" charset="-120"/>
+              </a:rPr>
+              <a:t> bảng.</a:t>
             </a:r>
             <a:endParaRPr lang="en-US" sz="2250" dirty="0"/>
           </a:p>
@@ -8941,7 +9040,18 @@
                 <a:ea typeface="Be Vietnam Pro" pitchFamily="34" charset="-122"/>
                 <a:cs typeface="Be Vietnam Pro" pitchFamily="34" charset="-120"/>
               </a:rPr>
-              <a:t>Chuẩn</a:t>
+              <a:t>Cách</a:t>
+            </a:r>
+            <a:r>
+              <a:rPr lang="en-US" sz="2250" dirty="0" spc="-1" kern="0">
+                <a:solidFill>
+                  <a:srgbClr val="14161C"/>
+                </a:solidFill>
+                <a:latin typeface="Be Vietnam Pro" pitchFamily="34" charset="0"/>
+                <a:ea typeface="Be Vietnam Pro" pitchFamily="34" charset="-122"/>
+                <a:cs typeface="Be Vietnam Pro" pitchFamily="34" charset="-120"/>
+              </a:rPr>
+              <a:t> ghi</a:t>
             </a:r>
             <a:r>
               <a:rPr lang="en-US" sz="2250" dirty="0" spc="-17" kern="0">
@@ -8966,26 +9076,59 @@
               <a:t> giờ</a:t>
             </a:r>
             <a:r>
-              <a:rPr lang="en-US" sz="2250" dirty="0" spc="16" kern="0">
-                <a:solidFill>
-                  <a:srgbClr val="14161C"/>
-                </a:solidFill>
-                <a:latin typeface="Be Vietnam Pro" pitchFamily="34" charset="0"/>
-                <a:ea typeface="Be Vietnam Pro" pitchFamily="34" charset="-122"/>
-                <a:cs typeface="Be Vietnam Pro" pitchFamily="34" charset="-120"/>
-              </a:rPr>
-              <a:t> để</a:t>
-            </a:r>
-            <a:r>
-              <a:rPr lang="en-US" sz="2250" dirty="0" spc="-20" kern="0">
-                <a:solidFill>
-                  <a:srgbClr val="14161C"/>
-                </a:solidFill>
-                <a:latin typeface="Be Vietnam Pro" pitchFamily="34" charset="0"/>
-                <a:ea typeface="Be Vietnam Pro" pitchFamily="34" charset="-122"/>
-                <a:cs typeface="Be Vietnam Pro" pitchFamily="34" charset="-120"/>
-              </a:rPr>
-              <a:t> trao</a:t>
+              <a:rPr lang="en-US" sz="2250" dirty="0" spc="1" kern="0">
+                <a:solidFill>
+                  <a:srgbClr val="14161C"/>
+                </a:solidFill>
+                <a:latin typeface="Be Vietnam Pro" pitchFamily="34" charset="0"/>
+                <a:ea typeface="Be Vietnam Pro" pitchFamily="34" charset="-122"/>
+                <a:cs typeface="Be Vietnam Pro" pitchFamily="34" charset="-120"/>
+              </a:rPr>
+              <a:t> chung</a:t>
+            </a:r>
+            <a:r>
+              <a:rPr lang="en-US" sz="2250" dirty="0" spc="6" kern="0">
+                <a:solidFill>
+                  <a:srgbClr val="14161C"/>
+                </a:solidFill>
+                <a:latin typeface="Be Vietnam Pro" pitchFamily="34" charset="0"/>
+                <a:ea typeface="Be Vietnam Pro" pitchFamily="34" charset="-122"/>
+                <a:cs typeface="Be Vietnam Pro" pitchFamily="34" charset="-120"/>
+              </a:rPr>
+              <a:t> giữa</a:t>
+            </a:r>
+            <a:r>
+              <a:rPr lang="en-US" sz="2250" dirty="0" spc="2" kern="0">
+                <a:solidFill>
+                  <a:srgbClr val="14161C"/>
+                </a:solidFill>
+                <a:latin typeface="Be Vietnam Pro" pitchFamily="34" charset="0"/>
+                <a:ea typeface="Be Vietnam Pro" pitchFamily="34" charset="-122"/>
+                <a:cs typeface="Be Vietnam Pro" pitchFamily="34" charset="-120"/>
+              </a:rPr>
+              <a:t> các</a:t>
+            </a:r>
+            <a:r>
+              <a:rPr lang="en-US" sz="2250" dirty="0" spc="0" kern="0">
+                <a:solidFill>
+                  <a:srgbClr val="14161C"/>
+                </a:solidFill>
+                <a:latin typeface="Be Vietnam Pro" pitchFamily="34" charset="0"/>
+                <a:ea typeface="Be Vietnam Pro" pitchFamily="34" charset="-122"/>
+                <a:cs typeface="Be Vietnam Pro" pitchFamily="34" charset="-120"/>
+              </a:rPr>
+              <a:t> hệ thống,</a:t>
+            </a:r>
+            <a:r>
+              <a:rPr lang="en-US" sz="2250" dirty="0" spc="4" kern="0">
+                <a:solidFill>
+                  <a:srgbClr val="14161C"/>
+                </a:solidFill>
+                <a:latin typeface="Be Vietnam Pro" pitchFamily="34" charset="0"/>
+                <a:ea typeface="Be Vietnam Pro" pitchFamily="34" charset="-122"/>
+                <a:cs typeface="Be Vietnam Pro" pitchFamily="34" charset="-120"/>
+              </a:rPr>
+              <a:t> từ</a:t>
             </a:r>
             <a:r>
               <a:rPr lang="en-US" sz="2250" dirty="0" spc="12" kern="0">
@@ -8996,40 +9139,18 @@
                 <a:ea typeface="Be Vietnam Pro" pitchFamily="34" charset="-122"/>
                 <a:cs typeface="Be Vietnam Pro" pitchFamily="34" charset="-120"/>
               </a:rPr>
-              <a:t> đổi</a:t>
-            </a:r>
-            <a:r>
-              <a:rPr lang="en-US" sz="2250" dirty="0" spc="5" kern="0">
-                <a:solidFill>
-                  <a:srgbClr val="14161C"/>
-                </a:solidFill>
-                <a:latin typeface="Be Vietnam Pro" pitchFamily="34" charset="0"/>
-                <a:ea typeface="Be Vietnam Pro" pitchFamily="34" charset="-122"/>
-                <a:cs typeface="Be Vietnam Pro" pitchFamily="34" charset="-120"/>
-              </a:rPr>
-              <a:t> dữ</a:t>
-            </a:r>
-            <a:r>
-              <a:rPr lang="en-US" sz="2250" dirty="0" spc="-2" kern="0">
-                <a:solidFill>
-                  <a:srgbClr val="14161C"/>
-                </a:solidFill>
-                <a:latin typeface="Be Vietnam Pro" pitchFamily="34" charset="0"/>
-                <a:ea typeface="Be Vietnam Pro" pitchFamily="34" charset="-122"/>
-                <a:cs typeface="Be Vietnam Pro" pitchFamily="34" charset="-120"/>
-              </a:rPr>
-              <a:t> liệu</a:t>
-            </a:r>
-            <a:r>
-              <a:rPr lang="en-US" sz="2250" dirty="0" spc="6" kern="0">
-                <a:solidFill>
-                  <a:srgbClr val="14161C"/>
-                </a:solidFill>
-                <a:latin typeface="Be Vietnam Pro" pitchFamily="34" charset="0"/>
-                <a:ea typeface="Be Vietnam Pro" pitchFamily="34" charset="-122"/>
-                <a:cs typeface="Be Vietnam Pro" pitchFamily="34" charset="-120"/>
-              </a:rPr>
-              <a:t> giữa</a:t>
+              <a:t> đơn</a:t>
+            </a:r>
+            <a:r>
+              <a:rPr lang="en-US" sz="2250" dirty="0" spc="-1" kern="0">
+                <a:solidFill>
+                  <a:srgbClr val="14161C"/>
+                </a:solidFill>
+                <a:latin typeface="Be Vietnam Pro" pitchFamily="34" charset="0"/>
+                <a:ea typeface="Be Vietnam Pro" pitchFamily="34" charset="-122"/>
+                <a:cs typeface="Be Vietnam Pro" pitchFamily="34" charset="-120"/>
+              </a:rPr>
+              <a:t> vị</a:t>
             </a:r>
             <a:r>
               <a:rPr lang="en-US" sz="2250" dirty="0" spc="2" kern="0">
@@ -9040,62 +9161,29 @@
                 <a:ea typeface="Be Vietnam Pro" pitchFamily="34" charset="-122"/>
                 <a:cs typeface="Be Vietnam Pro" pitchFamily="34" charset="-120"/>
               </a:rPr>
-              <a:t> các</a:t>
-            </a:r>
-            <a:r>
-              <a:rPr lang="en-US" sz="2250" dirty="0" spc="7" kern="0">
-                <a:solidFill>
-                  <a:srgbClr val="14161C"/>
-                </a:solidFill>
-                <a:latin typeface="Be Vietnam Pro" pitchFamily="34" charset="0"/>
-                <a:ea typeface="Be Vietnam Pro" pitchFamily="34" charset="-122"/>
-                <a:cs typeface="Be Vietnam Pro" pitchFamily="34" charset="-120"/>
-              </a:rPr>
-              <a:t> nước,</a:t>
-            </a:r>
-            <a:r>
-              <a:rPr lang="en-US" sz="2250" dirty="0" spc="-12" kern="0">
-                <a:solidFill>
-                  <a:srgbClr val="14161C"/>
-                </a:solidFill>
-                <a:latin typeface="Be Vietnam Pro" pitchFamily="34" charset="0"/>
-                <a:ea typeface="Be Vietnam Pro" pitchFamily="34" charset="-122"/>
-                <a:cs typeface="Be Vietnam Pro" pitchFamily="34" charset="-120"/>
-              </a:rPr>
-              <a:t> văn</a:t>
-            </a:r>
-            <a:r>
-              <a:rPr lang="en-US" sz="2250" dirty="0" spc="-2" kern="0">
-                <a:solidFill>
-                  <a:srgbClr val="14161C"/>
-                </a:solidFill>
-                <a:latin typeface="Be Vietnam Pro" pitchFamily="34" charset="0"/>
-                <a:ea typeface="Be Vietnam Pro" pitchFamily="34" charset="-122"/>
-                <a:cs typeface="Be Vietnam Pro" pitchFamily="34" charset="-120"/>
-              </a:rPr>
-              <a:t> hóa</a:t>
-            </a:r>
-            <a:r>
-              <a:rPr lang="en-US" sz="2250" dirty="0" spc="-17" kern="0">
-                <a:solidFill>
-                  <a:srgbClr val="14161C"/>
-                </a:solidFill>
-                <a:latin typeface="Be Vietnam Pro" pitchFamily="34" charset="0"/>
-                <a:ea typeface="Be Vietnam Pro" pitchFamily="34" charset="-122"/>
-                <a:cs typeface="Be Vietnam Pro" pitchFamily="34" charset="-120"/>
-              </a:rPr>
-              <a:t> và</a:t>
-            </a:r>
-            <a:r>
-              <a:rPr lang="en-US" sz="2250" dirty="0" spc="-6" kern="0">
-                <a:solidFill>
-                  <a:srgbClr val="14161C"/>
-                </a:solidFill>
-                <a:latin typeface="Be Vietnam Pro" pitchFamily="34" charset="0"/>
-                <a:ea typeface="Be Vietnam Pro" pitchFamily="34" charset="-122"/>
-                <a:cs typeface="Be Vietnam Pro" pitchFamily="34" charset="-120"/>
-              </a:rPr>
-              <a:t> ngành.</a:t>
+              <a:t> lớn</a:t>
+            </a:r>
+            <a:r>
+              <a:rPr lang="en-US" sz="2250" dirty="0" spc="13" kern="0">
+                <a:solidFill>
+                  <a:srgbClr val="14161C"/>
+                </a:solidFill>
+                <a:latin typeface="Be Vietnam Pro" pitchFamily="34" charset="0"/>
+                <a:ea typeface="Be Vietnam Pro" pitchFamily="34" charset="-122"/>
+                <a:cs typeface="Be Vietnam Pro" pitchFamily="34" charset="-120"/>
+              </a:rPr>
+              <a:t> đến</a:t>
+            </a:r>
+            <a:r>
+              <a:rPr lang="en-US" sz="2250" dirty="0" spc="3" kern="0">
+                <a:solidFill>
+                  <a:srgbClr val="14161C"/>
+                </a:solidFill>
+                <a:latin typeface="Be Vietnam Pro" pitchFamily="34" charset="0"/>
+                <a:ea typeface="Be Vietnam Pro" pitchFamily="34" charset="-122"/>
+                <a:cs typeface="Be Vietnam Pro" pitchFamily="34" charset="-120"/>
+              </a:rPr>
+              <a:t> nhỏ.</a:t>
             </a:r>
             <a:endParaRPr lang="en-US" sz="2250" dirty="0"/>
           </a:p>
@@ -9291,7 +9379,117 @@
                 <a:ea typeface="Be Vietnam Pro" pitchFamily="34" charset="-122"/>
                 <a:cs typeface="Be Vietnam Pro" pitchFamily="34" charset="-120"/>
               </a:rPr>
-              <a:t>Định</a:t>
+              <a:t>Mô</a:t>
+            </a:r>
+            <a:r>
+              <a:rPr lang="en-US" sz="2250" dirty="0" spc="-15" kern="0">
+                <a:solidFill>
+                  <a:srgbClr val="14161C"/>
+                </a:solidFill>
+                <a:latin typeface="Be Vietnam Pro" pitchFamily="34" charset="0"/>
+                <a:ea typeface="Be Vietnam Pro" pitchFamily="34" charset="-122"/>
+                <a:cs typeface="Be Vietnam Pro" pitchFamily="34" charset="-120"/>
+              </a:rPr>
+              <a:t> tả</a:t>
+            </a:r>
+            <a:r>
+              <a:rPr lang="en-US" sz="2250" dirty="0" spc="4" kern="0">
+                <a:solidFill>
+                  <a:srgbClr val="14161C"/>
+                </a:solidFill>
+                <a:latin typeface="Be Vietnam Pro" pitchFamily="34" charset="0"/>
+                <a:ea typeface="Be Vietnam Pro" pitchFamily="34" charset="-122"/>
+                <a:cs typeface="Be Vietnam Pro" pitchFamily="34" charset="-120"/>
+              </a:rPr>
+              <a:t> API</a:t>
+            </a:r>
+            <a:r>
+              <a:rPr lang="en-US" sz="2250" dirty="0" spc="-6" kern="0">
+                <a:solidFill>
+                  <a:srgbClr val="14161C"/>
+                </a:solidFill>
+                <a:latin typeface="Be Vietnam Pro" pitchFamily="34" charset="0"/>
+                <a:ea typeface="Be Vietnam Pro" pitchFamily="34" charset="-122"/>
+                <a:cs typeface="Be Vietnam Pro" pitchFamily="34" charset="-120"/>
+              </a:rPr>
+              <a:t> chạy</a:t>
+            </a:r>
+            <a:r>
+              <a:rPr lang="en-US" sz="2250" dirty="0" spc="-19" kern="0">
+                <a:solidFill>
+                  <a:srgbClr val="14161C"/>
+                </a:solidFill>
+                <a:latin typeface="Be Vietnam Pro" pitchFamily="34" charset="0"/>
+                <a:ea typeface="Be Vietnam Pro" pitchFamily="34" charset="-122"/>
+                <a:cs typeface="Be Vietnam Pro" pitchFamily="34" charset="-120"/>
+              </a:rPr>
+              <a:t> trên</a:t>
+            </a:r>
+            <a:r>
+              <a:rPr lang="en-US" sz="2250" dirty="0" spc="-1" kern="0">
+                <a:solidFill>
+                  <a:srgbClr val="14161C"/>
+                </a:solidFill>
+                <a:latin typeface="Be Vietnam Pro" pitchFamily="34" charset="0"/>
+                <a:ea typeface="Be Vietnam Pro" pitchFamily="34" charset="-122"/>
+                <a:cs typeface="Be Vietnam Pro" pitchFamily="34" charset="-120"/>
+              </a:rPr>
+              <a:t> HTTP,</a:t>
+            </a:r>
+            <a:r>
+              <a:rPr lang="en-US" sz="2250" dirty="0" spc="1" kern="0">
+                <a:solidFill>
+                  <a:srgbClr val="14161C"/>
+                </a:solidFill>
+                <a:latin typeface="Be Vietnam Pro" pitchFamily="34" charset="0"/>
+                <a:ea typeface="Be Vietnam Pro" pitchFamily="34" charset="-122"/>
+                <a:cs typeface="Be Vietnam Pro" pitchFamily="34" charset="-120"/>
+              </a:rPr>
+              <a:t> không</a:t>
+            </a:r>
+            <a:r>
+              <a:rPr lang="en-US" sz="2250" dirty="0" spc="-12" kern="0">
+                <a:solidFill>
+                  <a:srgbClr val="14161C"/>
+                </a:solidFill>
+                <a:latin typeface="Be Vietnam Pro" pitchFamily="34" charset="0"/>
+                <a:ea typeface="Be Vietnam Pro" pitchFamily="34" charset="-122"/>
+                <a:cs typeface="Be Vietnam Pro" pitchFamily="34" charset="-120"/>
+              </a:rPr>
+              <a:t> gắn</a:t>
+            </a:r>
+            <a:r>
+              <a:rPr lang="en-US" sz="2250" dirty="0" spc="-11" kern="0">
+                <a:solidFill>
+                  <a:srgbClr val="14161C"/>
+                </a:solidFill>
+                <a:latin typeface="Be Vietnam Pro" pitchFamily="34" charset="0"/>
+                <a:ea typeface="Be Vietnam Pro" pitchFamily="34" charset="-122"/>
+                <a:cs typeface="Be Vietnam Pro" pitchFamily="34" charset="-120"/>
+              </a:rPr>
+              <a:t> với</a:t>
+            </a:r>
+            <a:r>
+              <a:rPr lang="en-US" sz="2250" dirty="0" spc="-7" kern="0">
+                <a:solidFill>
+                  <a:srgbClr val="14161C"/>
+                </a:solidFill>
+                <a:latin typeface="Be Vietnam Pro" pitchFamily="34" charset="0"/>
+                <a:ea typeface="Be Vietnam Pro" pitchFamily="34" charset="-122"/>
+                <a:cs typeface="Be Vietnam Pro" pitchFamily="34" charset="-120"/>
+              </a:rPr>
+              <a:t> ngôn</a:t>
+            </a:r>
+            <a:r>
+              <a:rPr lang="en-US" sz="2250" dirty="0" spc="2" kern="0">
+                <a:solidFill>
+                  <a:srgbClr val="14161C"/>
+                </a:solidFill>
+                <a:latin typeface="Be Vietnam Pro" pitchFamily="34" charset="0"/>
+                <a:ea typeface="Be Vietnam Pro" pitchFamily="34" charset="-122"/>
+                <a:cs typeface="Be Vietnam Pro" pitchFamily="34" charset="-120"/>
+              </a:rPr>
+              <a:t> ngữ</a:t>
             </a:r>
             <a:r>
               <a:rPr lang="en-US" sz="2250" dirty="0" spc="0" kern="0">
@@ -9302,128 +9500,7 @@
                 <a:ea typeface="Be Vietnam Pro" pitchFamily="34" charset="-122"/>
                 <a:cs typeface="Be Vietnam Pro" pitchFamily="34" charset="-120"/>
               </a:rPr>
-              <a:t> dạng</a:t>
-            </a:r>
-            <a:r>
-              <a:rPr lang="en-US" sz="2250" dirty="0" spc="1" kern="0">
-                <a:solidFill>
-                  <a:srgbClr val="14161C"/>
-                </a:solidFill>
-                <a:latin typeface="Be Vietnam Pro" pitchFamily="34" charset="0"/>
-                <a:ea typeface="Be Vietnam Pro" pitchFamily="34" charset="-122"/>
-                <a:cs typeface="Be Vietnam Pro" pitchFamily="34" charset="-120"/>
-              </a:rPr>
-              <a:t> chuẩn</a:t>
-            </a:r>
-            <a:r>
-              <a:rPr lang="en-US" sz="2250" dirty="0" spc="15" kern="0">
-                <a:solidFill>
-                  <a:srgbClr val="14161C"/>
-                </a:solidFill>
-                <a:latin typeface="Be Vietnam Pro" pitchFamily="34" charset="0"/>
-                <a:ea typeface="Be Vietnam Pro" pitchFamily="34" charset="-122"/>
-                <a:cs typeface="Be Vietnam Pro" pitchFamily="34" charset="-120"/>
-              </a:rPr>
-              <a:t> để</a:t>
-            </a:r>
-            <a:r>
-              <a:rPr lang="en-US" sz="2250" dirty="0" spc="2" kern="0">
-                <a:solidFill>
-                  <a:srgbClr val="14161C"/>
-                </a:solidFill>
-                <a:latin typeface="Be Vietnam Pro" pitchFamily="34" charset="0"/>
-                <a:ea typeface="Be Vietnam Pro" pitchFamily="34" charset="-122"/>
-                <a:cs typeface="Be Vietnam Pro" pitchFamily="34" charset="-120"/>
-              </a:rPr>
-              <a:t> mô</a:t>
-            </a:r>
-            <a:r>
-              <a:rPr lang="en-US" sz="2250" dirty="0" spc="-15" kern="0">
-                <a:solidFill>
-                  <a:srgbClr val="14161C"/>
-                </a:solidFill>
-                <a:latin typeface="Be Vietnam Pro" pitchFamily="34" charset="0"/>
-                <a:ea typeface="Be Vietnam Pro" pitchFamily="34" charset="-122"/>
-                <a:cs typeface="Be Vietnam Pro" pitchFamily="34" charset="-120"/>
-              </a:rPr>
-              <a:t> tả</a:t>
-            </a:r>
-            <a:r>
-              <a:rPr lang="en-US" sz="2250" dirty="0" spc="-16" kern="0">
-                <a:solidFill>
-                  <a:srgbClr val="14161C"/>
-                </a:solidFill>
-                <a:latin typeface="Be Vietnam Pro" pitchFamily="34" charset="0"/>
-                <a:ea typeface="Be Vietnam Pro" pitchFamily="34" charset="-122"/>
-                <a:cs typeface="Be Vietnam Pro" pitchFamily="34" charset="-120"/>
-              </a:rPr>
-              <a:t> và</a:t>
-            </a:r>
-            <a:r>
-              <a:rPr lang="en-US" sz="2250" dirty="0" spc="-2" kern="0">
-                <a:solidFill>
-                  <a:srgbClr val="14161C"/>
-                </a:solidFill>
-                <a:latin typeface="Be Vietnam Pro" pitchFamily="34" charset="0"/>
-                <a:ea typeface="Be Vietnam Pro" pitchFamily="34" charset="-122"/>
-                <a:cs typeface="Be Vietnam Pro" pitchFamily="34" charset="-120"/>
-              </a:rPr>
-              <a:t> ghi</a:t>
-            </a:r>
-            <a:r>
-              <a:rPr lang="en-US" sz="2250" dirty="0" spc="-12" kern="0">
-                <a:solidFill>
-                  <a:srgbClr val="14161C"/>
-                </a:solidFill>
-                <a:latin typeface="Be Vietnam Pro" pitchFamily="34" charset="0"/>
-                <a:ea typeface="Be Vietnam Pro" pitchFamily="34" charset="-122"/>
-                <a:cs typeface="Be Vietnam Pro" pitchFamily="34" charset="-120"/>
-              </a:rPr>
-              <a:t> tài</a:t>
-            </a:r>
-            <a:r>
-              <a:rPr lang="en-US" sz="2250" dirty="0" spc="-2" kern="0">
-                <a:solidFill>
-                  <a:srgbClr val="14161C"/>
-                </a:solidFill>
-                <a:latin typeface="Be Vietnam Pro" pitchFamily="34" charset="0"/>
-                <a:ea typeface="Be Vietnam Pro" pitchFamily="34" charset="-122"/>
-                <a:cs typeface="Be Vietnam Pro" pitchFamily="34" charset="-120"/>
-              </a:rPr>
-              <a:t> liệu</a:t>
-            </a:r>
-            <a:r>
-              <a:rPr lang="en-US" sz="2250" dirty="0" spc="1" kern="0">
-                <a:solidFill>
-                  <a:srgbClr val="14161C"/>
-                </a:solidFill>
-                <a:latin typeface="Be Vietnam Pro" pitchFamily="34" charset="0"/>
-                <a:ea typeface="Be Vietnam Pro" pitchFamily="34" charset="-122"/>
-                <a:cs typeface="Be Vietnam Pro" pitchFamily="34" charset="-120"/>
-              </a:rPr>
-              <a:t> cho</a:t>
-            </a:r>
-            <a:r>
-              <a:rPr lang="en-US" sz="2250" dirty="0" spc="2" kern="0">
-                <a:solidFill>
-                  <a:srgbClr val="14161C"/>
-                </a:solidFill>
-                <a:latin typeface="Be Vietnam Pro" pitchFamily="34" charset="0"/>
-                <a:ea typeface="Be Vietnam Pro" pitchFamily="34" charset="-122"/>
-                <a:cs typeface="Be Vietnam Pro" pitchFamily="34" charset="-120"/>
-              </a:rPr>
-              <a:t> các</a:t>
-            </a:r>
-            <a:r>
-              <a:rPr lang="en-US" sz="2250" dirty="0" spc="4" kern="0">
-                <a:solidFill>
-                  <a:srgbClr val="14161C"/>
-                </a:solidFill>
-                <a:latin typeface="Be Vietnam Pro" pitchFamily="34" charset="0"/>
-                <a:ea typeface="Be Vietnam Pro" pitchFamily="34" charset="-122"/>
-                <a:cs typeface="Be Vietnam Pro" pitchFamily="34" charset="-120"/>
-              </a:rPr>
-              <a:t> API.</a:t>
+              <a:t> nào.</a:t>
             </a:r>
             <a:endParaRPr lang="en-US" sz="2250" dirty="0"/>
           </a:p>
@@ -10727,6 +10804,39 @@
               <a:buChar char="•"/>
             </a:pPr>
             <a:r>
+              <a:rPr lang="en-US" sz="2550" dirty="0" spc="-9" kern="0">
+                <a:solidFill>
+                  <a:srgbClr val="F3EEE3"/>
+                </a:solidFill>
+                <a:latin typeface="Be Vietnam Pro" pitchFamily="34" charset="0"/>
+                <a:ea typeface="Be Vietnam Pro" pitchFamily="34" charset="-122"/>
+                <a:cs typeface="Be Vietnam Pro" pitchFamily="34" charset="-120"/>
+              </a:rPr>
+              <a:t>JavaScript</a:t>
+            </a:r>
+            <a:r>
+              <a:rPr lang="en-US" sz="2550" dirty="0" spc="8" kern="0">
+                <a:solidFill>
+                  <a:srgbClr val="F3EEE3"/>
+                </a:solidFill>
+                <a:latin typeface="Be Vietnam Pro" pitchFamily="34" charset="0"/>
+                <a:ea typeface="Be Vietnam Pro" pitchFamily="34" charset="-122"/>
+                <a:cs typeface="Be Vietnam Pro" pitchFamily="34" charset="-120"/>
+              </a:rPr>
+              <a:t> dựa</a:t>
+            </a:r>
+            <a:r>
+              <a:rPr lang="en-US" sz="2550" dirty="0" spc="-19" kern="0">
+                <a:solidFill>
+                  <a:srgbClr val="F3EEE3"/>
+                </a:solidFill>
+                <a:latin typeface="Be Vietnam Pro" pitchFamily="34" charset="0"/>
+                <a:ea typeface="Be Vietnam Pro" pitchFamily="34" charset="-122"/>
+                <a:cs typeface="Be Vietnam Pro" pitchFamily="34" charset="-120"/>
+              </a:rPr>
+              <a:t> trên</a:t>
+            </a:r>
+            <a:r>
               <a:rPr lang="en-US" sz="2550" dirty="0" spc="-2" kern="0">
                 <a:solidFill>
                   <a:srgbClr val="F3EEE3"/>
@@ -10735,51 +10845,7 @@
                 <a:ea typeface="Be Vietnam Pro" pitchFamily="34" charset="-122"/>
                 <a:cs typeface="Be Vietnam Pro" pitchFamily="34" charset="-120"/>
               </a:rPr>
-              <a:t>ECMAScript</a:t>
-            </a:r>
-            <a:r>
-              <a:rPr lang="en-US" sz="2550" dirty="0" spc="1" kern="0">
-                <a:solidFill>
-                  <a:srgbClr val="F3EEE3"/>
-                </a:solidFill>
-                <a:latin typeface="Be Vietnam Pro" pitchFamily="34" charset="0"/>
-                <a:ea typeface="Be Vietnam Pro" pitchFamily="34" charset="-122"/>
-                <a:cs typeface="Be Vietnam Pro" pitchFamily="34" charset="-120"/>
-              </a:rPr>
-              <a:t> làm</a:t>
-            </a:r>
-            <a:r>
-              <a:rPr lang="en-US" sz="2550" dirty="0" spc="0" kern="0">
-                <a:solidFill>
-                  <a:srgbClr val="F3EEE3"/>
-                </a:solidFill>
-                <a:latin typeface="Be Vietnam Pro" pitchFamily="34" charset="0"/>
-                <a:ea typeface="Be Vietnam Pro" pitchFamily="34" charset="-122"/>
-                <a:cs typeface="Be Vietnam Pro" pitchFamily="34" charset="-120"/>
-              </a:rPr>
-              <a:t> nền cho nhiều</a:t>
-            </a:r>
-            <a:r>
-              <a:rPr lang="en-US" sz="2550" dirty="0" spc="-10" kern="0">
-                <a:solidFill>
-                  <a:srgbClr val="F3EEE3"/>
-                </a:solidFill>
-                <a:latin typeface="Be Vietnam Pro" pitchFamily="34" charset="0"/>
-                <a:ea typeface="Be Vietnam Pro" pitchFamily="34" charset="-122"/>
-                <a:cs typeface="Be Vietnam Pro" pitchFamily="34" charset="-120"/>
-              </a:rPr>
-              <a:t> ngôn</a:t>
-            </a:r>
-            <a:r>
-              <a:rPr lang="en-US" sz="2550" dirty="0" spc="-2" kern="0">
-                <a:solidFill>
-                  <a:srgbClr val="F3EEE3"/>
-                </a:solidFill>
-                <a:latin typeface="Be Vietnam Pro" pitchFamily="34" charset="0"/>
-                <a:ea typeface="Be Vietnam Pro" pitchFamily="34" charset="-122"/>
-                <a:cs typeface="Be Vietnam Pro" pitchFamily="34" charset="-120"/>
-              </a:rPr>
-              <a:t> ngữ</a:t>
+              <a:t> ECMAScript</a:t>
             </a:r>
             <a:endParaRPr lang="en-US" sz="2550" dirty="0"/>
           </a:p>
@@ -11564,37 +11630,15 @@
               <a:buNone/>
             </a:pPr>
             <a:r>
-              <a:rPr lang="en-US" sz="1950" b="1" dirty="0" spc="0" kern="0">
-                <a:solidFill>
-                  <a:srgbClr val="F3EEE3"/>
-                </a:solidFill>
-                <a:latin typeface="Be Vietnam Pro" pitchFamily="34" charset="0"/>
-                <a:ea typeface="Be Vietnam Pro" pitchFamily="34" charset="-122"/>
-                <a:cs typeface="Be Vietnam Pro" pitchFamily="34" charset="-120"/>
-              </a:rPr>
-              <a:t>Nhiều</a:t>
-            </a:r>
-            <a:r>
-              <a:rPr lang="en-US" sz="1950" b="1" dirty="0" spc="-8" kern="0">
-                <a:solidFill>
-                  <a:srgbClr val="F3EEE3"/>
-                </a:solidFill>
-                <a:latin typeface="Be Vietnam Pro" pitchFamily="34" charset="0"/>
-                <a:ea typeface="Be Vietnam Pro" pitchFamily="34" charset="-122"/>
-                <a:cs typeface="Be Vietnam Pro" pitchFamily="34" charset="-120"/>
-              </a:rPr>
-              <a:t> ngôn</a:t>
-            </a:r>
-            <a:r>
-              <a:rPr lang="en-US" sz="1950" b="1" dirty="0" spc="-4" kern="0">
-                <a:solidFill>
-                  <a:srgbClr val="F3EEE3"/>
-                </a:solidFill>
-                <a:latin typeface="Be Vietnam Pro" pitchFamily="34" charset="0"/>
-                <a:ea typeface="Be Vietnam Pro" pitchFamily="34" charset="-122"/>
-                <a:cs typeface="Be Vietnam Pro" pitchFamily="34" charset="-120"/>
-              </a:rPr>
-              <a:t> ngữ</a:t>
+              <a:rPr lang="en-US" sz="1950" b="1" dirty="0" spc="-9" kern="0">
+                <a:solidFill>
+                  <a:srgbClr val="F3EEE3"/>
+                </a:solidFill>
+                <a:latin typeface="Be Vietnam Pro" pitchFamily="34" charset="0"/>
+                <a:ea typeface="Be Vietnam Pro" pitchFamily="34" charset="-122"/>
+                <a:cs typeface="Be Vietnam Pro" pitchFamily="34" charset="-120"/>
+              </a:rPr>
+              <a:t>JavaScript</a:t>
             </a:r>
             <a:endParaRPr lang="en-US" sz="1950" dirty="0"/>
           </a:p>
@@ -11700,7 +11744,7 @@
               <a:t>JavaScript</a:t>
             </a:r>
             <a:r>
-              <a:rPr lang="en-US" sz="1950" dirty="0" spc="-1" kern="0">
+              <a:rPr lang="en-US" sz="1950" dirty="0" spc="8" kern="0">
                 <a:solidFill>
                   <a:srgbClr val="C4C8D6"/>
                 </a:solidFill>
@@ -11708,7 +11752,40 @@
                 <a:ea typeface="Be Vietnam Pro" pitchFamily="34" charset="-122"/>
                 <a:cs typeface="Be Vietnam Pro" pitchFamily="34" charset="-120"/>
               </a:rPr>
-              <a:t> là</a:t>
+              <a:t> dựa</a:t>
+            </a:r>
+            <a:r>
+              <a:rPr lang="en-US" sz="1950" dirty="0" spc="-16" kern="0">
+                <a:solidFill>
+                  <a:srgbClr val="C4C8D6"/>
+                </a:solidFill>
+                <a:latin typeface="Be Vietnam Pro" pitchFamily="34" charset="0"/>
+                <a:ea typeface="Be Vietnam Pro" pitchFamily="34" charset="-122"/>
+                <a:cs typeface="Be Vietnam Pro" pitchFamily="34" charset="-120"/>
+              </a:rPr>
+              <a:t> trên</a:t>
+            </a:r>
+            <a:r>
+              <a:rPr lang="en-US" sz="1950" dirty="0" spc="9" kern="0">
+                <a:solidFill>
+                  <a:srgbClr val="C4C8D6"/>
+                </a:solidFill>
+                <a:latin typeface="Be Vietnam Pro" pitchFamily="34" charset="0"/>
+                <a:ea typeface="Be Vietnam Pro" pitchFamily="34" charset="-122"/>
+                <a:cs typeface="Be Vietnam Pro" pitchFamily="34" charset="-120"/>
+              </a:rPr>
+              <a:t> đặc</a:t>
+            </a:r>
+            <a:r>
+              <a:rPr lang="en-US" sz="1950" dirty="0" spc="-15" kern="0">
+                <a:solidFill>
+                  <a:srgbClr val="C4C8D6"/>
+                </a:solidFill>
+                <a:latin typeface="Be Vietnam Pro" pitchFamily="34" charset="0"/>
+                <a:ea typeface="Be Vietnam Pro" pitchFamily="34" charset="-122"/>
+                <a:cs typeface="Be Vietnam Pro" pitchFamily="34" charset="-120"/>
+              </a:rPr>
+              <a:t> tả</a:t>
             </a:r>
             <a:r>
               <a:rPr lang="en-US" sz="1950" dirty="0" spc="-6" kern="0">
@@ -11719,51 +11796,7 @@
                 <a:ea typeface="Be Vietnam Pro" pitchFamily="34" charset="-122"/>
                 <a:cs typeface="Be Vietnam Pro" pitchFamily="34" charset="-120"/>
               </a:rPr>
-              <a:t> ngôn</a:t>
-            </a:r>
-            <a:r>
-              <a:rPr lang="en-US" sz="1950" dirty="0" spc="2" kern="0">
-                <a:solidFill>
-                  <a:srgbClr val="C4C8D6"/>
-                </a:solidFill>
-                <a:latin typeface="Be Vietnam Pro" pitchFamily="34" charset="0"/>
-                <a:ea typeface="Be Vietnam Pro" pitchFamily="34" charset="-122"/>
-                <a:cs typeface="Be Vietnam Pro" pitchFamily="34" charset="-120"/>
-              </a:rPr>
-              <a:t> ngữ</a:t>
-            </a:r>
-            <a:r>
-              <a:rPr lang="en-US" sz="1950" dirty="0" spc="0" kern="0">
-                <a:solidFill>
-                  <a:srgbClr val="C4C8D6"/>
-                </a:solidFill>
-                <a:latin typeface="Be Vietnam Pro" pitchFamily="34" charset="0"/>
-                <a:ea typeface="Be Vietnam Pro" pitchFamily="34" charset="-122"/>
-                <a:cs typeface="Be Vietnam Pro" pitchFamily="34" charset="-120"/>
-              </a:rPr>
-              <a:t> nổi</a:t>
-            </a:r>
-            <a:r>
-              <a:rPr lang="en-US" sz="1950" dirty="0" spc="1" kern="0">
-                <a:solidFill>
-                  <a:srgbClr val="C4C8D6"/>
-                </a:solidFill>
-                <a:latin typeface="Be Vietnam Pro" pitchFamily="34" charset="0"/>
-                <a:ea typeface="Be Vietnam Pro" pitchFamily="34" charset="-122"/>
-                <a:cs typeface="Be Vietnam Pro" pitchFamily="34" charset="-120"/>
-              </a:rPr>
-              <a:t> tiếng</a:t>
-            </a:r>
-            <a:r>
-              <a:rPr lang="en-US" sz="1950" dirty="0" spc="-7" kern="0">
-                <a:solidFill>
-                  <a:srgbClr val="C4C8D6"/>
-                </a:solidFill>
-                <a:latin typeface="Be Vietnam Pro" pitchFamily="34" charset="0"/>
-                <a:ea typeface="Be Vietnam Pro" pitchFamily="34" charset="-122"/>
-                <a:cs typeface="Be Vietnam Pro" pitchFamily="34" charset="-120"/>
-              </a:rPr>
-              <a:t> nhất.</a:t>
+              <a:t> này.</a:t>
             </a:r>
             <a:endParaRPr lang="en-US" sz="1950" dirty="0"/>
           </a:p>
@@ -12403,7 +12436,7 @@
               <a:buNone/>
             </a:pPr>
             <a:r>
-              <a:rPr lang="en-US" sz="3300" b="1" dirty="0" spc="-1" kern="0">
+              <a:rPr lang="en-US" sz="3300" b="1" dirty="0" spc="-14" kern="0">
                 <a:solidFill>
                   <a:srgbClr val="E8472B"/>
                 </a:solidFill>
@@ -12411,10 +12444,10 @@
                 <a:ea typeface="Be Vietnam Pro" pitchFamily="34" charset="-122"/>
                 <a:cs typeface="Be Vietnam Pro" pitchFamily="34" charset="-120"/>
               </a:rPr>
-              <a:t>Ba</a:t>
-            </a:r>
-            <a:r>
-              <a:rPr lang="en-US" sz="3300" b="1" dirty="0" spc="1" kern="0">
+              <a:t>Bảy</a:t>
+            </a:r>
+            <a:r>
+              <a:rPr lang="en-US" sz="3300" b="1" dirty="0" spc="0" kern="0">
                 <a:solidFill>
                   <a:srgbClr val="E8472B"/>
                 </a:solidFill>
@@ -12425,7 +12458,7 @@
               <a:t> chuẩn</a:t>
             </a:r>
             <a:r>
-              <a:rPr lang="en-US" sz="3300" b="1" dirty="0" spc="3" kern="0">
+              <a:rPr lang="en-US" sz="3300" b="1" dirty="0" spc="-8" kern="0">
                 <a:solidFill>
                   <a:srgbClr val="E8472B"/>
                 </a:solidFill>
@@ -12433,7 +12466,18 @@
                 <a:ea typeface="Be Vietnam Pro" pitchFamily="34" charset="-122"/>
                 <a:cs typeface="Be Vietnam Pro" pitchFamily="34" charset="-120"/>
               </a:rPr>
-              <a:t> đối</a:t>
+              <a:t> có</a:t>
+            </a:r>
+            <a:r>
+              <a:rPr lang="en-US" sz="3300" b="1" dirty="0" spc="-5" kern="0">
+                <a:solidFill>
+                  <a:srgbClr val="E8472B"/>
+                </a:solidFill>
+                <a:latin typeface="Be Vietnam Pro" pitchFamily="34" charset="0"/>
+                <a:ea typeface="Be Vietnam Pro" pitchFamily="34" charset="-122"/>
+                <a:cs typeface="Be Vietnam Pro" pitchFamily="34" charset="-120"/>
+              </a:rPr>
+              <a:t> tài</a:t>
             </a:r>
             <a:r>
               <a:rPr lang="en-US" sz="3300" b="1" dirty="0" spc="0" kern="0">
@@ -12444,7 +12488,18 @@
                 <a:ea typeface="Be Vietnam Pro" pitchFamily="34" charset="-122"/>
                 <a:cs typeface="Be Vietnam Pro" pitchFamily="34" charset="-120"/>
               </a:rPr>
-              <a:t> chiếu</a:t>
+              <a:t> liệu</a:t>
+            </a:r>
+            <a:r>
+              <a:rPr lang="en-US" sz="3300" b="1" dirty="0" spc="-12" kern="0">
+                <a:solidFill>
+                  <a:srgbClr val="E8472B"/>
+                </a:solidFill>
+                <a:latin typeface="Be Vietnam Pro" pitchFamily="34" charset="0"/>
+                <a:ea typeface="Be Vietnam Pro" pitchFamily="34" charset="-122"/>
+                <a:cs typeface="Be Vietnam Pro" pitchFamily="34" charset="-120"/>
+              </a:rPr>
+              <a:t> gốc</a:t>
             </a:r>
             <a:endParaRPr lang="en-US" sz="3300" dirty="0"/>
           </a:p>
@@ -12500,15 +12555,15 @@
               <a:t> từ</a:t>
             </a:r>
             <a:r>
-              <a:rPr lang="en-US" sz="2850" dirty="0" spc="1" kern="0">
-                <a:solidFill>
-                  <a:srgbClr val="14161C"/>
-                </a:solidFill>
-                <a:latin typeface="Be Vietnam Pro" pitchFamily="34" charset="0"/>
-                <a:ea typeface="Be Vietnam Pro" pitchFamily="34" charset="-122"/>
-                <a:cs typeface="Be Vietnam Pro" pitchFamily="34" charset="-120"/>
-              </a:rPr>
-              <a:t> kho</a:t>
+              <a:rPr lang="en-US" sz="2850" dirty="0" spc="3" kern="0">
+                <a:solidFill>
+                  <a:srgbClr val="14161C"/>
+                </a:solidFill>
+                <a:latin typeface="Be Vietnam Pro" pitchFamily="34" charset="0"/>
+                <a:ea typeface="Be Vietnam Pro" pitchFamily="34" charset="-122"/>
+                <a:cs typeface="Be Vietnam Pro" pitchFamily="34" charset="-120"/>
+              </a:rPr>
+              <a:t> MDN,</a:t>
             </a:r>
             <a:r>
               <a:rPr lang="en-US" sz="2850" dirty="0" spc="0" kern="0">
@@ -12519,18 +12574,7 @@
                 <a:ea typeface="Be Vietnam Pro" pitchFamily="34" charset="-122"/>
                 <a:cs typeface="Be Vietnam Pro" pitchFamily="34" charset="-120"/>
               </a:rPr>
-              <a:t> mã</a:t>
-            </a:r>
-            <a:r>
-              <a:rPr lang="en-US" sz="2850" dirty="0" spc="1" kern="0">
-                <a:solidFill>
-                  <a:srgbClr val="14161C"/>
-                </a:solidFill>
-                <a:latin typeface="Be Vietnam Pro" pitchFamily="34" charset="0"/>
-                <a:ea typeface="Be Vietnam Pro" pitchFamily="34" charset="-122"/>
-                <a:cs typeface="Be Vietnam Pro" pitchFamily="34" charset="-120"/>
-              </a:rPr>
-              <a:t> của</a:t>
+              <a:t> kho mã</a:t>
             </a:r>
             <a:r>
               <a:rPr lang="en-US" sz="2850" dirty="0" spc="-3" kern="0">
@@ -12588,15 +12632,37 @@
               <a:t> và</a:t>
             </a:r>
             <a:r>
-              <a:rPr lang="en-US" sz="2850" dirty="0" spc="-14" kern="0">
-                <a:solidFill>
-                  <a:srgbClr val="14161C"/>
-                </a:solidFill>
-                <a:latin typeface="Be Vietnam Pro" pitchFamily="34" charset="0"/>
-                <a:ea typeface="Be Vietnam Pro" pitchFamily="34" charset="-122"/>
-                <a:cs typeface="Be Vietnam Pro" pitchFamily="34" charset="-120"/>
-              </a:rPr>
-              <a:t> tài</a:t>
+              <a:rPr lang="en-US" sz="2850" dirty="0" spc="-5" kern="0">
+                <a:solidFill>
+                  <a:srgbClr val="14161C"/>
+                </a:solidFill>
+                <a:latin typeface="Be Vietnam Pro" pitchFamily="34" charset="0"/>
+                <a:ea typeface="Be Vietnam Pro" pitchFamily="34" charset="-122"/>
+                <a:cs typeface="Be Vietnam Pro" pitchFamily="34" charset="-120"/>
+              </a:rPr>
+              <a:t> bản</a:t>
+            </a:r>
+            <a:r>
+              <a:rPr lang="en-US" sz="2850" dirty="0" spc="-1" kern="0">
+                <a:solidFill>
+                  <a:srgbClr val="14161C"/>
+                </a:solidFill>
+                <a:latin typeface="Be Vietnam Pro" pitchFamily="34" charset="0"/>
+                <a:ea typeface="Be Vietnam Pro" pitchFamily="34" charset="-122"/>
+                <a:cs typeface="Be Vietnam Pro" pitchFamily="34" charset="-120"/>
+              </a:rPr>
+              <a:t> nháp</a:t>
+            </a:r>
+            <a:r>
+              <a:rPr lang="en-US" sz="2850" dirty="0" spc="-28" kern="0">
+                <a:solidFill>
+                  <a:srgbClr val="14161C"/>
+                </a:solidFill>
+                <a:latin typeface="Be Vietnam Pro" pitchFamily="34" charset="0"/>
+                <a:ea typeface="Be Vietnam Pro" pitchFamily="34" charset="-122"/>
+                <a:cs typeface="Be Vietnam Pro" pitchFamily="34" charset="-120"/>
+              </a:rPr>
+              <a:t> OAuth</a:t>
             </a:r>
             <a:r>
               <a:rPr lang="en-US" sz="2850" dirty="0" spc="2" kern="0">
@@ -12607,7 +12673,7 @@
                 <a:ea typeface="Be Vietnam Pro" pitchFamily="34" charset="-122"/>
                 <a:cs typeface="Be Vietnam Pro" pitchFamily="34" charset="-120"/>
               </a:rPr>
-              <a:t> liệu MDN.</a:t>
+              <a:t> 2.1.</a:t>
             </a:r>
             <a:endParaRPr lang="en-US" sz="2850" dirty="0"/>
           </a:p>
@@ -12728,26 +12794,26 @@
               <a:buNone/>
             </a:pPr>
             <a:r>
-              <a:rPr lang="en-US" sz="2250" b="1" dirty="0" spc="-1" kern="0">
-                <a:solidFill>
-                  <a:srgbClr val="F3EEE3"/>
-                </a:solidFill>
-                <a:latin typeface="Be Vietnam Pro" pitchFamily="34" charset="0"/>
-                <a:ea typeface="Be Vietnam Pro" pitchFamily="34" charset="-122"/>
-                <a:cs typeface="Be Vietnam Pro" pitchFamily="34" charset="-120"/>
-              </a:rPr>
-              <a:t>HTML</a:t>
-            </a:r>
-            <a:r>
-              <a:rPr lang="en-US" sz="2250" b="1" dirty="0" spc="-8" kern="0">
-                <a:solidFill>
-                  <a:srgbClr val="F3EEE3"/>
-                </a:solidFill>
-                <a:latin typeface="Be Vietnam Pro" pitchFamily="34" charset="0"/>
-                <a:ea typeface="Be Vietnam Pro" pitchFamily="34" charset="-122"/>
-                <a:cs typeface="Be Vietnam Pro" pitchFamily="34" charset="-120"/>
-              </a:rPr>
-              <a:t> Standard</a:t>
+              <a:rPr lang="en-US" sz="2250" b="1" dirty="0" spc="-23" kern="0">
+                <a:solidFill>
+                  <a:srgbClr val="F3EEE3"/>
+                </a:solidFill>
+                <a:latin typeface="Be Vietnam Pro" pitchFamily="34" charset="0"/>
+                <a:ea typeface="Be Vietnam Pro" pitchFamily="34" charset="-122"/>
+                <a:cs typeface="Be Vietnam Pro" pitchFamily="34" charset="-120"/>
+              </a:rPr>
+              <a:t>OAuth</a:t>
+            </a:r>
+            <a:r>
+              <a:rPr lang="en-US" sz="2250" b="1" dirty="0" spc="0" kern="0">
+                <a:solidFill>
+                  <a:srgbClr val="F3EEE3"/>
+                </a:solidFill>
+                <a:latin typeface="Be Vietnam Pro" pitchFamily="34" charset="0"/>
+                <a:ea typeface="Be Vietnam Pro" pitchFamily="34" charset="-122"/>
+                <a:cs typeface="Be Vietnam Pro" pitchFamily="34" charset="-120"/>
+              </a:rPr>
+              <a:t> 2.1</a:t>
             </a:r>
             <a:endParaRPr lang="en-US" sz="2250" dirty="0"/>
           </a:p>
@@ -12858,6 +12924,39 @@
               <a:buChar char="•"/>
             </a:pPr>
             <a:r>
+              <a:rPr lang="en-US" sz="2550" dirty="0" spc="-1" kern="0">
+                <a:solidFill>
+                  <a:srgbClr val="14161C"/>
+                </a:solidFill>
+                <a:latin typeface="Be Vietnam Pro" pitchFamily="34" charset="0"/>
+                <a:ea typeface="Be Vietnam Pro" pitchFamily="34" charset="-122"/>
+                <a:cs typeface="Be Vietnam Pro" pitchFamily="34" charset="-120"/>
+              </a:rPr>
+              <a:t>OpenAPI: API</a:t>
+            </a:r>
+            <a:r>
+              <a:rPr lang="en-US" sz="2550" dirty="0" spc="-7" kern="0">
+                <a:solidFill>
+                  <a:srgbClr val="14161C"/>
+                </a:solidFill>
+                <a:latin typeface="Be Vietnam Pro" pitchFamily="34" charset="0"/>
+                <a:ea typeface="Be Vietnam Pro" pitchFamily="34" charset="-122"/>
+                <a:cs typeface="Be Vietnam Pro" pitchFamily="34" charset="-120"/>
+              </a:rPr>
+              <a:t> chạy</a:t>
+            </a:r>
+            <a:r>
+              <a:rPr lang="en-US" sz="2550" dirty="0" spc="-20" kern="0">
+                <a:solidFill>
+                  <a:srgbClr val="14161C"/>
+                </a:solidFill>
+                <a:latin typeface="Be Vietnam Pro" pitchFamily="34" charset="0"/>
+                <a:ea typeface="Be Vietnam Pro" pitchFamily="34" charset="-122"/>
+                <a:cs typeface="Be Vietnam Pro" pitchFamily="34" charset="-120"/>
+              </a:rPr>
+              <a:t> trên</a:t>
+            </a:r>
+            <a:r>
               <a:rPr lang="en-US" sz="2550" dirty="0" spc="-2" kern="0">
                 <a:solidFill>
                   <a:srgbClr val="14161C"/>
@@ -12866,62 +12965,7 @@
                 <a:ea typeface="Be Vietnam Pro" pitchFamily="34" charset="-122"/>
                 <a:cs typeface="Be Vietnam Pro" pitchFamily="34" charset="-120"/>
               </a:rPr>
-              <a:t>OpenAPI</a:t>
-            </a:r>
-            <a:r>
-              <a:rPr lang="en-US" sz="2550" dirty="0" spc="-21" kern="0">
-                <a:solidFill>
-                  <a:srgbClr val="14161C"/>
-                </a:solidFill>
-                <a:latin typeface="Be Vietnam Pro" pitchFamily="34" charset="0"/>
-                <a:ea typeface="Be Vietnam Pro" pitchFamily="34" charset="-122"/>
-                <a:cs typeface="Be Vietnam Pro" pitchFamily="34" charset="-120"/>
-              </a:rPr>
-              <a:t> rộng</a:t>
-            </a:r>
-            <a:r>
-              <a:rPr lang="en-US" sz="2550" dirty="0" spc="-1" kern="0">
-                <a:solidFill>
-                  <a:srgbClr val="14161C"/>
-                </a:solidFill>
-                <a:latin typeface="Be Vietnam Pro" pitchFamily="34" charset="0"/>
-                <a:ea typeface="Be Vietnam Pro" pitchFamily="34" charset="-122"/>
-                <a:cs typeface="Be Vietnam Pro" pitchFamily="34" charset="-120"/>
-              </a:rPr>
-              <a:t> hơn chữ</a:t>
-            </a:r>
-            <a:r>
-              <a:rPr lang="en-US" sz="2550" dirty="0" spc="-10" kern="0">
-                <a:solidFill>
-                  <a:srgbClr val="14161C"/>
-                </a:solidFill>
-                <a:latin typeface="Be Vietnam Pro" pitchFamily="34" charset="0"/>
-                <a:ea typeface="Be Vietnam Pro" pitchFamily="34" charset="-122"/>
-                <a:cs typeface="Be Vietnam Pro" pitchFamily="34" charset="-120"/>
-              </a:rPr>
-              <a:t> RESTful</a:t>
-            </a:r>
-            <a:r>
-              <a:rPr lang="en-US" sz="2550" dirty="0" spc="-1" kern="0">
-                <a:solidFill>
-                  <a:srgbClr val="14161C"/>
-                </a:solidFill>
-                <a:latin typeface="Be Vietnam Pro" pitchFamily="34" charset="0"/>
-                <a:ea typeface="Be Vietnam Pro" pitchFamily="34" charset="-122"/>
-                <a:cs typeface="Be Vietnam Pro" pitchFamily="34" charset="-120"/>
-              </a:rPr>
-              <a:t> của</a:t>
-            </a:r>
-            <a:r>
-              <a:rPr lang="en-US" sz="2550" dirty="0" spc="1" kern="0">
-                <a:solidFill>
-                  <a:srgbClr val="14161C"/>
-                </a:solidFill>
-                <a:latin typeface="Be Vietnam Pro" pitchFamily="34" charset="0"/>
-                <a:ea typeface="Be Vietnam Pro" pitchFamily="34" charset="-122"/>
-                <a:cs typeface="Be Vietnam Pro" pitchFamily="34" charset="-120"/>
-              </a:rPr>
-              <a:t> nguồn</a:t>
+              <a:t> HTTP</a:t>
             </a:r>
             <a:endParaRPr lang="en-US" sz="2550" dirty="0"/>
           </a:p>
@@ -13004,15 +13048,15 @@
               <a:buChar char="•"/>
             </a:pPr>
             <a:r>
-              <a:rPr lang="en-US" sz="2550" dirty="0" spc="-2" kern="0">
-                <a:solidFill>
-                  <a:srgbClr val="14161C"/>
-                </a:solidFill>
-                <a:latin typeface="Be Vietnam Pro" pitchFamily="34" charset="0"/>
-                <a:ea typeface="Be Vietnam Pro" pitchFamily="34" charset="-122"/>
-                <a:cs typeface="Be Vietnam Pro" pitchFamily="34" charset="-120"/>
-              </a:rPr>
-              <a:t>Kho</a:t>
+              <a:rPr lang="en-US" sz="2550" dirty="0" spc="-24" kern="0">
+                <a:solidFill>
+                  <a:srgbClr val="14161C"/>
+                </a:solidFill>
+                <a:latin typeface="Be Vietnam Pro" pitchFamily="34" charset="0"/>
+                <a:ea typeface="Be Vietnam Pro" pitchFamily="34" charset="-122"/>
+                <a:cs typeface="Be Vietnam Pro" pitchFamily="34" charset="-120"/>
+              </a:rPr>
+              <a:t>OAuth:</a:t>
             </a:r>
             <a:r>
               <a:rPr lang="en-US" sz="2550" dirty="0" spc="1" kern="0">
@@ -13026,37 +13070,15 @@
               <a:t> mã</a:t>
             </a:r>
             <a:r>
-              <a:rPr lang="en-US" sz="2550" dirty="0" spc="-1" kern="0">
-                <a:solidFill>
-                  <a:srgbClr val="14161C"/>
-                </a:solidFill>
-                <a:latin typeface="Be Vietnam Pro" pitchFamily="34" charset="0"/>
-                <a:ea typeface="Be Vietnam Pro" pitchFamily="34" charset="-122"/>
-                <a:cs typeface="Be Vietnam Pro" pitchFamily="34" charset="-120"/>
-              </a:rPr>
-              <a:t> HTML</a:t>
-            </a:r>
-            <a:r>
-              <a:rPr lang="en-US" sz="2550" dirty="0" spc="-18" kern="0">
-                <a:solidFill>
-                  <a:srgbClr val="14161C"/>
-                </a:solidFill>
-                <a:latin typeface="Be Vietnam Pro" pitchFamily="34" charset="0"/>
-                <a:ea typeface="Be Vietnam Pro" pitchFamily="34" charset="-122"/>
-                <a:cs typeface="Be Vietnam Pro" pitchFamily="34" charset="-120"/>
-              </a:rPr>
-              <a:t> Standard</a:t>
-            </a:r>
-            <a:r>
-              <a:rPr lang="en-US" sz="2550" dirty="0" spc="7" kern="0">
-                <a:solidFill>
-                  <a:srgbClr val="14161C"/>
-                </a:solidFill>
-                <a:latin typeface="Be Vietnam Pro" pitchFamily="34" charset="0"/>
-                <a:ea typeface="Be Vietnam Pro" pitchFamily="34" charset="-122"/>
-                <a:cs typeface="Be Vietnam Pro" pitchFamily="34" charset="-120"/>
-              </a:rPr>
-              <a:t> chứa</a:t>
+              <a:rPr lang="en-US" sz="2550" dirty="0" spc="2" kern="0">
+                <a:solidFill>
+                  <a:srgbClr val="14161C"/>
+                </a:solidFill>
+                <a:latin typeface="Be Vietnam Pro" pitchFamily="34" charset="0"/>
+                <a:ea typeface="Be Vietnam Pro" pitchFamily="34" charset="-122"/>
+                <a:cs typeface="Be Vietnam Pro" pitchFamily="34" charset="-120"/>
+              </a:rPr>
+              <a:t> truy</a:t>
             </a:r>
             <a:r>
               <a:rPr lang="en-US" sz="2550" dirty="0" spc="0" kern="0">
@@ -13067,18 +13089,40 @@
                 <a:ea typeface="Be Vietnam Pro" pitchFamily="34" charset="-122"/>
                 <a:cs typeface="Be Vietnam Pro" pitchFamily="34" charset="-120"/>
               </a:rPr>
-              <a:t> chính</a:t>
-            </a:r>
-            <a:r>
-              <a:rPr lang="en-US" sz="2550" dirty="0" spc="1" kern="0">
-                <a:solidFill>
-                  <a:srgbClr val="14161C"/>
-                </a:solidFill>
-                <a:latin typeface="Be Vietnam Pro" pitchFamily="34" charset="0"/>
-                <a:ea typeface="Be Vietnam Pro" pitchFamily="34" charset="-122"/>
-                <a:cs typeface="Be Vietnam Pro" pitchFamily="34" charset="-120"/>
-              </a:rPr>
-              <a:t> chuẩn</a:t>
+              <a:t> cập</a:t>
+            </a:r>
+            <a:r>
+              <a:rPr lang="en-US" sz="2550" dirty="0" spc="-7" kern="0">
+                <a:solidFill>
+                  <a:srgbClr val="14161C"/>
+                </a:solidFill>
+                <a:latin typeface="Be Vietnam Pro" pitchFamily="34" charset="0"/>
+                <a:ea typeface="Be Vietnam Pro" pitchFamily="34" charset="-122"/>
+                <a:cs typeface="Be Vietnam Pro" pitchFamily="34" charset="-120"/>
+              </a:rPr>
+              <a:t> thay</a:t>
+            </a:r>
+            <a:r>
+              <a:rPr lang="en-US" sz="2550" dirty="0" spc="-11" kern="0">
+                <a:solidFill>
+                  <a:srgbClr val="14161C"/>
+                </a:solidFill>
+                <a:latin typeface="Be Vietnam Pro" pitchFamily="34" charset="0"/>
+                <a:ea typeface="Be Vietnam Pro" pitchFamily="34" charset="-122"/>
+                <a:cs typeface="Be Vietnam Pro" pitchFamily="34" charset="-120"/>
+              </a:rPr>
+              <a:t> mật</a:t>
+            </a:r>
+            <a:r>
+              <a:rPr lang="en-US" sz="2550" dirty="0" spc="2" kern="0">
+                <a:solidFill>
+                  <a:srgbClr val="14161C"/>
+                </a:solidFill>
+                <a:latin typeface="Be Vietnam Pro" pitchFamily="34" charset="0"/>
+                <a:ea typeface="Be Vietnam Pro" pitchFamily="34" charset="-122"/>
+                <a:cs typeface="Be Vietnam Pro" pitchFamily="34" charset="-120"/>
+              </a:rPr>
+              <a:t> khẩu</a:t>
             </a:r>
             <a:endParaRPr lang="en-US" sz="2550" dirty="0"/>
           </a:p>
@@ -13348,17 +13392,6 @@
               <a:t> HTTP,</a:t>
             </a:r>
             <a:r>
-              <a:rPr lang="en-US" sz="2250" dirty="0" spc="-18" kern="0">
-                <a:solidFill>
-                  <a:srgbClr val="14161C"/>
-                </a:solidFill>
-                <a:latin typeface="Be Vietnam Pro" pitchFamily="34" charset="0"/>
-                <a:ea typeface="Be Vietnam Pro" pitchFamily="34" charset="-122"/>
-                <a:cs typeface="Be Vietnam Pro" pitchFamily="34" charset="-120"/>
-              </a:rPr>
-              <a:t> rộng</a:t>
-            </a:r>
-            <a:r>
               <a:rPr lang="en-US" sz="2250" dirty="0" spc="1" kern="0">
                 <a:solidFill>
                   <a:srgbClr val="14161C"/>
@@ -13367,7 +13400,7 @@
                 <a:ea typeface="Be Vietnam Pro" pitchFamily="34" charset="-122"/>
                 <a:cs typeface="Be Vietnam Pro" pitchFamily="34" charset="-120"/>
               </a:rPr>
-              <a:t> hơn</a:t>
+              <a:t> không</a:t>
             </a:r>
             <a:r>
               <a:rPr lang="en-US" sz="2250" dirty="0" spc="3" kern="0">
@@ -13378,7 +13411,18 @@
                 <a:ea typeface="Be Vietnam Pro" pitchFamily="34" charset="-122"/>
                 <a:cs typeface="Be Vietnam Pro" pitchFamily="34" charset="-120"/>
               </a:rPr>
-              <a:t> chữ</a:t>
+              <a:t> phụ</a:t>
+            </a:r>
+            <a:r>
+              <a:rPr lang="en-US" sz="2250" dirty="0" spc="0" kern="0">
+                <a:solidFill>
+                  <a:srgbClr val="14161C"/>
+                </a:solidFill>
+                <a:latin typeface="Be Vietnam Pro" pitchFamily="34" charset="0"/>
+                <a:ea typeface="Be Vietnam Pro" pitchFamily="34" charset="-122"/>
+                <a:cs typeface="Be Vietnam Pro" pitchFamily="34" charset="-120"/>
+              </a:rPr>
+              <a:t> thuộc</a:t>
             </a:r>
             <a:r>
               <a:rPr lang="en-US" sz="2250" dirty="0" spc="-7" kern="0">
@@ -13389,18 +13433,18 @@
                 <a:ea typeface="Be Vietnam Pro" pitchFamily="34" charset="-122"/>
                 <a:cs typeface="Be Vietnam Pro" pitchFamily="34" charset="-120"/>
               </a:rPr>
-              <a:t> RESTful</a:t>
-            </a:r>
-            <a:r>
-              <a:rPr lang="en-US" sz="2250" dirty="0" spc="2" kern="0">
-                <a:solidFill>
-                  <a:srgbClr val="14161C"/>
-                </a:solidFill>
-                <a:latin typeface="Be Vietnam Pro" pitchFamily="34" charset="0"/>
-                <a:ea typeface="Be Vietnam Pro" pitchFamily="34" charset="-122"/>
-                <a:cs typeface="Be Vietnam Pro" pitchFamily="34" charset="-120"/>
-              </a:rPr>
-              <a:t> của nguồn.</a:t>
+              <a:t> ngôn</a:t>
+            </a:r>
+            <a:r>
+              <a:rPr lang="en-US" sz="2250" dirty="0" spc="3" kern="0">
+                <a:solidFill>
+                  <a:srgbClr val="14161C"/>
+                </a:solidFill>
+                <a:latin typeface="Be Vietnam Pro" pitchFamily="34" charset="0"/>
+                <a:ea typeface="Be Vietnam Pro" pitchFamily="34" charset="-122"/>
+                <a:cs typeface="Be Vietnam Pro" pitchFamily="34" charset="-120"/>
+              </a:rPr>
+              <a:t> ngữ.</a:t>
             </a:r>
             <a:endParaRPr lang="en-US" sz="2250" dirty="0"/>
           </a:p>
@@ -13802,7 +13846,7 @@
               <a:buNone/>
             </a:pPr>
             <a:r>
-              <a:rPr lang="en-US" sz="3600" dirty="0" spc="1" kern="0">
+              <a:rPr lang="en-US" sz="3600" dirty="0" spc="-44" kern="0">
                 <a:solidFill>
                   <a:srgbClr val="1F3FD1"/>
                 </a:solidFill>
@@ -13810,10 +13854,10 @@
                 <a:ea typeface="Bricolage Grotesque ExtraBold" pitchFamily="34" charset="-122"/>
                 <a:cs typeface="Bricolage Grotesque ExtraBold" pitchFamily="34" charset="-120"/>
               </a:rPr>
-              <a:t>HTML</a:t>
-            </a:r>
-            <a:r>
-              <a:rPr lang="en-US" sz="3600" dirty="0" spc="-1" kern="0">
+              <a:t>OAuth</a:t>
+            </a:r>
+            <a:r>
+              <a:rPr lang="en-US" sz="3600" dirty="0" spc="-27" kern="0">
                 <a:solidFill>
                   <a:srgbClr val="1F3FD1"/>
                 </a:solidFill>
@@ -13821,7 +13865,7 @@
                 <a:ea typeface="Bricolage Grotesque ExtraBold" pitchFamily="34" charset="-122"/>
                 <a:cs typeface="Bricolage Grotesque ExtraBold" pitchFamily="34" charset="-120"/>
               </a:rPr>
-              <a:t> Standard</a:t>
+              <a:t> 2.1</a:t>
             </a:r>
             <a:endParaRPr lang="en-US" sz="3600" dirty="0"/>
           </a:p>
@@ -13852,7 +13896,7 @@
               <a:buNone/>
             </a:pPr>
             <a:r>
-              <a:rPr lang="en-US" sz="1950" b="1" spc="150" kern="0" dirty="0">
+              <a:rPr lang="en-US" sz="1950" b="1" spc="142" kern="0" dirty="0">
                 <a:solidFill>
                   <a:srgbClr val="1F3FD1"/>
                 </a:solidFill>
@@ -13860,7 +13904,18 @@
                 <a:ea typeface="Be Vietnam Pro" pitchFamily="34" charset="-122"/>
                 <a:cs typeface="Be Vietnam Pro" pitchFamily="34" charset="-120"/>
               </a:rPr>
-              <a:t>README</a:t>
+              <a:t>BẢN</a:t>
+            </a:r>
+            <a:r>
+              <a:rPr lang="en-US" sz="1950" b="1" spc="149" kern="0" dirty="0">
+                <a:solidFill>
+                  <a:srgbClr val="1F3FD1"/>
+                </a:solidFill>
+                <a:latin typeface="Be Vietnam Pro" pitchFamily="34" charset="0"/>
+                <a:ea typeface="Be Vietnam Pro" pitchFamily="34" charset="-122"/>
+                <a:cs typeface="Be Vietnam Pro" pitchFamily="34" charset="-120"/>
+              </a:rPr>
+              <a:t> NHÁP</a:t>
             </a:r>
             <a:endParaRPr lang="en-US" sz="1950" dirty="0"/>
           </a:p>
@@ -13894,15 +13949,59 @@
               <a:buNone/>
             </a:pPr>
             <a:r>
-              <a:rPr lang="en-US" sz="2250" dirty="0" spc="-1" kern="0">
-                <a:solidFill>
-                  <a:srgbClr val="14161C"/>
-                </a:solidFill>
-                <a:latin typeface="Be Vietnam Pro" pitchFamily="34" charset="0"/>
-                <a:ea typeface="Be Vietnam Pro" pitchFamily="34" charset="-122"/>
-                <a:cs typeface="Be Vietnam Pro" pitchFamily="34" charset="-120"/>
-              </a:rPr>
-              <a:t>Kho</a:t>
+              <a:rPr lang="en-US" sz="2250" dirty="0" spc="-6" kern="0">
+                <a:solidFill>
+                  <a:srgbClr val="14161C"/>
+                </a:solidFill>
+                <a:latin typeface="Be Vietnam Pro" pitchFamily="34" charset="0"/>
+                <a:ea typeface="Be Vietnam Pro" pitchFamily="34" charset="-122"/>
+                <a:cs typeface="Be Vietnam Pro" pitchFamily="34" charset="-120"/>
+              </a:rPr>
+              <a:t>Mã</a:t>
+            </a:r>
+            <a:r>
+              <a:rPr lang="en-US" sz="2250" dirty="0" spc="0" kern="0">
+                <a:solidFill>
+                  <a:srgbClr val="14161C"/>
+                </a:solidFill>
+                <a:latin typeface="Be Vietnam Pro" pitchFamily="34" charset="0"/>
+                <a:ea typeface="Be Vietnam Pro" pitchFamily="34" charset="-122"/>
+                <a:cs typeface="Be Vietnam Pro" pitchFamily="34" charset="-120"/>
+              </a:rPr>
+              <a:t> truy</a:t>
+            </a:r>
+            <a:r>
+              <a:rPr lang="en-US" sz="2250" dirty="0" spc="2" kern="0">
+                <a:solidFill>
+                  <a:srgbClr val="14161C"/>
+                </a:solidFill>
+                <a:latin typeface="Be Vietnam Pro" pitchFamily="34" charset="0"/>
+                <a:ea typeface="Be Vietnam Pro" pitchFamily="34" charset="-122"/>
+                <a:cs typeface="Be Vietnam Pro" pitchFamily="34" charset="-120"/>
+              </a:rPr>
+              <a:t> cập</a:t>
+            </a:r>
+            <a:r>
+              <a:rPr lang="en-US" sz="2250" dirty="0" spc="4" kern="0">
+                <a:solidFill>
+                  <a:srgbClr val="14161C"/>
+                </a:solidFill>
+                <a:latin typeface="Be Vietnam Pro" pitchFamily="34" charset="0"/>
+                <a:ea typeface="Be Vietnam Pro" pitchFamily="34" charset="-122"/>
+                <a:cs typeface="Be Vietnam Pro" pitchFamily="34" charset="-120"/>
+              </a:rPr>
+              <a:t> có</a:t>
+            </a:r>
+            <a:r>
+              <a:rPr lang="en-US" sz="2250" dirty="0" spc="0" kern="0">
+                <a:solidFill>
+                  <a:srgbClr val="14161C"/>
+                </a:solidFill>
+                <a:latin typeface="Be Vietnam Pro" pitchFamily="34" charset="0"/>
+                <a:ea typeface="Be Vietnam Pro" pitchFamily="34" charset="-122"/>
+                <a:cs typeface="Be Vietnam Pro" pitchFamily="34" charset="-120"/>
+              </a:rPr>
+              <a:t> phạm</a:t>
             </a:r>
             <a:r>
               <a:rPr lang="en-US" sz="2250" dirty="0" spc="-2" kern="0">
@@ -13913,18 +14012,29 @@
                 <a:ea typeface="Be Vietnam Pro" pitchFamily="34" charset="-122"/>
                 <a:cs typeface="Be Vietnam Pro" pitchFamily="34" charset="-120"/>
               </a:rPr>
-              <a:t> mã</a:t>
-            </a:r>
-            <a:r>
-              <a:rPr lang="en-US" sz="2250" dirty="0" spc="2" kern="0">
-                <a:solidFill>
-                  <a:srgbClr val="14161C"/>
-                </a:solidFill>
-                <a:latin typeface="Be Vietnam Pro" pitchFamily="34" charset="0"/>
-                <a:ea typeface="Be Vietnam Pro" pitchFamily="34" charset="-122"/>
-                <a:cs typeface="Be Vietnam Pro" pitchFamily="34" charset="-120"/>
-              </a:rPr>
-              <a:t> của</a:t>
+              <a:t> vi</a:t>
+            </a:r>
+            <a:r>
+              <a:rPr lang="en-US" sz="2250" dirty="0" spc="-16" kern="0">
+                <a:solidFill>
+                  <a:srgbClr val="14161C"/>
+                </a:solidFill>
+                <a:latin typeface="Be Vietnam Pro" pitchFamily="34" charset="0"/>
+                <a:ea typeface="Be Vietnam Pro" pitchFamily="34" charset="-122"/>
+                <a:cs typeface="Be Vietnam Pro" pitchFamily="34" charset="-120"/>
+              </a:rPr>
+              <a:t> và</a:t>
+            </a:r>
+            <a:r>
+              <a:rPr lang="en-US" sz="2250" dirty="0" spc="0" kern="0">
+                <a:solidFill>
+                  <a:srgbClr val="14161C"/>
+                </a:solidFill>
+                <a:latin typeface="Be Vietnam Pro" pitchFamily="34" charset="0"/>
+                <a:ea typeface="Be Vietnam Pro" pitchFamily="34" charset="-122"/>
+                <a:cs typeface="Be Vietnam Pro" pitchFamily="34" charset="-120"/>
+              </a:rPr>
+              <a:t> thời</a:t>
             </a:r>
             <a:r>
               <a:rPr lang="en-US" sz="2250" dirty="0" spc="1" kern="0">
@@ -13935,51 +14045,18 @@
                 <a:ea typeface="Be Vietnam Pro" pitchFamily="34" charset="-122"/>
                 <a:cs typeface="Be Vietnam Pro" pitchFamily="34" charset="-120"/>
               </a:rPr>
-              <a:t> chuẩn</a:t>
-            </a:r>
-            <a:r>
-              <a:rPr lang="en-US" sz="2250" dirty="0" spc="-1" kern="0">
-                <a:solidFill>
-                  <a:srgbClr val="14161C"/>
-                </a:solidFill>
-                <a:latin typeface="Be Vietnam Pro" pitchFamily="34" charset="0"/>
-                <a:ea typeface="Be Vietnam Pro" pitchFamily="34" charset="-122"/>
-                <a:cs typeface="Be Vietnam Pro" pitchFamily="34" charset="-120"/>
-              </a:rPr>
-              <a:t> HTML</a:t>
-            </a:r>
-            <a:r>
-              <a:rPr lang="en-US" sz="2250" dirty="0" spc="4" kern="0">
-                <a:solidFill>
-                  <a:srgbClr val="14161C"/>
-                </a:solidFill>
-                <a:latin typeface="Be Vietnam Pro" pitchFamily="34" charset="0"/>
-                <a:ea typeface="Be Vietnam Pro" pitchFamily="34" charset="-122"/>
-                <a:cs typeface="Be Vietnam Pro" pitchFamily="34" charset="-120"/>
-              </a:rPr>
-              <a:t> tự</a:t>
-            </a:r>
-            <a:r>
-              <a:rPr lang="en-US" sz="2250" dirty="0" spc="-1" kern="0">
-                <a:solidFill>
-                  <a:srgbClr val="14161C"/>
-                </a:solidFill>
-                <a:latin typeface="Be Vietnam Pro" pitchFamily="34" charset="0"/>
-                <a:ea typeface="Be Vietnam Pro" pitchFamily="34" charset="-122"/>
-                <a:cs typeface="Be Vietnam Pro" pitchFamily="34" charset="-120"/>
-              </a:rPr>
-              <a:t> giới thiệu là nơi</a:t>
-            </a:r>
-            <a:r>
-              <a:rPr lang="en-US" sz="2250" dirty="0" spc="8" kern="0">
-                <a:solidFill>
-                  <a:srgbClr val="14161C"/>
-                </a:solidFill>
-                <a:latin typeface="Be Vietnam Pro" pitchFamily="34" charset="0"/>
-                <a:ea typeface="Be Vietnam Pro" pitchFamily="34" charset="-122"/>
-                <a:cs typeface="Be Vietnam Pro" pitchFamily="34" charset="-120"/>
-              </a:rPr>
-              <a:t> chứa</a:t>
+              <a:t> hạn</a:t>
+            </a:r>
+            <a:r>
+              <a:rPr lang="en-US" sz="2250" dirty="0" spc="-7" kern="0">
+                <a:solidFill>
+                  <a:srgbClr val="14161C"/>
+                </a:solidFill>
+                <a:latin typeface="Be Vietnam Pro" pitchFamily="34" charset="0"/>
+                <a:ea typeface="Be Vietnam Pro" pitchFamily="34" charset="-122"/>
+                <a:cs typeface="Be Vietnam Pro" pitchFamily="34" charset="-120"/>
+              </a:rPr>
+              <a:t> thay</a:t>
             </a:r>
             <a:r>
               <a:rPr lang="en-US" sz="2250" dirty="0" spc="0" kern="0">
@@ -13990,18 +14067,29 @@
                 <a:ea typeface="Be Vietnam Pro" pitchFamily="34" charset="-122"/>
                 <a:cs typeface="Be Vietnam Pro" pitchFamily="34" charset="-120"/>
               </a:rPr>
-              <a:t> HTML</a:t>
-            </a:r>
-            <a:r>
-              <a:rPr lang="en-US" sz="2250" dirty="0" spc="-13" kern="0">
-                <a:solidFill>
-                  <a:srgbClr val="14161C"/>
-                </a:solidFill>
-                <a:latin typeface="Be Vietnam Pro" pitchFamily="34" charset="0"/>
-                <a:ea typeface="Be Vietnam Pro" pitchFamily="34" charset="-122"/>
-                <a:cs typeface="Be Vietnam Pro" pitchFamily="34" charset="-120"/>
-              </a:rPr>
-              <a:t> Standard.</a:t>
+              <a:t> cho</a:t>
+            </a:r>
+            <a:r>
+              <a:rPr lang="en-US" sz="2250" dirty="0" spc="-12" kern="0">
+                <a:solidFill>
+                  <a:srgbClr val="14161C"/>
+                </a:solidFill>
+                <a:latin typeface="Be Vietnam Pro" pitchFamily="34" charset="0"/>
+                <a:ea typeface="Be Vietnam Pro" pitchFamily="34" charset="-122"/>
+                <a:cs typeface="Be Vietnam Pro" pitchFamily="34" charset="-120"/>
+              </a:rPr>
+              <a:t> mật</a:t>
+            </a:r>
+            <a:r>
+              <a:rPr lang="en-US" sz="2250" dirty="0" spc="0" kern="0">
+                <a:solidFill>
+                  <a:srgbClr val="14161C"/>
+                </a:solidFill>
+                <a:latin typeface="Be Vietnam Pro" pitchFamily="34" charset="0"/>
+                <a:ea typeface="Be Vietnam Pro" pitchFamily="34" charset="-122"/>
+                <a:cs typeface="Be Vietnam Pro" pitchFamily="34" charset="-120"/>
+              </a:rPr>
+              <a:t> khẩu.</a:t>
             </a:r>
             <a:endParaRPr lang="en-US" sz="2250" dirty="0"/>
           </a:p>
@@ -14683,6 +14771,72 @@
               <a:buNone/>
             </a:pPr>
             <a:r>
+              <a:rPr lang="en-US" sz="2850" dirty="0" spc="14" kern="0">
+                <a:solidFill>
+                  <a:srgbClr val="F3EEE3"/>
+                </a:solidFill>
+                <a:latin typeface="Be Vietnam Pro" pitchFamily="34" charset="0"/>
+                <a:ea typeface="Be Vietnam Pro" pitchFamily="34" charset="-122"/>
+                <a:cs typeface="Be Vietnam Pro" pitchFamily="34" charset="-120"/>
+              </a:rPr>
+              <a:t>ISO</a:t>
+            </a:r>
+            <a:r>
+              <a:rPr lang="en-US" sz="2850" dirty="0" spc="0" kern="0">
+                <a:solidFill>
+                  <a:srgbClr val="F3EEE3"/>
+                </a:solidFill>
+                <a:latin typeface="Be Vietnam Pro" pitchFamily="34" charset="0"/>
+                <a:ea typeface="Be Vietnam Pro" pitchFamily="34" charset="-122"/>
+                <a:cs typeface="Be Vietnam Pro" pitchFamily="34" charset="-120"/>
+              </a:rPr>
+              <a:t> 8601</a:t>
+            </a:r>
+            <a:r>
+              <a:rPr lang="en-US" sz="2850" dirty="0" spc="10" kern="0">
+                <a:solidFill>
+                  <a:srgbClr val="F3EEE3"/>
+                </a:solidFill>
+                <a:latin typeface="Be Vietnam Pro" pitchFamily="34" charset="0"/>
+                <a:ea typeface="Be Vietnam Pro" pitchFamily="34" charset="-122"/>
+                <a:cs typeface="Be Vietnam Pro" pitchFamily="34" charset="-120"/>
+              </a:rPr>
+              <a:t> chưa</a:t>
+            </a:r>
+            <a:r>
+              <a:rPr lang="en-US" sz="2850" dirty="0" spc="16" kern="0">
+                <a:solidFill>
+                  <a:srgbClr val="F3EEE3"/>
+                </a:solidFill>
+                <a:latin typeface="Be Vietnam Pro" pitchFamily="34" charset="0"/>
+                <a:ea typeface="Be Vietnam Pro" pitchFamily="34" charset="-122"/>
+                <a:cs typeface="Be Vietnam Pro" pitchFamily="34" charset="-120"/>
+              </a:rPr>
+              <a:t> đối</a:t>
+            </a:r>
+            <a:r>
+              <a:rPr lang="en-US" sz="2850" dirty="0" spc="0" kern="0">
+                <a:solidFill>
+                  <a:srgbClr val="F3EEE3"/>
+                </a:solidFill>
+                <a:latin typeface="Be Vietnam Pro" pitchFamily="34" charset="0"/>
+                <a:ea typeface="Be Vietnam Pro" pitchFamily="34" charset="-122"/>
+                <a:cs typeface="Be Vietnam Pro" pitchFamily="34" charset="-120"/>
+              </a:rPr>
+              <a:t> chiếu;</a:t>
+            </a:r>
+            <a:r>
+              <a:rPr lang="en-US" sz="2850" dirty="0" spc="-28" kern="0">
+                <a:solidFill>
+                  <a:srgbClr val="F3EEE3"/>
+                </a:solidFill>
+                <a:latin typeface="Be Vietnam Pro" pitchFamily="34" charset="0"/>
+                <a:ea typeface="Be Vietnam Pro" pitchFamily="34" charset="-122"/>
+                <a:cs typeface="Be Vietnam Pro" pitchFamily="34" charset="-120"/>
+              </a:rPr>
+              <a:t> OAuth</a:t>
+            </a:r>
+            <a:r>
               <a:rPr lang="en-US" sz="2850" dirty="0" spc="-3" kern="0">
                 <a:solidFill>
                   <a:srgbClr val="F3EEE3"/>
@@ -14691,7 +14845,29 @@
                 <a:ea typeface="Be Vietnam Pro" pitchFamily="34" charset="-122"/>
                 <a:cs typeface="Be Vietnam Pro" pitchFamily="34" charset="-120"/>
               </a:rPr>
-              <a:t>Các</a:t>
+              <a:t> theo</a:t>
+            </a:r>
+            <a:r>
+              <a:rPr lang="en-US" sz="2850" dirty="0" spc="-5" kern="0">
+                <a:solidFill>
+                  <a:srgbClr val="F3EEE3"/>
+                </a:solidFill>
+                <a:latin typeface="Be Vietnam Pro" pitchFamily="34" charset="0"/>
+                <a:ea typeface="Be Vietnam Pro" pitchFamily="34" charset="-122"/>
+                <a:cs typeface="Be Vietnam Pro" pitchFamily="34" charset="-120"/>
+              </a:rPr>
+              <a:t> bản</a:t>
+            </a:r>
+            <a:r>
+              <a:rPr lang="en-US" sz="2850" dirty="0" spc="-1" kern="0">
+                <a:solidFill>
+                  <a:srgbClr val="F3EEE3"/>
+                </a:solidFill>
+                <a:latin typeface="Be Vietnam Pro" pitchFamily="34" charset="0"/>
+                <a:ea typeface="Be Vietnam Pro" pitchFamily="34" charset="-122"/>
+                <a:cs typeface="Be Vietnam Pro" pitchFamily="34" charset="-120"/>
+              </a:rPr>
+              <a:t> nháp</a:t>
             </a:r>
             <a:r>
               <a:rPr lang="en-US" sz="2850" dirty="0" spc="3" kern="0">
@@ -14702,139 +14878,7 @@
                 <a:ea typeface="Be Vietnam Pro" pitchFamily="34" charset="-122"/>
                 <a:cs typeface="Be Vietnam Pro" pitchFamily="34" charset="-120"/>
               </a:rPr>
-              <a:t> ý</a:t>
-            </a:r>
-            <a:r>
-              <a:rPr lang="en-US" sz="2850" dirty="0" spc="-17" kern="0">
-                <a:solidFill>
-                  <a:srgbClr val="F3EEE3"/>
-                </a:solidFill>
-                <a:latin typeface="Be Vietnam Pro" pitchFamily="34" charset="0"/>
-                <a:ea typeface="Be Vietnam Pro" pitchFamily="34" charset="-122"/>
-                <a:cs typeface="Be Vietnam Pro" pitchFamily="34" charset="-120"/>
-              </a:rPr>
-              <a:t> về</a:t>
-            </a:r>
-            <a:r>
-              <a:rPr lang="en-US" sz="2850" dirty="0" spc="3" kern="0">
-                <a:solidFill>
-                  <a:srgbClr val="F3EEE3"/>
-                </a:solidFill>
-                <a:latin typeface="Be Vietnam Pro" pitchFamily="34" charset="0"/>
-                <a:ea typeface="Be Vietnam Pro" pitchFamily="34" charset="-122"/>
-                <a:cs typeface="Be Vietnam Pro" pitchFamily="34" charset="-120"/>
-              </a:rPr>
-              <a:t> IETF,</a:t>
-            </a:r>
-            <a:r>
-              <a:rPr lang="en-US" sz="2850" dirty="0" spc="11" kern="0">
-                <a:solidFill>
-                  <a:srgbClr val="F3EEE3"/>
-                </a:solidFill>
-                <a:latin typeface="Be Vietnam Pro" pitchFamily="34" charset="0"/>
-                <a:ea typeface="Be Vietnam Pro" pitchFamily="34" charset="-122"/>
-                <a:cs typeface="Be Vietnam Pro" pitchFamily="34" charset="-120"/>
-              </a:rPr>
-              <a:t> ISO</a:t>
-            </a:r>
-            <a:r>
-              <a:rPr lang="en-US" sz="2850" dirty="0" spc="0" kern="0">
-                <a:solidFill>
-                  <a:srgbClr val="F3EEE3"/>
-                </a:solidFill>
-                <a:latin typeface="Be Vietnam Pro" pitchFamily="34" charset="0"/>
-                <a:ea typeface="Be Vietnam Pro" pitchFamily="34" charset="-122"/>
-                <a:cs typeface="Be Vietnam Pro" pitchFamily="34" charset="-120"/>
-              </a:rPr>
-              <a:t> 8601</a:t>
-            </a:r>
-            <a:r>
-              <a:rPr lang="en-US" sz="2850" dirty="0" spc="-16" kern="0">
-                <a:solidFill>
-                  <a:srgbClr val="F3EEE3"/>
-                </a:solidFill>
-                <a:latin typeface="Be Vietnam Pro" pitchFamily="34" charset="0"/>
-                <a:ea typeface="Be Vietnam Pro" pitchFamily="34" charset="-122"/>
-                <a:cs typeface="Be Vietnam Pro" pitchFamily="34" charset="-120"/>
-              </a:rPr>
-              <a:t> và</a:t>
-            </a:r>
-            <a:r>
-              <a:rPr lang="en-US" sz="2850" dirty="0" spc="-28" kern="0">
-                <a:solidFill>
-                  <a:srgbClr val="F3EEE3"/>
-                </a:solidFill>
-                <a:latin typeface="Be Vietnam Pro" pitchFamily="34" charset="0"/>
-                <a:ea typeface="Be Vietnam Pro" pitchFamily="34" charset="-122"/>
-                <a:cs typeface="Be Vietnam Pro" pitchFamily="34" charset="-120"/>
-              </a:rPr>
-              <a:t> OAuth</a:t>
-            </a:r>
-            <a:r>
-              <a:rPr lang="en-US" sz="2850" dirty="0" spc="2" kern="0">
-                <a:solidFill>
-                  <a:srgbClr val="F3EEE3"/>
-                </a:solidFill>
-                <a:latin typeface="Be Vietnam Pro" pitchFamily="34" charset="0"/>
-                <a:ea typeface="Be Vietnam Pro" pitchFamily="34" charset="-122"/>
-                <a:cs typeface="Be Vietnam Pro" pitchFamily="34" charset="-120"/>
-              </a:rPr>
-              <a:t> là</a:t>
-            </a:r>
-            <a:r>
-              <a:rPr lang="en-US" sz="2850" dirty="0" spc="1" kern="0">
-                <a:solidFill>
-                  <a:srgbClr val="F3EEE3"/>
-                </a:solidFill>
-                <a:latin typeface="Be Vietnam Pro" pitchFamily="34" charset="0"/>
-                <a:ea typeface="Be Vietnam Pro" pitchFamily="34" charset="-122"/>
-                <a:cs typeface="Be Vietnam Pro" pitchFamily="34" charset="-120"/>
-              </a:rPr>
-              <a:t> lời của</a:t>
-            </a:r>
-            <a:r>
-              <a:rPr lang="en-US" sz="2850" dirty="0" spc="-2" kern="0">
-                <a:solidFill>
-                  <a:srgbClr val="F3EEE3"/>
-                </a:solidFill>
-                <a:latin typeface="Be Vietnam Pro" pitchFamily="34" charset="0"/>
-                <a:ea typeface="Be Vietnam Pro" pitchFamily="34" charset="-122"/>
-                <a:cs typeface="Be Vietnam Pro" pitchFamily="34" charset="-120"/>
-              </a:rPr>
-              <a:t> nguồn, bài</a:t>
-            </a:r>
-            <a:r>
-              <a:rPr lang="en-US" sz="2850" dirty="0" spc="10" kern="0">
-                <a:solidFill>
-                  <a:srgbClr val="F3EEE3"/>
-                </a:solidFill>
-                <a:latin typeface="Be Vietnam Pro" pitchFamily="34" charset="0"/>
-                <a:ea typeface="Be Vietnam Pro" pitchFamily="34" charset="-122"/>
-                <a:cs typeface="Be Vietnam Pro" pitchFamily="34" charset="-120"/>
-              </a:rPr>
-              <a:t> chưa</a:t>
-            </a:r>
-            <a:r>
-              <a:rPr lang="en-US" sz="2850" dirty="0" spc="16" kern="0">
-                <a:solidFill>
-                  <a:srgbClr val="F3EEE3"/>
-                </a:solidFill>
-                <a:latin typeface="Be Vietnam Pro" pitchFamily="34" charset="0"/>
-                <a:ea typeface="Be Vietnam Pro" pitchFamily="34" charset="-122"/>
-                <a:cs typeface="Be Vietnam Pro" pitchFamily="34" charset="-120"/>
-              </a:rPr>
-              <a:t> đối</a:t>
-            </a:r>
-            <a:r>
-              <a:rPr lang="en-US" sz="2850" dirty="0" spc="0" kern="0">
-                <a:solidFill>
-                  <a:srgbClr val="F3EEE3"/>
-                </a:solidFill>
-                <a:latin typeface="Be Vietnam Pro" pitchFamily="34" charset="0"/>
-                <a:ea typeface="Be Vietnam Pro" pitchFamily="34" charset="-122"/>
-                <a:cs typeface="Be Vietnam Pro" pitchFamily="34" charset="-120"/>
-              </a:rPr>
-              <a:t> chiếu.</a:t>
+              <a:t> 2.1.</a:t>
             </a:r>
             <a:endParaRPr lang="en-US" sz="2850" dirty="0"/>
           </a:p>
@@ -15047,15 +15091,15 @@
               <a:buChar char="•"/>
             </a:pPr>
             <a:r>
-              <a:rPr lang="en-US" sz="2550" dirty="0" spc="2" kern="0">
-                <a:solidFill>
-                  <a:srgbClr val="F3EEE3"/>
-                </a:solidFill>
-                <a:latin typeface="Be Vietnam Pro" pitchFamily="34" charset="0"/>
-                <a:ea typeface="Be Vietnam Pro" pitchFamily="34" charset="-122"/>
-                <a:cs typeface="Be Vietnam Pro" pitchFamily="34" charset="-120"/>
-              </a:rPr>
-              <a:t>Nguồn</a:t>
+              <a:rPr lang="en-US" sz="2550" dirty="0" spc="-1" kern="0">
+                <a:solidFill>
+                  <a:srgbClr val="F3EEE3"/>
+                </a:solidFill>
+                <a:latin typeface="Be Vietnam Pro" pitchFamily="34" charset="0"/>
+                <a:ea typeface="Be Vietnam Pro" pitchFamily="34" charset="-122"/>
+                <a:cs typeface="Be Vietnam Pro" pitchFamily="34" charset="-120"/>
+              </a:rPr>
+              <a:t>Mỗi</a:t>
             </a:r>
             <a:r>
               <a:rPr lang="en-US" sz="2550" dirty="0" spc="1" kern="0">
@@ -15066,7 +15110,40 @@
                 <a:ea typeface="Be Vietnam Pro" pitchFamily="34" charset="-122"/>
                 <a:cs typeface="Be Vietnam Pro" pitchFamily="34" charset="-120"/>
               </a:rPr>
-              <a:t> chỉ nêu</a:t>
+              <a:t> chuẩn</a:t>
+            </a:r>
+            <a:r>
+              <a:rPr lang="en-US" sz="2550" dirty="0" spc="-5" kern="0">
+                <a:solidFill>
+                  <a:srgbClr val="F3EEE3"/>
+                </a:solidFill>
+                <a:latin typeface="Be Vietnam Pro" pitchFamily="34" charset="0"/>
+                <a:ea typeface="Be Vietnam Pro" pitchFamily="34" charset="-122"/>
+                <a:cs typeface="Be Vietnam Pro" pitchFamily="34" charset="-120"/>
+              </a:rPr>
+              <a:t> một</a:t>
+            </a:r>
+            <a:r>
+              <a:rPr lang="en-US" sz="2550" dirty="0" spc="3" kern="0">
+                <a:solidFill>
+                  <a:srgbClr val="F3EEE3"/>
+                </a:solidFill>
+                <a:latin typeface="Be Vietnam Pro" pitchFamily="34" charset="0"/>
+                <a:ea typeface="Be Vietnam Pro" pitchFamily="34" charset="-122"/>
+                <a:cs typeface="Be Vietnam Pro" pitchFamily="34" charset="-120"/>
+              </a:rPr>
+              <a:t> câu:</a:t>
+            </a:r>
+            <a:r>
+              <a:rPr lang="en-US" sz="2550" dirty="0" spc="-1" kern="0">
+                <a:solidFill>
+                  <a:srgbClr val="F3EEE3"/>
+                </a:solidFill>
+                <a:latin typeface="Be Vietnam Pro" pitchFamily="34" charset="0"/>
+                <a:ea typeface="Be Vietnam Pro" pitchFamily="34" charset="-122"/>
+                <a:cs typeface="Be Vietnam Pro" pitchFamily="34" charset="-120"/>
+              </a:rPr>
+              <a:t> nó lo</a:t>
             </a:r>
             <a:r>
               <a:rPr lang="en-US" sz="2550" dirty="0" spc="-3" kern="0">
@@ -15088,18 +15165,7 @@
                 <a:ea typeface="Be Vietnam Pro" pitchFamily="34" charset="-122"/>
                 <a:cs typeface="Be Vietnam Pro" pitchFamily="34" charset="-120"/>
               </a:rPr>
-              <a:t> chuẩn</a:t>
-            </a:r>
-            <a:r>
-              <a:rPr lang="en-US" sz="2550" dirty="0" spc="-1" kern="0">
-                <a:solidFill>
-                  <a:srgbClr val="F3EEE3"/>
-                </a:solidFill>
-                <a:latin typeface="Be Vietnam Pro" pitchFamily="34" charset="0"/>
-                <a:ea typeface="Be Vietnam Pro" pitchFamily="34" charset="-122"/>
-                <a:cs typeface="Be Vietnam Pro" pitchFamily="34" charset="-120"/>
-              </a:rPr>
-              <a:t> lo</a:t>
+              <a:t> gì</a:t>
             </a:r>
             <a:endParaRPr lang="en-US" sz="2550" dirty="0"/>
           </a:p>
@@ -15368,6 +15434,28 @@
               <a:buNone/>
             </a:pPr>
             <a:r>
+              <a:rPr lang="en-US" sz="2250" dirty="0" spc="-2" kern="0">
+                <a:solidFill>
+                  <a:srgbClr val="C4C8D6"/>
+                </a:solidFill>
+                <a:latin typeface="Be Vietnam Pro" pitchFamily="34" charset="0"/>
+                <a:ea typeface="Be Vietnam Pro" pitchFamily="34" charset="-122"/>
+                <a:cs typeface="Be Vietnam Pro" pitchFamily="34" charset="-120"/>
+              </a:rPr>
+              <a:t>Chính</a:t>
+            </a:r>
+            <a:r>
+              <a:rPr lang="en-US" sz="2250" dirty="0" spc="2" kern="0">
+                <a:solidFill>
+                  <a:srgbClr val="C4C8D6"/>
+                </a:solidFill>
+                <a:latin typeface="Be Vietnam Pro" pitchFamily="34" charset="0"/>
+                <a:ea typeface="Be Vietnam Pro" pitchFamily="34" charset="-122"/>
+                <a:cs typeface="Be Vietnam Pro" pitchFamily="34" charset="-120"/>
+              </a:rPr>
+              <a:t> các</a:t>
+            </a:r>
+            <a:r>
               <a:rPr lang="en-US" sz="2250" dirty="0" spc="0" kern="0">
                 <a:solidFill>
                   <a:srgbClr val="C4C8D6"/>
@@ -15376,7 +15464,7 @@
                 <a:ea typeface="Be Vietnam Pro" pitchFamily="34" charset="-122"/>
                 <a:cs typeface="Be Vietnam Pro" pitchFamily="34" charset="-120"/>
               </a:rPr>
-              <a:t>Nguồn</a:t>
+              <a:t> chuẩn</a:t>
             </a:r>
             <a:r>
               <a:rPr lang="en-US" sz="2250" dirty="0" spc="1" kern="0">
@@ -15390,7 +15478,7 @@
               <a:t> không</a:t>
             </a:r>
             <a:r>
-              <a:rPr lang="en-US" sz="2250" dirty="0" spc="-1" kern="0">
+              <a:rPr lang="en-US" sz="2250" dirty="0" spc="4" kern="0">
                 <a:solidFill>
                   <a:srgbClr val="C4C8D6"/>
                 </a:solidFill>
@@ -15398,10 +15486,10 @@
                 <a:ea typeface="Be Vietnam Pro" pitchFamily="34" charset="-122"/>
                 <a:cs typeface="Be Vietnam Pro" pitchFamily="34" charset="-120"/>
               </a:rPr>
-              <a:t> chia</a:t>
-            </a:r>
-            <a:r>
-              <a:rPr lang="en-US" sz="2250" dirty="0" spc="2" kern="0">
+              <a:t> tự</a:t>
+            </a:r>
+            <a:r>
+              <a:rPr lang="en-US" sz="2250" dirty="0" spc="0" kern="0">
                 <a:solidFill>
                   <a:srgbClr val="C4C8D6"/>
                 </a:solidFill>
@@ -15409,10 +15497,32 @@
                 <a:ea typeface="Be Vietnam Pro" pitchFamily="34" charset="-122"/>
                 <a:cs typeface="Be Vietnam Pro" pitchFamily="34" charset="-120"/>
               </a:rPr>
+              <a:t> chia thành</a:t>
+            </a:r>
+            <a:r>
+              <a:rPr lang="en-US" sz="2250" dirty="0" spc="-3" kern="0">
+                <a:solidFill>
+                  <a:srgbClr val="C4C8D6"/>
+                </a:solidFill>
+                <a:latin typeface="Be Vietnam Pro" pitchFamily="34" charset="0"/>
+                <a:ea typeface="Be Vietnam Pro" pitchFamily="34" charset="-122"/>
+                <a:cs typeface="Be Vietnam Pro" pitchFamily="34" charset="-120"/>
+              </a:rPr>
+              <a:t> ba</a:t>
+            </a:r>
+            <a:r>
+              <a:rPr lang="en-US" sz="2250" dirty="0" spc="1" kern="0">
+                <a:solidFill>
+                  <a:srgbClr val="C4C8D6"/>
+                </a:solidFill>
+                <a:latin typeface="Be Vietnam Pro" pitchFamily="34" charset="0"/>
+                <a:ea typeface="Be Vietnam Pro" pitchFamily="34" charset="-122"/>
+                <a:cs typeface="Be Vietnam Pro" pitchFamily="34" charset="-120"/>
+              </a:rPr>
               <a:t> nhóm</a:t>
             </a:r>
             <a:r>
-              <a:rPr lang="en-US" sz="2250" dirty="0" spc="-10" kern="0">
+              <a:rPr lang="en-US" sz="2250" dirty="0" spc="-5" kern="0">
                 <a:solidFill>
                   <a:srgbClr val="C4C8D6"/>
                 </a:solidFill>
@@ -15420,95 +15530,7 @@
                 <a:ea typeface="Be Vietnam Pro" pitchFamily="34" charset="-122"/>
                 <a:cs typeface="Be Vietnam Pro" pitchFamily="34" charset="-120"/>
               </a:rPr>
-              <a:t> hay</a:t>
-            </a:r>
-            <a:r>
-              <a:rPr lang="en-US" sz="2250" dirty="0" spc="1" kern="0">
-                <a:solidFill>
-                  <a:srgbClr val="C4C8D6"/>
-                </a:solidFill>
-                <a:latin typeface="Be Vietnam Pro" pitchFamily="34" charset="0"/>
-                <a:ea typeface="Be Vietnam Pro" pitchFamily="34" charset="-122"/>
-                <a:cs typeface="Be Vietnam Pro" pitchFamily="34" charset="-120"/>
-              </a:rPr>
-              <a:t> phân</a:t>
-            </a:r>
-            <a:r>
-              <a:rPr lang="en-US" sz="2250" dirty="0" spc="-4" kern="0">
-                <a:solidFill>
-                  <a:srgbClr val="C4C8D6"/>
-                </a:solidFill>
-                <a:latin typeface="Be Vietnam Pro" pitchFamily="34" charset="0"/>
-                <a:ea typeface="Be Vietnam Pro" pitchFamily="34" charset="-122"/>
-                <a:cs typeface="Be Vietnam Pro" pitchFamily="34" charset="-120"/>
-              </a:rPr>
-              <a:t> biệt</a:t>
-            </a:r>
-            <a:r>
-              <a:rPr lang="en-US" sz="2250" dirty="0" spc="-3" kern="0">
-                <a:solidFill>
-                  <a:srgbClr val="C4C8D6"/>
-                </a:solidFill>
-                <a:latin typeface="Be Vietnam Pro" pitchFamily="34" charset="0"/>
-                <a:ea typeface="Be Vietnam Pro" pitchFamily="34" charset="-122"/>
-                <a:cs typeface="Be Vietnam Pro" pitchFamily="34" charset="-120"/>
-              </a:rPr>
-              <a:t> giao</a:t>
-            </a:r>
-            <a:r>
-              <a:rPr lang="en-US" sz="2250" dirty="0" spc="7" kern="0">
-                <a:solidFill>
-                  <a:srgbClr val="C4C8D6"/>
-                </a:solidFill>
-                <a:latin typeface="Be Vietnam Pro" pitchFamily="34" charset="0"/>
-                <a:ea typeface="Be Vietnam Pro" pitchFamily="34" charset="-122"/>
-                <a:cs typeface="Be Vietnam Pro" pitchFamily="34" charset="-120"/>
-              </a:rPr>
-              <a:t> thức,</a:t>
-            </a:r>
-            <a:r>
-              <a:rPr lang="en-US" sz="2250" dirty="0" spc="-7" kern="0">
-                <a:solidFill>
-                  <a:srgbClr val="C4C8D6"/>
-                </a:solidFill>
-                <a:latin typeface="Be Vietnam Pro" pitchFamily="34" charset="0"/>
-                <a:ea typeface="Be Vietnam Pro" pitchFamily="34" charset="-122"/>
-                <a:cs typeface="Be Vietnam Pro" pitchFamily="34" charset="-120"/>
-              </a:rPr>
-              <a:t> ngôn</a:t>
-            </a:r>
-            <a:r>
-              <a:rPr lang="en-US" sz="2250" dirty="0" spc="0" kern="0">
-                <a:solidFill>
-                  <a:srgbClr val="C4C8D6"/>
-                </a:solidFill>
-                <a:latin typeface="Be Vietnam Pro" pitchFamily="34" charset="0"/>
-                <a:ea typeface="Be Vietnam Pro" pitchFamily="34" charset="-122"/>
-                <a:cs typeface="Be Vietnam Pro" pitchFamily="34" charset="-120"/>
-              </a:rPr>
-              <a:t> ngữ,</a:t>
-            </a:r>
-            <a:r>
-              <a:rPr lang="en-US" sz="2250" dirty="0" spc="19" kern="0">
-                <a:solidFill>
-                  <a:srgbClr val="C4C8D6"/>
-                </a:solidFill>
-                <a:latin typeface="Be Vietnam Pro" pitchFamily="34" charset="0"/>
-                <a:ea typeface="Be Vietnam Pro" pitchFamily="34" charset="-122"/>
-                <a:cs typeface="Be Vietnam Pro" pitchFamily="34" charset="-120"/>
-              </a:rPr>
-              <a:t> định</a:t>
-            </a:r>
-            <a:r>
-              <a:rPr lang="en-US" sz="2250" dirty="0" spc="1" kern="0">
-                <a:solidFill>
-                  <a:srgbClr val="C4C8D6"/>
-                </a:solidFill>
-                <a:latin typeface="Be Vietnam Pro" pitchFamily="34" charset="0"/>
-                <a:ea typeface="Be Vietnam Pro" pitchFamily="34" charset="-122"/>
-                <a:cs typeface="Be Vietnam Pro" pitchFamily="34" charset="-120"/>
-              </a:rPr>
-              <a:t> dạng.</a:t>
+              <a:t> này.</a:t>
             </a:r>
             <a:endParaRPr lang="en-US" sz="2250" dirty="0"/>
           </a:p>
@@ -15684,7 +15706,7 @@
               <a:buNone/>
             </a:pPr>
             <a:r>
-              <a:rPr lang="en-US" sz="2250" dirty="0" spc="0" kern="0">
+              <a:rPr lang="en-US" sz="2250" dirty="0" spc="-3" kern="0">
                 <a:solidFill>
                   <a:srgbClr val="C4C8D6"/>
                 </a:solidFill>
@@ -15692,7 +15714,7 @@
                 <a:ea typeface="Be Vietnam Pro" pitchFamily="34" charset="-122"/>
                 <a:cs typeface="Be Vietnam Pro" pitchFamily="34" charset="-120"/>
               </a:rPr>
-              <a:t>Nguồn</a:t>
+              <a:t>Bài</a:t>
             </a:r>
             <a:r>
               <a:rPr lang="en-US" sz="2250" dirty="0" spc="1" kern="0">
@@ -15703,7 +15725,40 @@
                 <a:ea typeface="Be Vietnam Pro" pitchFamily="34" charset="-122"/>
                 <a:cs typeface="Be Vietnam Pro" pitchFamily="34" charset="-120"/>
               </a:rPr>
-              <a:t> không nói chi</a:t>
+              <a:t> không</a:t>
+            </a:r>
+            <a:r>
+              <a:rPr lang="en-US" sz="2250" dirty="0" spc="31" kern="0">
+                <a:solidFill>
+                  <a:srgbClr val="C4C8D6"/>
+                </a:solidFill>
+                <a:latin typeface="Be Vietnam Pro" pitchFamily="34" charset="0"/>
+                <a:ea typeface="Be Vietnam Pro" pitchFamily="34" charset="-122"/>
+                <a:cs typeface="Be Vietnam Pro" pitchFamily="34" charset="-120"/>
+              </a:rPr>
+              <a:t> đi</a:t>
+            </a:r>
+            <a:r>
+              <a:rPr lang="en-US" sz="2250" dirty="0" spc="-14" kern="0">
+                <a:solidFill>
+                  <a:srgbClr val="C4C8D6"/>
+                </a:solidFill>
+                <a:latin typeface="Be Vietnam Pro" pitchFamily="34" charset="0"/>
+                <a:ea typeface="Be Vietnam Pro" pitchFamily="34" charset="-122"/>
+                <a:cs typeface="Be Vietnam Pro" pitchFamily="34" charset="-120"/>
+              </a:rPr>
+              <a:t> vào</a:t>
+            </a:r>
+            <a:r>
+              <a:rPr lang="en-US" sz="2250" dirty="0" spc="1" kern="0">
+                <a:solidFill>
+                  <a:srgbClr val="C4C8D6"/>
+                </a:solidFill>
+                <a:latin typeface="Be Vietnam Pro" pitchFamily="34" charset="0"/>
+                <a:ea typeface="Be Vietnam Pro" pitchFamily="34" charset="-122"/>
+                <a:cs typeface="Be Vietnam Pro" pitchFamily="34" charset="-120"/>
+              </a:rPr>
+              <a:t> chi</a:t>
             </a:r>
             <a:r>
               <a:rPr lang="en-US" sz="2250" dirty="0" spc="-6" kern="0">
@@ -15739,7 +15794,7 @@
               <a:t> thuật</a:t>
             </a:r>
             <a:r>
-              <a:rPr lang="en-US" sz="2250" dirty="0" spc="3" kern="0">
+              <a:rPr lang="en-US" sz="2250" dirty="0" spc="-16" kern="0">
                 <a:solidFill>
                   <a:srgbClr val="C4C8D6"/>
                 </a:solidFill>
@@ -15747,29 +15802,7 @@
                 <a:ea typeface="Be Vietnam Pro" pitchFamily="34" charset="-122"/>
                 <a:cs typeface="Be Vietnam Pro" pitchFamily="34" charset="-120"/>
               </a:rPr>
-              <a:t> của</a:t>
-            </a:r>
-            <a:r>
-              <a:rPr lang="en-US" sz="2250" dirty="0" spc="0" kern="0">
-                <a:solidFill>
-                  <a:srgbClr val="C4C8D6"/>
-                </a:solidFill>
-                <a:latin typeface="Be Vietnam Pro" pitchFamily="34" charset="0"/>
-                <a:ea typeface="Be Vietnam Pro" pitchFamily="34" charset="-122"/>
-                <a:cs typeface="Be Vietnam Pro" pitchFamily="34" charset="-120"/>
-              </a:rPr>
-              <a:t> chuẩn</a:t>
-            </a:r>
-            <a:r>
-              <a:rPr lang="en-US" sz="2250" dirty="0" spc="-2" kern="0">
-                <a:solidFill>
-                  <a:srgbClr val="C4C8D6"/>
-                </a:solidFill>
-                <a:latin typeface="Be Vietnam Pro" pitchFamily="34" charset="0"/>
-                <a:ea typeface="Be Vietnam Pro" pitchFamily="34" charset="-122"/>
-                <a:cs typeface="Be Vietnam Pro" pitchFamily="34" charset="-120"/>
-              </a:rPr>
-              <a:t> nào,</a:t>
+              <a:t> và</a:t>
             </a:r>
             <a:r>
               <a:rPr lang="en-US" sz="2250" dirty="0" spc="1" kern="0">
@@ -15903,7 +15936,7 @@
               <a:buNone/>
             </a:pPr>
             <a:r>
-              <a:rPr lang="en-US" sz="3600" dirty="0" spc="2" kern="0">
+              <a:rPr lang="en-US" sz="3600" dirty="0" spc="-44" kern="0">
                 <a:solidFill>
                   <a:srgbClr val="F3EEE3"/>
                 </a:solidFill>
@@ -15911,10 +15944,10 @@
                 <a:ea typeface="Bricolage Grotesque ExtraBold" pitchFamily="34" charset="-122"/>
                 <a:cs typeface="Bricolage Grotesque ExtraBold" pitchFamily="34" charset="-120"/>
               </a:rPr>
-              <a:t>Câu HTML</a:t>
-            </a:r>
-            <a:r>
-              <a:rPr lang="en-US" sz="3600" dirty="0" spc="1" kern="0">
+              <a:t>OAuth</a:t>
+            </a:r>
+            <a:r>
+              <a:rPr lang="en-US" sz="3600" dirty="0" spc="5" kern="0">
                 <a:solidFill>
                   <a:srgbClr val="F3EEE3"/>
                 </a:solidFill>
@@ -15922,10 +15955,10 @@
                 <a:ea typeface="Bricolage Grotesque ExtraBold" pitchFamily="34" charset="-122"/>
                 <a:cs typeface="Bricolage Grotesque ExtraBold" pitchFamily="34" charset="-120"/>
               </a:rPr>
-              <a:t> dở</a:t>
-            </a:r>
-            <a:r>
-              <a:rPr lang="en-US" sz="3600" dirty="0" spc="2" kern="0">
+              <a:t> là</a:t>
+            </a:r>
+            <a:r>
+              <a:rPr lang="en-US" sz="3600" dirty="0" spc="0" kern="0">
                 <a:solidFill>
                   <a:srgbClr val="F3EEE3"/>
                 </a:solidFill>
@@ -15933,7 +15966,18 @@
                 <a:ea typeface="Bricolage Grotesque ExtraBold" pitchFamily="34" charset="-122"/>
                 <a:cs typeface="Bricolage Grotesque ExtraBold" pitchFamily="34" charset="-120"/>
               </a:rPr>
-              <a:t> dang</a:t>
+              <a:t> bản</a:t>
+            </a:r>
+            <a:r>
+              <a:rPr lang="en-US" sz="3600" dirty="0" spc="3" kern="0">
+                <a:solidFill>
+                  <a:srgbClr val="F3EEE3"/>
+                </a:solidFill>
+                <a:latin typeface="Bricolage Grotesque ExtraBold" pitchFamily="34" charset="0"/>
+                <a:ea typeface="Bricolage Grotesque ExtraBold" pitchFamily="34" charset="-122"/>
+                <a:cs typeface="Bricolage Grotesque ExtraBold" pitchFamily="34" charset="-120"/>
+              </a:rPr>
+              <a:t> nháp</a:t>
             </a:r>
             <a:endParaRPr lang="en-US" sz="3600" dirty="0"/>
           </a:p>
@@ -15967,7 +16011,7 @@
               <a:buNone/>
             </a:pPr>
             <a:r>
-              <a:rPr lang="en-US" sz="2250" dirty="0" spc="-1" kern="0">
+              <a:rPr lang="en-US" sz="2250" dirty="0" spc="-3" kern="0">
                 <a:solidFill>
                   <a:srgbClr val="C4C8D6"/>
                 </a:solidFill>
@@ -15975,7 +16019,73 @@
                 <a:ea typeface="Be Vietnam Pro" pitchFamily="34" charset="-122"/>
                 <a:cs typeface="Be Vietnam Pro" pitchFamily="34" charset="-120"/>
               </a:rPr>
-              <a:t>Đuôi</a:t>
+              <a:t>Bài</a:t>
+            </a:r>
+            <a:r>
+              <a:rPr lang="en-US" sz="2250" dirty="0" spc="3" kern="0">
+                <a:solidFill>
+                  <a:srgbClr val="C4C8D6"/>
+                </a:solidFill>
+                <a:latin typeface="Be Vietnam Pro" pitchFamily="34" charset="0"/>
+                <a:ea typeface="Be Vietnam Pro" pitchFamily="34" charset="-122"/>
+                <a:cs typeface="Be Vietnam Pro" pitchFamily="34" charset="-120"/>
+              </a:rPr>
+              <a:t> dùng</a:t>
+            </a:r>
+            <a:r>
+              <a:rPr lang="en-US" sz="2250" dirty="0" spc="-2" kern="0">
+                <a:solidFill>
+                  <a:srgbClr val="C4C8D6"/>
+                </a:solidFill>
+                <a:latin typeface="Be Vietnam Pro" pitchFamily="34" charset="0"/>
+                <a:ea typeface="Be Vietnam Pro" pitchFamily="34" charset="-122"/>
+                <a:cs typeface="Be Vietnam Pro" pitchFamily="34" charset="-120"/>
+              </a:rPr>
+              <a:t> bản</a:t>
+            </a:r>
+            <a:r>
+              <a:rPr lang="en-US" sz="2250" dirty="0" spc="1" kern="0">
+                <a:solidFill>
+                  <a:srgbClr val="C4C8D6"/>
+                </a:solidFill>
+                <a:latin typeface="Be Vietnam Pro" pitchFamily="34" charset="0"/>
+                <a:ea typeface="Be Vietnam Pro" pitchFamily="34" charset="-122"/>
+                <a:cs typeface="Be Vietnam Pro" pitchFamily="34" charset="-120"/>
+              </a:rPr>
+              <a:t> nháp</a:t>
+            </a:r>
+            <a:r>
+              <a:rPr lang="en-US" sz="2250" dirty="0" spc="-21" kern="0">
+                <a:solidFill>
+                  <a:srgbClr val="C4C8D6"/>
+                </a:solidFill>
+                <a:latin typeface="Be Vietnam Pro" pitchFamily="34" charset="0"/>
+                <a:ea typeface="Be Vietnam Pro" pitchFamily="34" charset="-122"/>
+                <a:cs typeface="Be Vietnam Pro" pitchFamily="34" charset="-120"/>
+              </a:rPr>
+              <a:t> OAuth</a:t>
+            </a:r>
+            <a:r>
+              <a:rPr lang="en-US" sz="2250" dirty="0" spc="2" kern="0">
+                <a:solidFill>
+                  <a:srgbClr val="C4C8D6"/>
+                </a:solidFill>
+                <a:latin typeface="Be Vietnam Pro" pitchFamily="34" charset="0"/>
+                <a:ea typeface="Be Vietnam Pro" pitchFamily="34" charset="-122"/>
+                <a:cs typeface="Be Vietnam Pro" pitchFamily="34" charset="-120"/>
+              </a:rPr>
+              <a:t> 2.1,</a:t>
+            </a:r>
+            <a:r>
+              <a:rPr lang="en-US" sz="2250" dirty="0" spc="6" kern="0">
+                <a:solidFill>
+                  <a:srgbClr val="C4C8D6"/>
+                </a:solidFill>
+                <a:latin typeface="Be Vietnam Pro" pitchFamily="34" charset="0"/>
+                <a:ea typeface="Be Vietnam Pro" pitchFamily="34" charset="-122"/>
+                <a:cs typeface="Be Vietnam Pro" pitchFamily="34" charset="-120"/>
+              </a:rPr>
+              <a:t> chưa</a:t>
             </a:r>
             <a:r>
               <a:rPr lang="en-US" sz="2250" dirty="0" spc="0" kern="0">
@@ -15986,10 +16096,10 @@
                 <a:ea typeface="Be Vietnam Pro" pitchFamily="34" charset="-122"/>
                 <a:cs typeface="Be Vietnam Pro" pitchFamily="34" charset="-120"/>
               </a:rPr>
-              <a:t> câu</a:t>
-            </a:r>
-            <a:r>
-              <a:rPr lang="en-US" sz="2250" dirty="0" spc="5" kern="0">
+              <a:t> phải chuẩn</a:t>
+            </a:r>
+            <a:r>
+              <a:rPr lang="en-US" sz="2250" dirty="0" spc="16" kern="0">
                 <a:solidFill>
                   <a:srgbClr val="C4C8D6"/>
                 </a:solidFill>
@@ -15997,7 +16107,18 @@
                 <a:ea typeface="Be Vietnam Pro" pitchFamily="34" charset="-122"/>
                 <a:cs typeface="Be Vietnam Pro" pitchFamily="34" charset="-120"/>
               </a:rPr>
-              <a:t> có</a:t>
+              <a:t> đã</a:t>
+            </a:r>
+            <a:r>
+              <a:rPr lang="en-US" sz="2250" dirty="0" spc="2" kern="0">
+                <a:solidFill>
+                  <a:srgbClr val="C4C8D6"/>
+                </a:solidFill>
+                <a:latin typeface="Be Vietnam Pro" pitchFamily="34" charset="0"/>
+                <a:ea typeface="Be Vietnam Pro" pitchFamily="34" charset="-122"/>
+                <a:cs typeface="Be Vietnam Pro" pitchFamily="34" charset="-120"/>
+              </a:rPr>
+              <a:t> công</a:t>
             </a:r>
             <a:r>
               <a:rPr lang="en-US" sz="2250" dirty="0" spc="3" kern="0">
@@ -16008,95 +16129,7 @@
                 <a:ea typeface="Be Vietnam Pro" pitchFamily="34" charset="-122"/>
                 <a:cs typeface="Be Vietnam Pro" pitchFamily="34" charset="-120"/>
               </a:rPr>
-              <a:t> chữ</a:t>
-            </a:r>
-            <a:r>
-              <a:rPr lang="en-US" sz="2250" dirty="0" spc="0" kern="0">
-                <a:solidFill>
-                  <a:srgbClr val="C4C8D6"/>
-                </a:solidFill>
-                <a:latin typeface="Be Vietnam Pro" pitchFamily="34" charset="0"/>
-                <a:ea typeface="Be Vietnam Pro" pitchFamily="34" charset="-122"/>
-                <a:cs typeface="Be Vietnam Pro" pitchFamily="34" charset="-120"/>
-              </a:rPr>
-              <a:t> HTML</a:t>
-            </a:r>
-            <a:r>
-              <a:rPr lang="en-US" sz="2250" dirty="0" spc="-9" kern="0">
-                <a:solidFill>
-                  <a:srgbClr val="C4C8D6"/>
-                </a:solidFill>
-                <a:latin typeface="Be Vietnam Pro" pitchFamily="34" charset="0"/>
-                <a:ea typeface="Be Vietnam Pro" pitchFamily="34" charset="-122"/>
-                <a:cs typeface="Be Vietnam Pro" pitchFamily="34" charset="-120"/>
-              </a:rPr>
-              <a:t> tags</a:t>
-            </a:r>
-            <a:r>
-              <a:rPr lang="en-US" sz="2250" dirty="0" spc="1" kern="0">
-                <a:solidFill>
-                  <a:srgbClr val="C4C8D6"/>
-                </a:solidFill>
-                <a:latin typeface="Be Vietnam Pro" pitchFamily="34" charset="0"/>
-                <a:ea typeface="Be Vietnam Pro" pitchFamily="34" charset="-122"/>
-                <a:cs typeface="Be Vietnam Pro" pitchFamily="34" charset="-120"/>
-              </a:rPr>
-              <a:t> lạc</a:t>
-            </a:r>
-            <a:r>
-              <a:rPr lang="en-US" sz="2250" dirty="0" spc="-12" kern="0">
-                <a:solidFill>
-                  <a:srgbClr val="C4C8D6"/>
-                </a:solidFill>
-                <a:latin typeface="Be Vietnam Pro" pitchFamily="34" charset="0"/>
-                <a:ea typeface="Be Vietnam Pro" pitchFamily="34" charset="-122"/>
-                <a:cs typeface="Be Vietnam Pro" pitchFamily="34" charset="-120"/>
-              </a:rPr>
-              <a:t> vào;</a:t>
-            </a:r>
-            <a:r>
-              <a:rPr lang="en-US" sz="2250" dirty="0" spc="-4" kern="0">
-                <a:solidFill>
-                  <a:srgbClr val="C4C8D6"/>
-                </a:solidFill>
-                <a:latin typeface="Be Vietnam Pro" pitchFamily="34" charset="0"/>
-                <a:ea typeface="Be Vietnam Pro" pitchFamily="34" charset="-122"/>
-                <a:cs typeface="Be Vietnam Pro" pitchFamily="34" charset="-120"/>
-              </a:rPr>
-              <a:t> bài</a:t>
-            </a:r>
-            <a:r>
-              <a:rPr lang="en-US" sz="2250" dirty="0" spc="1" kern="0">
-                <a:solidFill>
-                  <a:srgbClr val="C4C8D6"/>
-                </a:solidFill>
-                <a:latin typeface="Be Vietnam Pro" pitchFamily="34" charset="0"/>
-                <a:ea typeface="Be Vietnam Pro" pitchFamily="34" charset="-122"/>
-                <a:cs typeface="Be Vietnam Pro" pitchFamily="34" charset="-120"/>
-              </a:rPr>
-              <a:t> chỉ giữ phần</a:t>
-            </a:r>
-            <a:r>
-              <a:rPr lang="en-US" sz="2250" dirty="0" spc="-2" kern="0">
-                <a:solidFill>
-                  <a:srgbClr val="C4C8D6"/>
-                </a:solidFill>
-                <a:latin typeface="Be Vietnam Pro" pitchFamily="34" charset="0"/>
-                <a:ea typeface="Be Vietnam Pro" pitchFamily="34" charset="-122"/>
-                <a:cs typeface="Be Vietnam Pro" pitchFamily="34" charset="-120"/>
-              </a:rPr>
-              <a:t> hiểu</a:t>
-            </a:r>
-            <a:r>
-              <a:rPr lang="en-US" sz="2250" dirty="0" spc="9" kern="0">
-                <a:solidFill>
-                  <a:srgbClr val="C4C8D6"/>
-                </a:solidFill>
-                <a:latin typeface="Be Vietnam Pro" pitchFamily="34" charset="0"/>
-                <a:ea typeface="Be Vietnam Pro" pitchFamily="34" charset="-122"/>
-                <a:cs typeface="Be Vietnam Pro" pitchFamily="34" charset="-120"/>
-              </a:rPr>
-              <a:t> được.</a:t>
+              <a:t> bố.</a:t>
             </a:r>
             <a:endParaRPr lang="en-US" sz="2250" dirty="0"/>
           </a:p>
@@ -17511,6 +17544,28 @@
               <a:buNone/>
             </a:pPr>
             <a:r>
+              <a:rPr lang="en-US" sz="2250" dirty="0" spc="-8" kern="0">
+                <a:solidFill>
+                  <a:srgbClr val="14161C"/>
+                </a:solidFill>
+                <a:latin typeface="Be Vietnam Pro" pitchFamily="34" charset="0"/>
+                <a:ea typeface="Be Vietnam Pro" pitchFamily="34" charset="-122"/>
+                <a:cs typeface="Be Vietnam Pro" pitchFamily="34" charset="-120"/>
+              </a:rPr>
+              <a:t>Một</a:t>
+            </a:r>
+            <a:r>
+              <a:rPr lang="en-US" sz="2250" dirty="0" spc="2" kern="0">
+                <a:solidFill>
+                  <a:srgbClr val="14161C"/>
+                </a:solidFill>
+                <a:latin typeface="Be Vietnam Pro" pitchFamily="34" charset="0"/>
+                <a:ea typeface="Be Vietnam Pro" pitchFamily="34" charset="-122"/>
+                <a:cs typeface="Be Vietnam Pro" pitchFamily="34" charset="-120"/>
+              </a:rPr>
+              <a:t> cách</a:t>
+            </a:r>
+            <a:r>
               <a:rPr lang="en-US" sz="2250" dirty="0" spc="-2" kern="0">
                 <a:solidFill>
                   <a:srgbClr val="14161C"/>
@@ -17519,10 +17574,98 @@
                 <a:ea typeface="Be Vietnam Pro" pitchFamily="34" charset="-122"/>
                 <a:cs typeface="Be Vietnam Pro" pitchFamily="34" charset="-120"/>
               </a:rPr>
-              <a:t>Chuẩn</a:t>
-            </a:r>
-            <a:r>
-              <a:rPr lang="en-US" sz="2250" dirty="0" spc="-17" kern="0">
+              <a:t> ghi</a:t>
+            </a:r>
+            <a:r>
+              <a:rPr lang="en-US" sz="2250" dirty="0" spc="1" kern="0">
+                <a:solidFill>
+                  <a:srgbClr val="14161C"/>
+                </a:solidFill>
+                <a:latin typeface="Be Vietnam Pro" pitchFamily="34" charset="0"/>
+                <a:ea typeface="Be Vietnam Pro" pitchFamily="34" charset="-122"/>
+                <a:cs typeface="Be Vietnam Pro" pitchFamily="34" charset="-120"/>
+              </a:rPr>
+              <a:t> chung</a:t>
+            </a:r>
+            <a:r>
+              <a:rPr lang="en-US" sz="2250" dirty="0" spc="16" kern="0">
+                <a:solidFill>
+                  <a:srgbClr val="14161C"/>
+                </a:solidFill>
+                <a:latin typeface="Be Vietnam Pro" pitchFamily="34" charset="0"/>
+                <a:ea typeface="Be Vietnam Pro" pitchFamily="34" charset="-122"/>
+                <a:cs typeface="Be Vietnam Pro" pitchFamily="34" charset="-120"/>
+              </a:rPr>
+              <a:t> để</a:t>
+            </a:r>
+            <a:r>
+              <a:rPr lang="en-US" sz="2250" dirty="0" spc="-2" kern="0">
+                <a:solidFill>
+                  <a:srgbClr val="14161C"/>
+                </a:solidFill>
+                <a:latin typeface="Be Vietnam Pro" pitchFamily="34" charset="0"/>
+                <a:ea typeface="Be Vietnam Pro" pitchFamily="34" charset="-122"/>
+                <a:cs typeface="Be Vietnam Pro" pitchFamily="34" charset="-120"/>
+              </a:rPr>
+              <a:t> hai</a:t>
+            </a:r>
+            <a:r>
+              <a:rPr lang="en-US" sz="2250" dirty="0" spc="0" kern="0">
+                <a:solidFill>
+                  <a:srgbClr val="14161C"/>
+                </a:solidFill>
+                <a:latin typeface="Be Vietnam Pro" pitchFamily="34" charset="0"/>
+                <a:ea typeface="Be Vietnam Pro" pitchFamily="34" charset="-122"/>
+                <a:cs typeface="Be Vietnam Pro" pitchFamily="34" charset="-120"/>
+              </a:rPr>
+              <a:t> hệ</a:t>
+            </a:r>
+            <a:r>
+              <a:rPr lang="en-US" sz="2250" dirty="0" spc="1" kern="0">
+                <a:solidFill>
+                  <a:srgbClr val="14161C"/>
+                </a:solidFill>
+                <a:latin typeface="Be Vietnam Pro" pitchFamily="34" charset="0"/>
+                <a:ea typeface="Be Vietnam Pro" pitchFamily="34" charset="-122"/>
+                <a:cs typeface="Be Vietnam Pro" pitchFamily="34" charset="-120"/>
+              </a:rPr>
+              <a:t> thống</a:t>
+            </a:r>
+            <a:r>
+              <a:rPr lang="en-US" sz="2250" dirty="0" spc="-1" kern="0">
+                <a:solidFill>
+                  <a:srgbClr val="14161C"/>
+                </a:solidFill>
+                <a:latin typeface="Be Vietnam Pro" pitchFamily="34" charset="0"/>
+                <a:ea typeface="Be Vietnam Pro" pitchFamily="34" charset="-122"/>
+                <a:cs typeface="Be Vietnam Pro" pitchFamily="34" charset="-120"/>
+              </a:rPr>
+              <a:t> hiểu</a:t>
+            </a:r>
+            <a:r>
+              <a:rPr lang="en-US" sz="2250" dirty="0" spc="2" kern="0">
+                <a:solidFill>
+                  <a:srgbClr val="14161C"/>
+                </a:solidFill>
+                <a:latin typeface="Be Vietnam Pro" pitchFamily="34" charset="0"/>
+                <a:ea typeface="Be Vietnam Pro" pitchFamily="34" charset="-122"/>
+                <a:cs typeface="Be Vietnam Pro" pitchFamily="34" charset="-120"/>
+              </a:rPr>
+              <a:t> cùng</a:t>
+            </a:r>
+            <a:r>
+              <a:rPr lang="en-US" sz="2250" dirty="0" spc="-4" kern="0">
+                <a:solidFill>
+                  <a:srgbClr val="14161C"/>
+                </a:solidFill>
+                <a:latin typeface="Be Vietnam Pro" pitchFamily="34" charset="0"/>
+                <a:ea typeface="Be Vietnam Pro" pitchFamily="34" charset="-122"/>
+                <a:cs typeface="Be Vietnam Pro" pitchFamily="34" charset="-120"/>
+              </a:rPr>
+              <a:t> một</a:t>
+            </a:r>
+            <a:r>
+              <a:rPr lang="en-US" sz="2250" dirty="0" spc="-16" kern="0">
                 <a:solidFill>
                   <a:srgbClr val="14161C"/>
                 </a:solidFill>
@@ -17533,61 +17676,6 @@
               <a:t> ngày</a:t>
             </a:r>
             <a:r>
-              <a:rPr lang="en-US" sz="2250" dirty="0" spc="0" kern="0">
-                <a:solidFill>
-                  <a:srgbClr val="14161C"/>
-                </a:solidFill>
-                <a:latin typeface="Be Vietnam Pro" pitchFamily="34" charset="0"/>
-                <a:ea typeface="Be Vietnam Pro" pitchFamily="34" charset="-122"/>
-                <a:cs typeface="Be Vietnam Pro" pitchFamily="34" charset="-120"/>
-              </a:rPr>
-              <a:t> giờ</a:t>
-            </a:r>
-            <a:r>
-              <a:rPr lang="en-US" sz="2250" dirty="0" spc="2" kern="0">
-                <a:solidFill>
-                  <a:srgbClr val="14161C"/>
-                </a:solidFill>
-                <a:latin typeface="Be Vietnam Pro" pitchFamily="34" charset="0"/>
-                <a:ea typeface="Be Vietnam Pro" pitchFamily="34" charset="-122"/>
-                <a:cs typeface="Be Vietnam Pro" pitchFamily="34" charset="-120"/>
-              </a:rPr>
-              <a:t> do</a:t>
-            </a:r>
-            <a:r>
-              <a:rPr lang="en-US" sz="2250" dirty="0" spc="11" kern="0">
-                <a:solidFill>
-                  <a:srgbClr val="14161C"/>
-                </a:solidFill>
-                <a:latin typeface="Be Vietnam Pro" pitchFamily="34" charset="0"/>
-                <a:ea typeface="Be Vietnam Pro" pitchFamily="34" charset="-122"/>
-                <a:cs typeface="Be Vietnam Pro" pitchFamily="34" charset="-120"/>
-              </a:rPr>
-              <a:t> ISO</a:t>
-            </a:r>
-            <a:r>
-              <a:rPr lang="en-US" sz="2250" dirty="0" spc="-7" kern="0">
-                <a:solidFill>
-                  <a:srgbClr val="14161C"/>
-                </a:solidFill>
-                <a:latin typeface="Be Vietnam Pro" pitchFamily="34" charset="0"/>
-                <a:ea typeface="Be Vietnam Pro" pitchFamily="34" charset="-122"/>
-                <a:cs typeface="Be Vietnam Pro" pitchFamily="34" charset="-120"/>
-              </a:rPr>
-              <a:t> soạn,</a:t>
-            </a:r>
-            <a:r>
-              <a:rPr lang="en-US" sz="2250" dirty="0" spc="3" kern="0">
-                <a:solidFill>
-                  <a:srgbClr val="14161C"/>
-                </a:solidFill>
-                <a:latin typeface="Be Vietnam Pro" pitchFamily="34" charset="0"/>
-                <a:ea typeface="Be Vietnam Pro" pitchFamily="34" charset="-122"/>
-                <a:cs typeface="Be Vietnam Pro" pitchFamily="34" charset="-120"/>
-              </a:rPr>
-              <a:t> dùng</a:t>
-            </a:r>
-            <a:r>
               <a:rPr lang="en-US" sz="2250" dirty="0" spc="1" kern="0">
                 <a:solidFill>
                   <a:srgbClr val="14161C"/>
@@ -17596,84 +17684,7 @@
                 <a:ea typeface="Be Vietnam Pro" pitchFamily="34" charset="-122"/>
                 <a:cs typeface="Be Vietnam Pro" pitchFamily="34" charset="-120"/>
               </a:rPr>
-              <a:t> chung</a:t>
-            </a:r>
-            <a:r>
-              <a:rPr lang="en-US" sz="2250" dirty="0" spc="6" kern="0">
-                <a:solidFill>
-                  <a:srgbClr val="14161C"/>
-                </a:solidFill>
-                <a:latin typeface="Be Vietnam Pro" pitchFamily="34" charset="0"/>
-                <a:ea typeface="Be Vietnam Pro" pitchFamily="34" charset="-122"/>
-                <a:cs typeface="Be Vietnam Pro" pitchFamily="34" charset="-120"/>
-              </a:rPr>
-              <a:t> giữa</a:t>
-            </a:r>
-            <a:r>
-              <a:rPr lang="en-US" sz="2250" dirty="0" spc="2" kern="0">
-                <a:solidFill>
-                  <a:srgbClr val="14161C"/>
-                </a:solidFill>
-                <a:latin typeface="Be Vietnam Pro" pitchFamily="34" charset="0"/>
-                <a:ea typeface="Be Vietnam Pro" pitchFamily="34" charset="-122"/>
-                <a:cs typeface="Be Vietnam Pro" pitchFamily="34" charset="-120"/>
-              </a:rPr>
-              <a:t> các</a:t>
-            </a:r>
-            <a:r>
-              <a:rPr lang="en-US" sz="2250" dirty="0" spc="6" kern="0">
-                <a:solidFill>
-                  <a:srgbClr val="14161C"/>
-                </a:solidFill>
-                <a:latin typeface="Be Vietnam Pro" pitchFamily="34" charset="0"/>
-                <a:ea typeface="Be Vietnam Pro" pitchFamily="34" charset="-122"/>
-                <a:cs typeface="Be Vietnam Pro" pitchFamily="34" charset="-120"/>
-              </a:rPr>
-              <a:t> nước,</a:t>
-            </a:r>
-            <a:r>
-              <a:rPr lang="en-US" sz="2250" dirty="0" spc="-12" kern="0">
-                <a:solidFill>
-                  <a:srgbClr val="14161C"/>
-                </a:solidFill>
-                <a:latin typeface="Be Vietnam Pro" pitchFamily="34" charset="0"/>
-                <a:ea typeface="Be Vietnam Pro" pitchFamily="34" charset="-122"/>
-                <a:cs typeface="Be Vietnam Pro" pitchFamily="34" charset="-120"/>
-              </a:rPr>
-              <a:t> văn</a:t>
-            </a:r>
-            <a:r>
-              <a:rPr lang="en-US" sz="2250" dirty="0" spc="-2" kern="0">
-                <a:solidFill>
-                  <a:srgbClr val="14161C"/>
-                </a:solidFill>
-                <a:latin typeface="Be Vietnam Pro" pitchFamily="34" charset="0"/>
-                <a:ea typeface="Be Vietnam Pro" pitchFamily="34" charset="-122"/>
-                <a:cs typeface="Be Vietnam Pro" pitchFamily="34" charset="-120"/>
-              </a:rPr>
-              <a:t> hóa</a:t>
-            </a:r>
-            <a:r>
-              <a:rPr lang="en-US" sz="2250" dirty="0" spc="-16" kern="0">
-                <a:solidFill>
-                  <a:srgbClr val="14161C"/>
-                </a:solidFill>
-                <a:latin typeface="Be Vietnam Pro" pitchFamily="34" charset="0"/>
-                <a:ea typeface="Be Vietnam Pro" pitchFamily="34" charset="-122"/>
-                <a:cs typeface="Be Vietnam Pro" pitchFamily="34" charset="-120"/>
-              </a:rPr>
-              <a:t> và</a:t>
-            </a:r>
-            <a:r>
-              <a:rPr lang="en-US" sz="2250" dirty="0" spc="-6" kern="0">
-                <a:solidFill>
-                  <a:srgbClr val="14161C"/>
-                </a:solidFill>
-                <a:latin typeface="Be Vietnam Pro" pitchFamily="34" charset="0"/>
-                <a:ea typeface="Be Vietnam Pro" pitchFamily="34" charset="-122"/>
-                <a:cs typeface="Be Vietnam Pro" pitchFamily="34" charset="-120"/>
-              </a:rPr>
-              <a:t> ngành.</a:t>
+              <a:t> giờ.</a:t>
             </a:r>
             <a:endParaRPr lang="en-US" sz="2250" dirty="0"/>
           </a:p>
@@ -17883,15 +17894,92 @@
               <a:buNone/>
             </a:pPr>
             <a:r>
-              <a:rPr lang="en-US" sz="2250" dirty="0" spc="-4" kern="0">
-                <a:solidFill>
-                  <a:srgbClr val="14161C"/>
-                </a:solidFill>
-                <a:latin typeface="Be Vietnam Pro" pitchFamily="34" charset="0"/>
-                <a:ea typeface="Be Vietnam Pro" pitchFamily="34" charset="-122"/>
-                <a:cs typeface="Be Vietnam Pro" pitchFamily="34" charset="-120"/>
-              </a:rPr>
-              <a:t>Cho</a:t>
+              <a:rPr lang="en-US" sz="2250" dirty="0" spc="0" kern="0">
+                <a:solidFill>
+                  <a:srgbClr val="14161C"/>
+                </a:solidFill>
+                <a:latin typeface="Be Vietnam Pro" pitchFamily="34" charset="0"/>
+                <a:ea typeface="Be Vietnam Pro" pitchFamily="34" charset="-122"/>
+                <a:cs typeface="Be Vietnam Pro" pitchFamily="34" charset="-120"/>
+              </a:rPr>
+              <a:t>Ứng</a:t>
+            </a:r>
+            <a:r>
+              <a:rPr lang="en-US" sz="2250" dirty="0" spc="3" kern="0">
+                <a:solidFill>
+                  <a:srgbClr val="14161C"/>
+                </a:solidFill>
+                <a:latin typeface="Be Vietnam Pro" pitchFamily="34" charset="0"/>
+                <a:ea typeface="Be Vietnam Pro" pitchFamily="34" charset="-122"/>
+                <a:cs typeface="Be Vietnam Pro" pitchFamily="34" charset="-120"/>
+              </a:rPr>
+              <a:t> dụng</a:t>
+            </a:r>
+            <a:r>
+              <a:rPr lang="en-US" sz="2250" dirty="0" spc="-1" kern="0">
+                <a:solidFill>
+                  <a:srgbClr val="14161C"/>
+                </a:solidFill>
+                <a:latin typeface="Be Vietnam Pro" pitchFamily="34" charset="0"/>
+                <a:ea typeface="Be Vietnam Pro" pitchFamily="34" charset="-122"/>
+                <a:cs typeface="Be Vietnam Pro" pitchFamily="34" charset="-120"/>
+              </a:rPr>
+              <a:t> cầm mã</a:t>
+            </a:r>
+            <a:r>
+              <a:rPr lang="en-US" sz="2250" dirty="0" spc="0" kern="0">
+                <a:solidFill>
+                  <a:srgbClr val="14161C"/>
+                </a:solidFill>
+                <a:latin typeface="Be Vietnam Pro" pitchFamily="34" charset="0"/>
+                <a:ea typeface="Be Vietnam Pro" pitchFamily="34" charset="-122"/>
+                <a:cs typeface="Be Vietnam Pro" pitchFamily="34" charset="-120"/>
+              </a:rPr>
+              <a:t> truy</a:t>
+            </a:r>
+            <a:r>
+              <a:rPr lang="en-US" sz="2250" dirty="0" spc="2" kern="0">
+                <a:solidFill>
+                  <a:srgbClr val="14161C"/>
+                </a:solidFill>
+                <a:latin typeface="Be Vietnam Pro" pitchFamily="34" charset="0"/>
+                <a:ea typeface="Be Vietnam Pro" pitchFamily="34" charset="-122"/>
+                <a:cs typeface="Be Vietnam Pro" pitchFamily="34" charset="-120"/>
+              </a:rPr>
+              <a:t> cập</a:t>
+            </a:r>
+            <a:r>
+              <a:rPr lang="en-US" sz="2250" dirty="0" spc="4" kern="0">
+                <a:solidFill>
+                  <a:srgbClr val="14161C"/>
+                </a:solidFill>
+                <a:latin typeface="Be Vietnam Pro" pitchFamily="34" charset="0"/>
+                <a:ea typeface="Be Vietnam Pro" pitchFamily="34" charset="-122"/>
+                <a:cs typeface="Be Vietnam Pro" pitchFamily="34" charset="-120"/>
+              </a:rPr>
+              <a:t> có</a:t>
+            </a:r>
+            <a:r>
+              <a:rPr lang="en-US" sz="2250" dirty="0" spc="0" kern="0">
+                <a:solidFill>
+                  <a:srgbClr val="14161C"/>
+                </a:solidFill>
+                <a:latin typeface="Be Vietnam Pro" pitchFamily="34" charset="0"/>
+                <a:ea typeface="Be Vietnam Pro" pitchFamily="34" charset="-122"/>
+                <a:cs typeface="Be Vietnam Pro" pitchFamily="34" charset="-120"/>
+              </a:rPr>
+              <a:t> phạm</a:t>
+            </a:r>
+            <a:r>
+              <a:rPr lang="en-US" sz="2250" dirty="0" spc="-2" kern="0">
+                <a:solidFill>
+                  <a:srgbClr val="14161C"/>
+                </a:solidFill>
+                <a:latin typeface="Be Vietnam Pro" pitchFamily="34" charset="0"/>
+                <a:ea typeface="Be Vietnam Pro" pitchFamily="34" charset="-122"/>
+                <a:cs typeface="Be Vietnam Pro" pitchFamily="34" charset="-120"/>
+              </a:rPr>
+              <a:t> vi</a:t>
             </a:r>
             <a:r>
               <a:rPr lang="en-US" sz="2250" dirty="0" spc="-16" kern="0">
@@ -17902,62 +17990,18 @@
                 <a:ea typeface="Be Vietnam Pro" pitchFamily="34" charset="-122"/>
                 <a:cs typeface="Be Vietnam Pro" pitchFamily="34" charset="-120"/>
               </a:rPr>
-              <a:t> trang</a:t>
-            </a:r>
-            <a:r>
-              <a:rPr lang="en-US" sz="2250" dirty="0" spc="-11" kern="0">
-                <a:solidFill>
-                  <a:srgbClr val="14161C"/>
-                </a:solidFill>
-                <a:latin typeface="Be Vietnam Pro" pitchFamily="34" charset="0"/>
-                <a:ea typeface="Be Vietnam Pro" pitchFamily="34" charset="-122"/>
-                <a:cs typeface="Be Vietnam Pro" pitchFamily="34" charset="-120"/>
-              </a:rPr>
-              <a:t> web</a:t>
-            </a:r>
-            <a:r>
-              <a:rPr lang="en-US" sz="2250" dirty="0" spc="-3" kern="0">
-                <a:solidFill>
-                  <a:srgbClr val="14161C"/>
-                </a:solidFill>
-                <a:latin typeface="Be Vietnam Pro" pitchFamily="34" charset="0"/>
-                <a:ea typeface="Be Vietnam Pro" pitchFamily="34" charset="-122"/>
-                <a:cs typeface="Be Vietnam Pro" pitchFamily="34" charset="-120"/>
-              </a:rPr>
-              <a:t> hoặc</a:t>
-            </a:r>
-            <a:r>
-              <a:rPr lang="en-US" sz="2250" dirty="0" spc="25" kern="0">
-                <a:solidFill>
-                  <a:srgbClr val="14161C"/>
-                </a:solidFill>
-                <a:latin typeface="Be Vietnam Pro" pitchFamily="34" charset="0"/>
-                <a:ea typeface="Be Vietnam Pro" pitchFamily="34" charset="-122"/>
-                <a:cs typeface="Be Vietnam Pro" pitchFamily="34" charset="-120"/>
-              </a:rPr>
-              <a:t> ứng</a:t>
-            </a:r>
-            <a:r>
-              <a:rPr lang="en-US" sz="2250" dirty="0" spc="2" kern="0">
-                <a:solidFill>
-                  <a:srgbClr val="14161C"/>
-                </a:solidFill>
-                <a:latin typeface="Be Vietnam Pro" pitchFamily="34" charset="0"/>
-                <a:ea typeface="Be Vietnam Pro" pitchFamily="34" charset="-122"/>
-                <a:cs typeface="Be Vietnam Pro" pitchFamily="34" charset="-120"/>
-              </a:rPr>
-              <a:t> dụng</a:t>
-            </a:r>
-            <a:r>
-              <a:rPr lang="en-US" sz="2250" dirty="0" spc="-12" kern="0">
-                <a:solidFill>
-                  <a:srgbClr val="14161C"/>
-                </a:solidFill>
-                <a:latin typeface="Be Vietnam Pro" pitchFamily="34" charset="0"/>
-                <a:ea typeface="Be Vietnam Pro" pitchFamily="34" charset="-122"/>
-                <a:cs typeface="Be Vietnam Pro" pitchFamily="34" charset="-120"/>
-              </a:rPr>
-              <a:t> quyền</a:t>
+              <a:t> và</a:t>
+            </a:r>
+            <a:r>
+              <a:rPr lang="en-US" sz="2250" dirty="0" spc="0" kern="0">
+                <a:solidFill>
+                  <a:srgbClr val="14161C"/>
+                </a:solidFill>
+                <a:latin typeface="Be Vietnam Pro" pitchFamily="34" charset="0"/>
+                <a:ea typeface="Be Vietnam Pro" pitchFamily="34" charset="-122"/>
+                <a:cs typeface="Be Vietnam Pro" pitchFamily="34" charset="-120"/>
+              </a:rPr>
+              <a:t> thời</a:t>
             </a:r>
             <a:r>
               <a:rPr lang="en-US" sz="2250" dirty="0" spc="-1" kern="0">
@@ -17968,18 +18012,7 @@
                 <a:ea typeface="Be Vietnam Pro" pitchFamily="34" charset="-122"/>
                 <a:cs typeface="Be Vietnam Pro" pitchFamily="34" charset="-120"/>
               </a:rPr>
-              <a:t> truy</a:t>
-            </a:r>
-            <a:r>
-              <a:rPr lang="en-US" sz="2250" dirty="0" spc="2" kern="0">
-                <a:solidFill>
-                  <a:srgbClr val="14161C"/>
-                </a:solidFill>
-                <a:latin typeface="Be Vietnam Pro" pitchFamily="34" charset="0"/>
-                <a:ea typeface="Be Vietnam Pro" pitchFamily="34" charset="-122"/>
-                <a:cs typeface="Be Vietnam Pro" pitchFamily="34" charset="-120"/>
-              </a:rPr>
-              <a:t> cập</a:t>
+              <a:t> hạn,</a:t>
             </a:r>
             <a:r>
               <a:rPr lang="en-US" sz="2250" dirty="0" spc="1" kern="0">
@@ -17990,65 +18023,21 @@
                 <a:ea typeface="Be Vietnam Pro" pitchFamily="34" charset="-122"/>
                 <a:cs typeface="Be Vietnam Pro" pitchFamily="34" charset="-120"/>
               </a:rPr>
-              <a:t> hạn</a:t>
-            </a:r>
-            <a:r>
-              <a:rPr lang="en-US" sz="2250" dirty="0" spc="0" kern="0">
-                <a:solidFill>
-                  <a:srgbClr val="14161C"/>
-                </a:solidFill>
-                <a:latin typeface="Be Vietnam Pro" pitchFamily="34" charset="0"/>
-                <a:ea typeface="Be Vietnam Pro" pitchFamily="34" charset="-122"/>
-                <a:cs typeface="Be Vietnam Pro" pitchFamily="34" charset="-120"/>
-              </a:rPr>
-              <a:t> chế</a:t>
-            </a:r>
-            <a:r>
-              <a:rPr lang="en-US" sz="2250" dirty="0" spc="-1" kern="0">
-                <a:solidFill>
-                  <a:srgbClr val="14161C"/>
-                </a:solidFill>
-                <a:latin typeface="Be Vietnam Pro" pitchFamily="34" charset="0"/>
-                <a:ea typeface="Be Vietnam Pro" pitchFamily="34" charset="-122"/>
-                <a:cs typeface="Be Vietnam Pro" pitchFamily="34" charset="-120"/>
-              </a:rPr>
-              <a:t> mà</a:t>
+              <a:t> không cầm</a:t>
+            </a:r>
+            <a:r>
+              <a:rPr lang="en-US" sz="2250" dirty="0" spc="-13" kern="0">
+                <a:solidFill>
+                  <a:srgbClr val="14161C"/>
+                </a:solidFill>
+                <a:latin typeface="Be Vietnam Pro" pitchFamily="34" charset="0"/>
+                <a:ea typeface="Be Vietnam Pro" pitchFamily="34" charset="-122"/>
+                <a:cs typeface="Be Vietnam Pro" pitchFamily="34" charset="-120"/>
+              </a:rPr>
+              <a:t> mật</a:t>
             </a:r>
             <a:r>
               <a:rPr lang="en-US" sz="2250" dirty="0" spc="1" kern="0">
-                <a:solidFill>
-                  <a:srgbClr val="14161C"/>
-                </a:solidFill>
-                <a:latin typeface="Be Vietnam Pro" pitchFamily="34" charset="0"/>
-                <a:ea typeface="Be Vietnam Pro" pitchFamily="34" charset="-122"/>
-                <a:cs typeface="Be Vietnam Pro" pitchFamily="34" charset="-120"/>
-              </a:rPr>
-              <a:t> không</a:t>
-            </a:r>
-            <a:r>
-              <a:rPr lang="en-US" sz="2250" dirty="0" spc="3" kern="0">
-                <a:solidFill>
-                  <a:srgbClr val="14161C"/>
-                </a:solidFill>
-                <a:latin typeface="Be Vietnam Pro" pitchFamily="34" charset="0"/>
-                <a:ea typeface="Be Vietnam Pro" pitchFamily="34" charset="-122"/>
-                <a:cs typeface="Be Vietnam Pro" pitchFamily="34" charset="-120"/>
-              </a:rPr>
-              <a:t> lộ</a:t>
-            </a:r>
-            <a:r>
-              <a:rPr lang="en-US" sz="2250" dirty="0" spc="-12" kern="0">
-                <a:solidFill>
-                  <a:srgbClr val="14161C"/>
-                </a:solidFill>
-                <a:latin typeface="Be Vietnam Pro" pitchFamily="34" charset="0"/>
-                <a:ea typeface="Be Vietnam Pro" pitchFamily="34" charset="-122"/>
-                <a:cs typeface="Be Vietnam Pro" pitchFamily="34" charset="-120"/>
-              </a:rPr>
-              <a:t> mật</a:t>
-            </a:r>
-            <a:r>
-              <a:rPr lang="en-US" sz="2250" dirty="0" spc="0" kern="0">
                 <a:solidFill>
                   <a:srgbClr val="14161C"/>
                 </a:solidFill>
@@ -19121,7 +19110,7 @@
               <a:buNone/>
             </a:pPr>
             <a:r>
-              <a:rPr lang="en-US" sz="6600" dirty="0" spc="4" kern="0">
+              <a:rPr lang="en-US" sz="6600" dirty="0" spc="-45" kern="0">
                 <a:solidFill>
                   <a:srgbClr val="7C93FF"/>
                 </a:solidFill>
@@ -19129,7 +19118,7 @@
                 <a:ea typeface="Bricolage Grotesque ExtraBold" pitchFamily="34" charset="-122"/>
                 <a:cs typeface="Bricolage Grotesque ExtraBold" pitchFamily="34" charset="-120"/>
               </a:rPr>
-              <a:t>IETF</a:t>
+              <a:t>RFC</a:t>
             </a:r>
             <a:endParaRPr lang="en-US" sz="6600" dirty="0"/>
           </a:p>
@@ -19163,7 +19152,7 @@
               <a:buNone/>
             </a:pPr>
             <a:r>
-              <a:rPr lang="en-US" sz="1950" dirty="0" spc="-10" kern="0">
+              <a:rPr lang="en-US" sz="1950" dirty="0" spc="-16" kern="0">
                 <a:solidFill>
                   <a:srgbClr val="C4C8D6"/>
                 </a:solidFill>
@@ -19171,10 +19160,10 @@
                 <a:ea typeface="Be Vietnam Pro" pitchFamily="34" charset="-122"/>
                 <a:cs typeface="Be Vietnam Pro" pitchFamily="34" charset="-120"/>
               </a:rPr>
-              <a:t>Internet</a:t>
-            </a:r>
-            <a:r>
-              <a:rPr lang="en-US" sz="1950" dirty="0" spc="6" kern="0">
+              <a:t>Request</a:t>
+            </a:r>
+            <a:r>
+              <a:rPr lang="en-US" sz="1950" dirty="0" spc="-25" kern="0">
                 <a:solidFill>
                   <a:srgbClr val="C4C8D6"/>
                 </a:solidFill>
@@ -19182,10 +19171,10 @@
                 <a:ea typeface="Be Vietnam Pro" pitchFamily="34" charset="-122"/>
                 <a:cs typeface="Be Vietnam Pro" pitchFamily="34" charset="-120"/>
               </a:rPr>
-              <a:t> Engineering</a:t>
-            </a:r>
-            <a:r>
-              <a:rPr lang="en-US" sz="1950" dirty="0" spc="-36" kern="0">
+              <a:t> For</a:t>
+            </a:r>
+            <a:r>
+              <a:rPr lang="en-US" sz="1950" dirty="0" spc="-2" kern="0">
                 <a:solidFill>
                   <a:srgbClr val="C4C8D6"/>
                 </a:solidFill>
@@ -19193,18 +19182,7 @@
                 <a:ea typeface="Be Vietnam Pro" pitchFamily="34" charset="-122"/>
                 <a:cs typeface="Be Vietnam Pro" pitchFamily="34" charset="-120"/>
               </a:rPr>
-              <a:t> Task</a:t>
-            </a:r>
-            <a:r>
-              <a:rPr lang="en-US" sz="1950" dirty="0" spc="-29" kern="0">
-                <a:solidFill>
-                  <a:srgbClr val="C4C8D6"/>
-                </a:solidFill>
-                <a:latin typeface="Be Vietnam Pro" pitchFamily="34" charset="0"/>
-                <a:ea typeface="Be Vietnam Pro" pitchFamily="34" charset="-122"/>
-                <a:cs typeface="Be Vietnam Pro" pitchFamily="34" charset="-120"/>
-              </a:rPr>
-              <a:t> Force</a:t>
+              <a:t> Comments</a:t>
             </a:r>
             <a:endParaRPr lang="en-US" sz="1950" dirty="0"/>
           </a:p>
@@ -19238,37 +19216,37 @@
               <a:buNone/>
             </a:pPr>
             <a:r>
-              <a:rPr lang="en-US" sz="2250" dirty="0" spc="-1" kern="0">
-                <a:solidFill>
-                  <a:srgbClr val="F3EEE3"/>
-                </a:solidFill>
-                <a:latin typeface="Be Vietnam Pro" pitchFamily="34" charset="0"/>
-                <a:ea typeface="Be Vietnam Pro" pitchFamily="34" charset="-122"/>
-                <a:cs typeface="Be Vietnam Pro" pitchFamily="34" charset="-120"/>
-              </a:rPr>
-              <a:t>Cộng</a:t>
-            </a:r>
-            <a:r>
-              <a:rPr lang="en-US" sz="2250" dirty="0" spc="11" kern="0">
-                <a:solidFill>
-                  <a:srgbClr val="F3EEE3"/>
-                </a:solidFill>
-                <a:latin typeface="Be Vietnam Pro" pitchFamily="34" charset="0"/>
-                <a:ea typeface="Be Vietnam Pro" pitchFamily="34" charset="-122"/>
-                <a:cs typeface="Be Vietnam Pro" pitchFamily="34" charset="-120"/>
-              </a:rPr>
-              <a:t> đồng</a:t>
-            </a:r>
-            <a:r>
-              <a:rPr lang="en-US" sz="2250" dirty="0" spc="-6" kern="0">
-                <a:solidFill>
-                  <a:srgbClr val="F3EEE3"/>
-                </a:solidFill>
-                <a:latin typeface="Be Vietnam Pro" pitchFamily="34" charset="0"/>
-                <a:ea typeface="Be Vietnam Pro" pitchFamily="34" charset="-122"/>
-                <a:cs typeface="Be Vietnam Pro" pitchFamily="34" charset="-120"/>
-              </a:rPr>
-              <a:t> soạn</a:t>
+              <a:rPr lang="en-US" sz="2250" dirty="0" spc="-38" kern="0">
+                <a:solidFill>
+                  <a:srgbClr val="F3EEE3"/>
+                </a:solidFill>
+                <a:latin typeface="Be Vietnam Pro" pitchFamily="34" charset="0"/>
+                <a:ea typeface="Be Vietnam Pro" pitchFamily="34" charset="-122"/>
+                <a:cs typeface="Be Vietnam Pro" pitchFamily="34" charset="-120"/>
+              </a:rPr>
+              <a:t>Loạt</a:t>
+            </a:r>
+            <a:r>
+              <a:rPr lang="en-US" sz="2250" dirty="0" spc="-12" kern="0">
+                <a:solidFill>
+                  <a:srgbClr val="F3EEE3"/>
+                </a:solidFill>
+                <a:latin typeface="Be Vietnam Pro" pitchFamily="34" charset="0"/>
+                <a:ea typeface="Be Vietnam Pro" pitchFamily="34" charset="-122"/>
+                <a:cs typeface="Be Vietnam Pro" pitchFamily="34" charset="-120"/>
+              </a:rPr>
+              <a:t> văn</a:t>
+            </a:r>
+            <a:r>
+              <a:rPr lang="en-US" sz="2250" dirty="0" spc="-2" kern="0">
+                <a:solidFill>
+                  <a:srgbClr val="F3EEE3"/>
+                </a:solidFill>
+                <a:latin typeface="Be Vietnam Pro" pitchFamily="34" charset="0"/>
+                <a:ea typeface="Be Vietnam Pro" pitchFamily="34" charset="-122"/>
+                <a:cs typeface="Be Vietnam Pro" pitchFamily="34" charset="-120"/>
+              </a:rPr>
+              <a:t> bản</a:t>
             </a:r>
             <a:r>
               <a:rPr lang="en-US" sz="2250" dirty="0" spc="1" kern="0">
@@ -19279,51 +19257,84 @@
                 <a:ea typeface="Be Vietnam Pro" pitchFamily="34" charset="-122"/>
                 <a:cs typeface="Be Vietnam Pro" pitchFamily="34" charset="-120"/>
               </a:rPr>
-              <a:t> các</a:t>
-            </a:r>
-            <a:r>
-              <a:rPr lang="en-US" sz="2250" dirty="0" spc="-1" kern="0">
-                <a:solidFill>
-                  <a:srgbClr val="F3EEE3"/>
-                </a:solidFill>
-                <a:latin typeface="Be Vietnam Pro" pitchFamily="34" charset="0"/>
-                <a:ea typeface="Be Vietnam Pro" pitchFamily="34" charset="-122"/>
-                <a:cs typeface="Be Vietnam Pro" pitchFamily="34" charset="-120"/>
-              </a:rPr>
-              <a:t> tiêu</a:t>
-            </a:r>
-            <a:r>
-              <a:rPr lang="en-US" sz="2250" dirty="0" spc="0" kern="0">
-                <a:solidFill>
-                  <a:srgbClr val="F3EEE3"/>
-                </a:solidFill>
-                <a:latin typeface="Be Vietnam Pro" pitchFamily="34" charset="0"/>
-                <a:ea typeface="Be Vietnam Pro" pitchFamily="34" charset="-122"/>
-                <a:cs typeface="Be Vietnam Pro" pitchFamily="34" charset="-120"/>
-              </a:rPr>
-              <a:t> chuẩn</a:t>
-            </a:r>
-            <a:r>
-              <a:rPr lang="en-US" sz="2250" dirty="0" spc="3" kern="0">
-                <a:solidFill>
-                  <a:srgbClr val="F3EEE3"/>
-                </a:solidFill>
-                <a:latin typeface="Be Vietnam Pro" pitchFamily="34" charset="0"/>
-                <a:ea typeface="Be Vietnam Pro" pitchFamily="34" charset="-122"/>
-                <a:cs typeface="Be Vietnam Pro" pitchFamily="34" charset="-120"/>
-              </a:rPr>
-              <a:t> của</a:t>
-            </a:r>
-            <a:r>
-              <a:rPr lang="en-US" sz="2250" dirty="0" spc="-10" kern="0">
-                <a:solidFill>
-                  <a:srgbClr val="F3EEE3"/>
-                </a:solidFill>
-                <a:latin typeface="Be Vietnam Pro" pitchFamily="34" charset="0"/>
-                <a:ea typeface="Be Vietnam Pro" pitchFamily="34" charset="-122"/>
-                <a:cs typeface="Be Vietnam Pro" pitchFamily="34" charset="-120"/>
-              </a:rPr>
-              <a:t> Internet.</a:t>
+              <a:t> kỹ</a:t>
+            </a:r>
+            <a:r>
+              <a:rPr lang="en-US" sz="2250" dirty="0" spc="-8" kern="0">
+                <a:solidFill>
+                  <a:srgbClr val="F3EEE3"/>
+                </a:solidFill>
+                <a:latin typeface="Be Vietnam Pro" pitchFamily="34" charset="0"/>
+                <a:ea typeface="Be Vietnam Pro" pitchFamily="34" charset="-122"/>
+                <a:cs typeface="Be Vietnam Pro" pitchFamily="34" charset="-120"/>
+              </a:rPr>
+              <a:t> thuật</a:t>
+            </a:r>
+            <a:r>
+              <a:rPr lang="en-US" sz="2250" dirty="0" spc="-16" kern="0">
+                <a:solidFill>
+                  <a:srgbClr val="F3EEE3"/>
+                </a:solidFill>
+                <a:latin typeface="Be Vietnam Pro" pitchFamily="34" charset="0"/>
+                <a:ea typeface="Be Vietnam Pro" pitchFamily="34" charset="-122"/>
+                <a:cs typeface="Be Vietnam Pro" pitchFamily="34" charset="-120"/>
+              </a:rPr>
+              <a:t> về</a:t>
+            </a:r>
+            <a:r>
+              <a:rPr lang="en-US" sz="2250" dirty="0" spc="-11" kern="0">
+                <a:solidFill>
+                  <a:srgbClr val="F3EEE3"/>
+                </a:solidFill>
+                <a:latin typeface="Be Vietnam Pro" pitchFamily="34" charset="0"/>
+                <a:ea typeface="Be Vietnam Pro" pitchFamily="34" charset="-122"/>
+                <a:cs typeface="Be Vietnam Pro" pitchFamily="34" charset="-120"/>
+              </a:rPr>
+              <a:t> Internet;</a:t>
+            </a:r>
+            <a:r>
+              <a:rPr lang="en-US" sz="2250" dirty="0" spc="-4" kern="0">
+                <a:solidFill>
+                  <a:srgbClr val="F3EEE3"/>
+                </a:solidFill>
+                <a:latin typeface="Be Vietnam Pro" pitchFamily="34" charset="0"/>
+                <a:ea typeface="Be Vietnam Pro" pitchFamily="34" charset="-122"/>
+                <a:cs typeface="Be Vietnam Pro" pitchFamily="34" charset="-120"/>
+              </a:rPr>
+              <a:t> bài</a:t>
+            </a:r>
+            <a:r>
+              <a:rPr lang="en-US" sz="2250" dirty="0" spc="1" kern="0">
+                <a:solidFill>
+                  <a:srgbClr val="F3EEE3"/>
+                </a:solidFill>
+                <a:latin typeface="Be Vietnam Pro" pitchFamily="34" charset="0"/>
+                <a:ea typeface="Be Vietnam Pro" pitchFamily="34" charset="-122"/>
+                <a:cs typeface="Be Vietnam Pro" pitchFamily="34" charset="-120"/>
+              </a:rPr>
+              <a:t> nhắc</a:t>
+            </a:r>
+            <a:r>
+              <a:rPr lang="en-US" sz="2250" dirty="0" spc="-11" kern="0">
+                <a:solidFill>
+                  <a:srgbClr val="F3EEE3"/>
+                </a:solidFill>
+                <a:latin typeface="Be Vietnam Pro" pitchFamily="34" charset="0"/>
+                <a:ea typeface="Be Vietnam Pro" pitchFamily="34" charset="-122"/>
+                <a:cs typeface="Be Vietnam Pro" pitchFamily="34" charset="-120"/>
+              </a:rPr>
+              <a:t> RFC</a:t>
+            </a:r>
+            <a:r>
+              <a:rPr lang="en-US" sz="2250" dirty="0" spc="-38" kern="0">
+                <a:solidFill>
+                  <a:srgbClr val="F3EEE3"/>
+                </a:solidFill>
+                <a:latin typeface="Be Vietnam Pro" pitchFamily="34" charset="0"/>
+                <a:ea typeface="Be Vietnam Pro" pitchFamily="34" charset="-122"/>
+                <a:cs typeface="Be Vietnam Pro" pitchFamily="34" charset="-120"/>
+              </a:rPr>
+              <a:t> 6749.</a:t>
             </a:r>
             <a:endParaRPr lang="en-US" sz="2250" dirty="0"/>
           </a:p>
@@ -20283,18 +20294,40 @@
                 <a:ea typeface="Be Vietnam Pro" pitchFamily="34" charset="-122"/>
                 <a:cs typeface="Be Vietnam Pro" pitchFamily="34" charset="-120"/>
               </a:rPr>
-              <a:t> Standard:</a:t>
-            </a:r>
-            <a:r>
-              <a:rPr lang="en-US" sz="2100" dirty="0" spc="6" kern="0">
-                <a:solidFill>
-                  <a:srgbClr val="F3EEE3"/>
-                </a:solidFill>
-                <a:latin typeface="Be Vietnam Pro" pitchFamily="34" charset="0"/>
-                <a:ea typeface="Be Vietnam Pro" pitchFamily="34" charset="-122"/>
-                <a:cs typeface="Be Vietnam Pro" pitchFamily="34" charset="-120"/>
-              </a:rPr>
-              <a:t> đọc</a:t>
+              <a:t> Standard;</a:t>
+            </a:r>
+            <a:r>
+              <a:rPr lang="en-US" sz="2100" dirty="0" spc="-6" kern="0">
+                <a:solidFill>
+                  <a:srgbClr val="F3EEE3"/>
+                </a:solidFill>
+                <a:latin typeface="Be Vietnam Pro" pitchFamily="34" charset="0"/>
+                <a:ea typeface="Be Vietnam Pro" pitchFamily="34" charset="-122"/>
+                <a:cs typeface="Be Vietnam Pro" pitchFamily="34" charset="-120"/>
+              </a:rPr>
+              <a:t> bản</a:t>
+            </a:r>
+            <a:r>
+              <a:rPr lang="en-US" sz="2100" dirty="0" spc="-2" kern="0">
+                <a:solidFill>
+                  <a:srgbClr val="F3EEE3"/>
+                </a:solidFill>
+                <a:latin typeface="Be Vietnam Pro" pitchFamily="34" charset="0"/>
+                <a:ea typeface="Be Vietnam Pro" pitchFamily="34" charset="-122"/>
+                <a:cs typeface="Be Vietnam Pro" pitchFamily="34" charset="-120"/>
+              </a:rPr>
+              <a:t> nháp</a:t>
+            </a:r>
+            <a:r>
+              <a:rPr lang="en-US" sz="2100" dirty="0" spc="-23" kern="0">
+                <a:solidFill>
+                  <a:srgbClr val="F3EEE3"/>
+                </a:solidFill>
+                <a:latin typeface="Be Vietnam Pro" pitchFamily="34" charset="0"/>
+                <a:ea typeface="Be Vietnam Pro" pitchFamily="34" charset="-122"/>
+                <a:cs typeface="Be Vietnam Pro" pitchFamily="34" charset="-120"/>
+              </a:rPr>
+              <a:t> OAuth</a:t>
             </a:r>
             <a:r>
               <a:rPr lang="en-US" sz="2100" dirty="0" spc="-1" kern="0">
@@ -20305,18 +20338,7 @@
                 <a:ea typeface="Be Vietnam Pro" pitchFamily="34" charset="-122"/>
                 <a:cs typeface="Be Vietnam Pro" pitchFamily="34" charset="-120"/>
               </a:rPr>
-              <a:t> từ kho</a:t>
-            </a:r>
-            <a:r>
-              <a:rPr lang="en-US" sz="2100" dirty="0" spc="-2" kern="0">
-                <a:solidFill>
-                  <a:srgbClr val="F3EEE3"/>
-                </a:solidFill>
-                <a:latin typeface="Be Vietnam Pro" pitchFamily="34" charset="0"/>
-                <a:ea typeface="Be Vietnam Pro" pitchFamily="34" charset="-122"/>
-                <a:cs typeface="Be Vietnam Pro" pitchFamily="34" charset="-120"/>
-              </a:rPr>
-              <a:t> mã</a:t>
+              <a:t> 2.1</a:t>
             </a:r>
             <a:endParaRPr lang="en-US" sz="2100" dirty="0"/>
           </a:p>
@@ -20341,15 +20363,26 @@
               <a:t>MDN:</a:t>
             </a:r>
             <a:r>
-              <a:rPr lang="en-US" sz="2100" dirty="0" spc="-9" kern="0">
-                <a:solidFill>
-                  <a:srgbClr val="F3EEE3"/>
-                </a:solidFill>
-                <a:latin typeface="Be Vietnam Pro" pitchFamily="34" charset="0"/>
-                <a:ea typeface="Be Vietnam Pro" pitchFamily="34" charset="-122"/>
-                <a:cs typeface="Be Vietnam Pro" pitchFamily="34" charset="-120"/>
-              </a:rPr>
-              <a:t> thuật</a:t>
+              <a:rPr lang="en-US" sz="2100" dirty="0" spc="-29" kern="0">
+                <a:solidFill>
+                  <a:srgbClr val="F3EEE3"/>
+                </a:solidFill>
+                <a:latin typeface="Be Vietnam Pro" pitchFamily="34" charset="0"/>
+                <a:ea typeface="Be Vietnam Pro" pitchFamily="34" charset="-122"/>
+                <a:cs typeface="Be Vietnam Pro" pitchFamily="34" charset="-120"/>
+              </a:rPr>
+              <a:t> TCP,</a:t>
+            </a:r>
+            <a:r>
+              <a:rPr lang="en-US" sz="2100" dirty="0" spc="0" kern="0">
+                <a:solidFill>
+                  <a:srgbClr val="F3EEE3"/>
+                </a:solidFill>
+                <a:latin typeface="Be Vietnam Pro" pitchFamily="34" charset="0"/>
+                <a:ea typeface="Be Vietnam Pro" pitchFamily="34" charset="-122"/>
+                <a:cs typeface="Be Vietnam Pro" pitchFamily="34" charset="-120"/>
+              </a:rPr>
+              <a:t> IP,</a:t>
             </a:r>
             <a:r>
               <a:rPr lang="en-US" sz="2100" dirty="0" spc="1" kern="0">
@@ -20360,29 +20393,7 @@
                 <a:ea typeface="Be Vietnam Pro" pitchFamily="34" charset="-122"/>
                 <a:cs typeface="Be Vietnam Pro" pitchFamily="34" charset="-120"/>
               </a:rPr>
-              <a:t> ngữ</a:t>
-            </a:r>
-            <a:r>
-              <a:rPr lang="en-US" sz="2100" dirty="0" spc="-7" kern="0">
-                <a:solidFill>
-                  <a:srgbClr val="F3EEE3"/>
-                </a:solidFill>
-                <a:latin typeface="Be Vietnam Pro" pitchFamily="34" charset="0"/>
-                <a:ea typeface="Be Vietnam Pro" pitchFamily="34" charset="-122"/>
-                <a:cs typeface="Be Vietnam Pro" pitchFamily="34" charset="-120"/>
-              </a:rPr>
-              <a:t> JavaScript,</a:t>
-            </a:r>
-            <a:r>
-              <a:rPr lang="en-US" sz="2100" dirty="0" spc="6" kern="0">
-                <a:solidFill>
-                  <a:srgbClr val="F3EEE3"/>
-                </a:solidFill>
-                <a:latin typeface="Be Vietnam Pro" pitchFamily="34" charset="0"/>
-                <a:ea typeface="Be Vietnam Pro" pitchFamily="34" charset="-122"/>
-                <a:cs typeface="Be Vietnam Pro" pitchFamily="34" charset="-120"/>
-              </a:rPr>
-              <a:t> đọc</a:t>
+              <a:t> HTTP,</a:t>
             </a:r>
             <a:r>
               <a:rPr lang="en-US" sz="2100" dirty="0" spc="0" kern="0">
@@ -20393,18 +20404,7 @@
                 <a:ea typeface="Be Vietnam Pro" pitchFamily="34" charset="-122"/>
                 <a:cs typeface="Be Vietnam Pro" pitchFamily="34" charset="-120"/>
               </a:rPr>
-              <a:t> từ</a:t>
-            </a:r>
-            <a:r>
-              <a:rPr lang="en-US" sz="2100" dirty="0" spc="-1" kern="0">
-                <a:solidFill>
-                  <a:srgbClr val="F3EEE3"/>
-                </a:solidFill>
-                <a:latin typeface="Be Vietnam Pro" pitchFamily="34" charset="0"/>
-                <a:ea typeface="Be Vietnam Pro" pitchFamily="34" charset="-122"/>
-                <a:cs typeface="Be Vietnam Pro" pitchFamily="34" charset="-120"/>
-              </a:rPr>
-              <a:t> kho</a:t>
+              <a:t> HTML,</a:t>
             </a:r>
             <a:r>
               <a:rPr lang="en-US" sz="2100" dirty="0" spc="-3" kern="0">
@@ -20415,7 +20415,29 @@
                 <a:ea typeface="Be Vietnam Pro" pitchFamily="34" charset="-122"/>
                 <a:cs typeface="Be Vietnam Pro" pitchFamily="34" charset="-120"/>
               </a:rPr>
-              <a:t> mã</a:t>
+              <a:t> CSS,</a:t>
+            </a:r>
+            <a:r>
+              <a:rPr lang="en-US" sz="2100" dirty="0" spc="4" kern="0">
+                <a:solidFill>
+                  <a:srgbClr val="F3EEE3"/>
+                </a:solidFill>
+                <a:latin typeface="Be Vietnam Pro" pitchFamily="34" charset="0"/>
+                <a:ea typeface="Be Vietnam Pro" pitchFamily="34" charset="-122"/>
+                <a:cs typeface="Be Vietnam Pro" pitchFamily="34" charset="-120"/>
+              </a:rPr>
+              <a:t> SQL,</a:t>
+            </a:r>
+            <a:r>
+              <a:rPr lang="en-US" sz="2100" dirty="0" spc="-3" kern="0">
+                <a:solidFill>
+                  <a:srgbClr val="F3EEE3"/>
+                </a:solidFill>
+                <a:latin typeface="Be Vietnam Pro" pitchFamily="34" charset="0"/>
+                <a:ea typeface="Be Vietnam Pro" pitchFamily="34" charset="-122"/>
+                <a:cs typeface="Be Vietnam Pro" pitchFamily="34" charset="-120"/>
+              </a:rPr>
+              <a:t> ECMAScript</a:t>
             </a:r>
             <a:endParaRPr lang="en-US" sz="2100" dirty="0"/>
           </a:p>
@@ -20498,10 +20520,10 @@
                 <a:ea typeface="Be Vietnam Pro" pitchFamily="34" charset="-122"/>
                 <a:cs typeface="Be Vietnam Pro" pitchFamily="34" charset="-120"/>
               </a:rPr>
-              <a:t> 2026-10-18.</a:t>
-            </a:r>
-            <a:r>
-              <a:rPr lang="en-US" sz="1950" dirty="0" spc="0" kern="0">
+              <a:t> 2026-10-19.</a:t>
+            </a:r>
+            <a:r>
+              <a:rPr lang="en-US" sz="1950" dirty="0" spc="9" kern="0">
                 <a:solidFill>
                   <a:srgbClr val="9AA0B5"/>
                 </a:solidFill>
@@ -20509,10 +20531,10 @@
                 <a:ea typeface="Be Vietnam Pro" pitchFamily="34" charset="-122"/>
                 <a:cs typeface="Be Vietnam Pro" pitchFamily="34" charset="-120"/>
               </a:rPr>
-              <a:t> Hình</a:t>
-            </a:r>
-            <a:r>
-              <a:rPr lang="en-US" sz="1950" dirty="0" spc="2" kern="0">
+              <a:t> ISO</a:t>
+            </a:r>
+            <a:r>
+              <a:rPr lang="en-US" sz="1950" dirty="0" spc="1" kern="0">
                 <a:solidFill>
                   <a:srgbClr val="9AA0B5"/>
                 </a:solidFill>
@@ -20520,10 +20542,10 @@
                 <a:ea typeface="Be Vietnam Pro" pitchFamily="34" charset="-122"/>
                 <a:cs typeface="Be Vietnam Pro" pitchFamily="34" charset="-120"/>
               </a:rPr>
-              <a:t> minh</a:t>
-            </a:r>
-            <a:r>
-              <a:rPr lang="en-US" sz="1950" dirty="0" spc="-3" kern="0">
+              <a:t> 8601</a:t>
+            </a:r>
+            <a:r>
+              <a:rPr lang="en-US" sz="1950" dirty="0" spc="4" kern="0">
                 <a:solidFill>
                   <a:srgbClr val="9AA0B5"/>
                 </a:solidFill>
@@ -20531,10 +20553,10 @@
                 <a:ea typeface="Be Vietnam Pro" pitchFamily="34" charset="-122"/>
                 <a:cs typeface="Be Vietnam Pro" pitchFamily="34" charset="-120"/>
               </a:rPr>
-              <a:t> họa</a:t>
-            </a:r>
-            <a:r>
-              <a:rPr lang="en-US" sz="1950" dirty="0" spc="-2" kern="0">
+              <a:t> chưa</a:t>
+            </a:r>
+            <a:r>
+              <a:rPr lang="en-US" sz="1950" dirty="0" spc="10" kern="0">
                 <a:solidFill>
                   <a:srgbClr val="9AA0B5"/>
                 </a:solidFill>
@@ -20542,10 +20564,10 @@
                 <a:ea typeface="Be Vietnam Pro" pitchFamily="34" charset="-122"/>
                 <a:cs typeface="Be Vietnam Pro" pitchFamily="34" charset="-120"/>
               </a:rPr>
-              <a:t> là</a:t>
-            </a:r>
-            <a:r>
-              <a:rPr lang="en-US" sz="1950" dirty="0" spc="-4" kern="0">
+              <a:t> đối</a:t>
+            </a:r>
+            <a:r>
+              <a:rPr lang="en-US" sz="1950" dirty="0" spc="-1" kern="0">
                 <a:solidFill>
                   <a:srgbClr val="9AA0B5"/>
                 </a:solidFill>
@@ -20553,29 +20575,7 @@
                 <a:ea typeface="Be Vietnam Pro" pitchFamily="34" charset="-122"/>
                 <a:cs typeface="Be Vietnam Pro" pitchFamily="34" charset="-120"/>
               </a:rPr>
-              <a:t> thiết</a:t>
-            </a:r>
-            <a:r>
-              <a:rPr lang="en-US" sz="1950" dirty="0" spc="-32" kern="0">
-                <a:solidFill>
-                  <a:srgbClr val="9AA0B5"/>
-                </a:solidFill>
-                <a:latin typeface="Be Vietnam Pro" pitchFamily="34" charset="0"/>
-                <a:ea typeface="Be Vietnam Pro" pitchFamily="34" charset="-122"/>
-                <a:cs typeface="Be Vietnam Pro" pitchFamily="34" charset="-120"/>
-              </a:rPr>
-              <a:t> kế</a:t>
-            </a:r>
-            <a:r>
-              <a:rPr lang="en-US" sz="1950" dirty="0" spc="-1" kern="0">
-                <a:solidFill>
-                  <a:srgbClr val="9AA0B5"/>
-                </a:solidFill>
-                <a:latin typeface="Be Vietnam Pro" pitchFamily="34" charset="0"/>
-                <a:ea typeface="Be Vietnam Pro" pitchFamily="34" charset="-122"/>
-                <a:cs typeface="Be Vietnam Pro" pitchFamily="34" charset="-120"/>
-              </a:rPr>
-              <a:t> mới.</a:t>
+              <a:t> chiếu.</a:t>
             </a:r>
             <a:endParaRPr lang="en-US" sz="1950" dirty="0"/>
           </a:p>

</xml_diff>